<commit_message>
feat(setup): apply slot names to real master + shapes≡slots validator (Phase 2)
Fix sidebar-callout layoutId collisions, emit layout-spec.json from the
approved naming table, mechanically rename 164 shapes in report.master.pptx,
and add a shapes≡slots validator wired into npm run validate.

Co-authored-by: Cursor <cursoragent@cursor.com>
</commit_message>
<xml_diff>
--- a/templates/report.master.pptx
+++ b/templates/report.master.pptx
@@ -5175,7 +5175,7 @@
       </p:cxnSp>
       <p:sp>
         <p:nvSpPr>
-          <p:cNvPr id="5" name="ZoneTexte 30">
+          <p:cNvPr id="5" name="slot.footer-copyright">
             <a:extLst>
               <a:ext uri="{FF2B5EF4-FFF2-40B4-BE49-F238E27FC236}">
                 <a16:creationId xmlns:a16="http://schemas.microsoft.com/office/drawing/2014/main" id="{A2FEA1FF-9F37-6219-3F4E-99D834B28FEB}"/>
@@ -5229,7 +5229,7 @@
       </p:sp>
       <p:sp>
         <p:nvSpPr>
-          <p:cNvPr id="8" name="ZoneTexte 7">
+          <p:cNvPr id="8" name="slot.footer-logo">
             <a:extLst>
               <a:ext uri="{FF2B5EF4-FFF2-40B4-BE49-F238E27FC236}">
                 <a16:creationId xmlns:a16="http://schemas.microsoft.com/office/drawing/2014/main" id="{E8981164-199B-BE71-F7D8-B1188DFC07F2}"/>
@@ -5881,7 +5881,7 @@
       </p:sp>
       <p:sp>
         <p:nvSpPr>
-          <p:cNvPr id="8" name="ZoneTexte 30">
+          <p:cNvPr id="8" name="slot.footer-copyright">
             <a:extLst>
               <a:ext uri="{FF2B5EF4-FFF2-40B4-BE49-F238E27FC236}">
                 <a16:creationId xmlns:a16="http://schemas.microsoft.com/office/drawing/2014/main" id="{E150FD5F-C13D-5321-DE4B-E1FDA4387569}"/>
@@ -5935,7 +5935,7 @@
       </p:sp>
       <p:sp>
         <p:nvSpPr>
-          <p:cNvPr id="12" name="ZoneTexte 11">
+          <p:cNvPr id="12" name="slot.footer-logo">
             <a:extLst>
               <a:ext uri="{FF2B5EF4-FFF2-40B4-BE49-F238E27FC236}">
                 <a16:creationId xmlns:a16="http://schemas.microsoft.com/office/drawing/2014/main" id="{8AF61725-8811-F4AA-3B06-802B815FDF5F}"/>
@@ -7250,7 +7250,7 @@
       </p:sp>
       <p:sp>
         <p:nvSpPr>
-          <p:cNvPr id="4" name="ZoneTexte 30">
+          <p:cNvPr id="4" name="slot.footer-copyright">
             <a:extLst>
               <a:ext uri="{FF2B5EF4-FFF2-40B4-BE49-F238E27FC236}">
                 <a16:creationId xmlns:a16="http://schemas.microsoft.com/office/drawing/2014/main" id="{C6A98321-E2FB-BA54-2C7C-C6FAE635B1A9}"/>
@@ -7304,7 +7304,7 @@
       </p:sp>
       <p:sp>
         <p:nvSpPr>
-          <p:cNvPr id="8" name="ZoneTexte 7">
+          <p:cNvPr id="8" name="slot.footer-logo">
             <a:extLst>
               <a:ext uri="{FF2B5EF4-FFF2-40B4-BE49-F238E27FC236}">
                 <a16:creationId xmlns:a16="http://schemas.microsoft.com/office/drawing/2014/main" id="{EF472C68-8BBB-B295-F133-C34823F6F4A8}"/>
@@ -8047,7 +8047,7 @@
       </p:cxnSp>
       <p:sp>
         <p:nvSpPr>
-          <p:cNvPr id="8" name="Espace réservé du numéro de diapositive 5">
+          <p:cNvPr id="8" name="slot.footer-page">
             <a:extLst>
               <a:ext uri="{FF2B5EF4-FFF2-40B4-BE49-F238E27FC236}">
                 <a16:creationId xmlns:a16="http://schemas.microsoft.com/office/drawing/2014/main" id="{510C2F0B-2799-67BD-FD30-3323FE6E8D3F}"/>
@@ -8081,7 +8081,7 @@
       </p:sp>
       <p:sp>
         <p:nvSpPr>
-          <p:cNvPr id="15" name="Espace réservé du contenu 6">
+          <p:cNvPr id="15" name="slot.source">
             <a:extLst>
               <a:ext uri="{FF2B5EF4-FFF2-40B4-BE49-F238E27FC236}">
                 <a16:creationId xmlns:a16="http://schemas.microsoft.com/office/drawing/2014/main" id="{BB6B3779-78D5-9210-1459-E20DFD83BF8E}"/>
@@ -8148,7 +8148,7 @@
       </p:sp>
       <p:sp>
         <p:nvSpPr>
-          <p:cNvPr id="7" name="ZoneTexte 30">
+          <p:cNvPr id="7" name="slot.footer-copyright">
             <a:extLst>
               <a:ext uri="{FF2B5EF4-FFF2-40B4-BE49-F238E27FC236}">
                 <a16:creationId xmlns:a16="http://schemas.microsoft.com/office/drawing/2014/main" id="{9A6DF3F5-8564-E129-6554-B6EDA6853068}"/>
@@ -8202,7 +8202,7 @@
       </p:sp>
       <p:sp>
         <p:nvSpPr>
-          <p:cNvPr id="9" name="ZoneTexte 8">
+          <p:cNvPr id="9" name="slot.footer-logo">
             <a:extLst>
               <a:ext uri="{FF2B5EF4-FFF2-40B4-BE49-F238E27FC236}">
                 <a16:creationId xmlns:a16="http://schemas.microsoft.com/office/drawing/2014/main" id="{06395C06-3B11-8812-966B-5A6B6AA95084}"/>
@@ -8945,7 +8945,7 @@
       </p:cxnSp>
       <p:sp>
         <p:nvSpPr>
-          <p:cNvPr id="11" name="Espace réservé du numéro de diapositive 5">
+          <p:cNvPr id="11" name="slot.footer-page">
             <a:extLst>
               <a:ext uri="{FF2B5EF4-FFF2-40B4-BE49-F238E27FC236}">
                 <a16:creationId xmlns:a16="http://schemas.microsoft.com/office/drawing/2014/main" id="{B083480F-4AEB-CC56-9E28-75B8E7A55047}"/>
@@ -8979,7 +8979,7 @@
       </p:sp>
       <p:sp>
         <p:nvSpPr>
-          <p:cNvPr id="19" name="Espace réservé du contenu 6">
+          <p:cNvPr id="19" name="slot.source">
             <a:extLst>
               <a:ext uri="{FF2B5EF4-FFF2-40B4-BE49-F238E27FC236}">
                 <a16:creationId xmlns:a16="http://schemas.microsoft.com/office/drawing/2014/main" id="{47DD7148-9127-86A3-6944-6DF6931A959F}"/>
@@ -9046,7 +9046,7 @@
       </p:sp>
       <p:sp>
         <p:nvSpPr>
-          <p:cNvPr id="7" name="ZoneTexte 30">
+          <p:cNvPr id="7" name="slot.footer-copyright">
             <a:extLst>
               <a:ext uri="{FF2B5EF4-FFF2-40B4-BE49-F238E27FC236}">
                 <a16:creationId xmlns:a16="http://schemas.microsoft.com/office/drawing/2014/main" id="{69C38BEF-2317-F24E-C3B1-1AA0A6810398}"/>
@@ -9100,7 +9100,7 @@
       </p:sp>
       <p:sp>
         <p:nvSpPr>
-          <p:cNvPr id="8" name="ZoneTexte 7">
+          <p:cNvPr id="8" name="slot.footer-logo">
             <a:extLst>
               <a:ext uri="{FF2B5EF4-FFF2-40B4-BE49-F238E27FC236}">
                 <a16:creationId xmlns:a16="http://schemas.microsoft.com/office/drawing/2014/main" id="{A2FB2DD0-93CC-F92C-4E8C-5BA3458E25C3}"/>
@@ -9450,7 +9450,7 @@
       </p:sp>
       <p:sp>
         <p:nvSpPr>
-          <p:cNvPr id="5" name="Espace réservé du texte 4">
+          <p:cNvPr id="5" name="slot.subtitle-2">
             <a:extLst>
               <a:ext uri="{FF2B5EF4-FFF2-40B4-BE49-F238E27FC236}">
                 <a16:creationId xmlns:a16="http://schemas.microsoft.com/office/drawing/2014/main" id="{2D35804D-7044-B129-7E2C-ED3868BD4F80}"/>
@@ -9541,7 +9541,7 @@
       </p:sp>
       <p:sp>
         <p:nvSpPr>
-          <p:cNvPr id="6" name="Espace réservé du contenu 5">
+          <p:cNvPr id="6" name="slot.body">
             <a:extLst>
               <a:ext uri="{FF2B5EF4-FFF2-40B4-BE49-F238E27FC236}">
                 <a16:creationId xmlns:a16="http://schemas.microsoft.com/office/drawing/2014/main" id="{C56BF488-D9DF-64BA-30D9-77D4A3CB1561}"/>
@@ -9871,7 +9871,7 @@
       </p:sp>
       <p:sp>
         <p:nvSpPr>
-          <p:cNvPr id="4" name="ZoneTexte 30">
+          <p:cNvPr id="4" name="slot.footer-copyright">
             <a:extLst>
               <a:ext uri="{FF2B5EF4-FFF2-40B4-BE49-F238E27FC236}">
                 <a16:creationId xmlns:a16="http://schemas.microsoft.com/office/drawing/2014/main" id="{B9EA91B6-6CF2-5B80-F0AE-B0ED5165D982}"/>
@@ -9925,7 +9925,7 @@
       </p:sp>
       <p:sp>
         <p:nvSpPr>
-          <p:cNvPr id="7" name="ZoneTexte 6">
+          <p:cNvPr id="7" name="slot.footer-logo">
             <a:extLst>
               <a:ext uri="{FF2B5EF4-FFF2-40B4-BE49-F238E27FC236}">
                 <a16:creationId xmlns:a16="http://schemas.microsoft.com/office/drawing/2014/main" id="{4C9F5E73-E5D7-0B11-9227-681DA930D820}"/>
@@ -10280,7 +10280,7 @@
       </p:sp>
       <p:sp>
         <p:nvSpPr>
-          <p:cNvPr id="5" name="Espace réservé du texte 4">
+          <p:cNvPr id="5" name="slot.subtitle-2">
             <a:extLst>
               <a:ext uri="{FF2B5EF4-FFF2-40B4-BE49-F238E27FC236}">
                 <a16:creationId xmlns:a16="http://schemas.microsoft.com/office/drawing/2014/main" id="{2D35804D-7044-B129-7E2C-ED3868BD4F80}"/>
@@ -10371,7 +10371,7 @@
       </p:sp>
       <p:sp>
         <p:nvSpPr>
-          <p:cNvPr id="6" name="Espace réservé du contenu 5">
+          <p:cNvPr id="6" name="slot.body">
             <a:extLst>
               <a:ext uri="{FF2B5EF4-FFF2-40B4-BE49-F238E27FC236}">
                 <a16:creationId xmlns:a16="http://schemas.microsoft.com/office/drawing/2014/main" id="{C56BF488-D9DF-64BA-30D9-77D4A3CB1561}"/>
@@ -10738,7 +10738,7 @@
       </p:sp>
       <p:sp>
         <p:nvSpPr>
-          <p:cNvPr id="7" name="ZoneTexte 30">
+          <p:cNvPr id="7" name="slot.footer-copyright">
             <a:extLst>
               <a:ext uri="{FF2B5EF4-FFF2-40B4-BE49-F238E27FC236}">
                 <a16:creationId xmlns:a16="http://schemas.microsoft.com/office/drawing/2014/main" id="{1BF41F40-595B-48CD-E781-95878742749D}"/>
@@ -10792,7 +10792,7 @@
       </p:sp>
       <p:sp>
         <p:nvSpPr>
-          <p:cNvPr id="9" name="ZoneTexte 8">
+          <p:cNvPr id="9" name="slot.footer-logo">
             <a:extLst>
               <a:ext uri="{FF2B5EF4-FFF2-40B4-BE49-F238E27FC236}">
                 <a16:creationId xmlns:a16="http://schemas.microsoft.com/office/drawing/2014/main" id="{EEBE6346-AC0F-95D1-CFD8-CB8054A615A5}"/>
@@ -11602,7 +11602,7 @@
       </p:cxnSp>
       <p:sp>
         <p:nvSpPr>
-          <p:cNvPr id="11" name="Espace réservé du numéro de diapositive 5">
+          <p:cNvPr id="11" name="slot.footer-page">
             <a:extLst>
               <a:ext uri="{FF2B5EF4-FFF2-40B4-BE49-F238E27FC236}">
                 <a16:creationId xmlns:a16="http://schemas.microsoft.com/office/drawing/2014/main" id="{EF3FC79F-B88C-8E01-0898-E0B4EFE85FEE}"/>
@@ -11645,7 +11645,7 @@
       </p:sp>
       <p:sp>
         <p:nvSpPr>
-          <p:cNvPr id="22" name="Espace réservé du contenu 6">
+          <p:cNvPr id="22" name="slot.source">
             <a:extLst>
               <a:ext uri="{FF2B5EF4-FFF2-40B4-BE49-F238E27FC236}">
                 <a16:creationId xmlns:a16="http://schemas.microsoft.com/office/drawing/2014/main" id="{BD45DD6B-1B35-99CF-127B-561BE4952E16}"/>
@@ -11712,7 +11712,7 @@
       </p:sp>
       <p:sp>
         <p:nvSpPr>
-          <p:cNvPr id="9" name="ZoneTexte 30">
+          <p:cNvPr id="9" name="slot.footer-copyright">
             <a:extLst>
               <a:ext uri="{FF2B5EF4-FFF2-40B4-BE49-F238E27FC236}">
                 <a16:creationId xmlns:a16="http://schemas.microsoft.com/office/drawing/2014/main" id="{E76FB809-1B2B-CCF6-24BB-429FDD2D7B24}"/>
@@ -11766,7 +11766,7 @@
       </p:sp>
       <p:sp>
         <p:nvSpPr>
-          <p:cNvPr id="14" name="ZoneTexte 13">
+          <p:cNvPr id="14" name="slot.footer-logo">
             <a:extLst>
               <a:ext uri="{FF2B5EF4-FFF2-40B4-BE49-F238E27FC236}">
                 <a16:creationId xmlns:a16="http://schemas.microsoft.com/office/drawing/2014/main" id="{003096E9-3812-E7EE-F73E-A45B1A3882EE}"/>
@@ -12577,7 +12577,7 @@
       </p:cxnSp>
       <p:sp>
         <p:nvSpPr>
-          <p:cNvPr id="8" name="Espace réservé du numéro de diapositive 5">
+          <p:cNvPr id="8" name="slot.footer-page">
             <a:extLst>
               <a:ext uri="{FF2B5EF4-FFF2-40B4-BE49-F238E27FC236}">
                 <a16:creationId xmlns:a16="http://schemas.microsoft.com/office/drawing/2014/main" id="{CF0FD329-A27E-51A3-480F-9C04DED50C30}"/>
@@ -12620,7 +12620,7 @@
       </p:sp>
       <p:sp>
         <p:nvSpPr>
-          <p:cNvPr id="20" name="Espace réservé du contenu 6">
+          <p:cNvPr id="20" name="slot.source">
             <a:extLst>
               <a:ext uri="{FF2B5EF4-FFF2-40B4-BE49-F238E27FC236}">
                 <a16:creationId xmlns:a16="http://schemas.microsoft.com/office/drawing/2014/main" id="{19D01319-1A5E-43BA-3540-3F52885879BC}"/>
@@ -12687,7 +12687,7 @@
       </p:sp>
       <p:sp>
         <p:nvSpPr>
-          <p:cNvPr id="9" name="ZoneTexte 30">
+          <p:cNvPr id="9" name="slot.footer-copyright">
             <a:extLst>
               <a:ext uri="{FF2B5EF4-FFF2-40B4-BE49-F238E27FC236}">
                 <a16:creationId xmlns:a16="http://schemas.microsoft.com/office/drawing/2014/main" id="{39D24033-DF4D-0ED7-1A57-92CACF576185}"/>
@@ -12741,7 +12741,7 @@
       </p:sp>
       <p:sp>
         <p:nvSpPr>
-          <p:cNvPr id="12" name="ZoneTexte 11">
+          <p:cNvPr id="12" name="slot.footer-logo">
             <a:extLst>
               <a:ext uri="{FF2B5EF4-FFF2-40B4-BE49-F238E27FC236}">
                 <a16:creationId xmlns:a16="http://schemas.microsoft.com/office/drawing/2014/main" id="{378E3F20-EC2E-870A-570B-4022DDD01109}"/>
@@ -13094,7 +13094,7 @@
       </p:sp>
       <p:sp>
         <p:nvSpPr>
-          <p:cNvPr id="4" name="ZoneTexte 30">
+          <p:cNvPr id="4" name="slot.footer-copyright">
             <a:extLst>
               <a:ext uri="{FF2B5EF4-FFF2-40B4-BE49-F238E27FC236}">
                 <a16:creationId xmlns:a16="http://schemas.microsoft.com/office/drawing/2014/main" id="{6F36171D-B542-2086-9241-E71F1886F35F}"/>
@@ -13148,7 +13148,7 @@
       </p:sp>
       <p:sp>
         <p:nvSpPr>
-          <p:cNvPr id="5" name="ZoneTexte 4">
+          <p:cNvPr id="5" name="slot.footer-logo">
             <a:extLst>
               <a:ext uri="{FF2B5EF4-FFF2-40B4-BE49-F238E27FC236}">
                 <a16:creationId xmlns:a16="http://schemas.microsoft.com/office/drawing/2014/main" id="{D41DD35C-CF64-510B-4D2D-9A5073A838A6}"/>
@@ -13515,7 +13515,7 @@
       </p:sp>
       <p:sp>
         <p:nvSpPr>
-          <p:cNvPr id="5" name="Espace réservé du texte 4">
+          <p:cNvPr id="5" name="slot.subtitle-2">
             <a:extLst>
               <a:ext uri="{FF2B5EF4-FFF2-40B4-BE49-F238E27FC236}">
                 <a16:creationId xmlns:a16="http://schemas.microsoft.com/office/drawing/2014/main" id="{2D35804D-7044-B129-7E2C-ED3868BD4F80}"/>
@@ -13606,7 +13606,7 @@
       </p:sp>
       <p:sp>
         <p:nvSpPr>
-          <p:cNvPr id="6" name="Espace réservé du contenu 5">
+          <p:cNvPr id="6" name="slot.body">
             <a:extLst>
               <a:ext uri="{FF2B5EF4-FFF2-40B4-BE49-F238E27FC236}">
                 <a16:creationId xmlns:a16="http://schemas.microsoft.com/office/drawing/2014/main" id="{C56BF488-D9DF-64BA-30D9-77D4A3CB1561}"/>
@@ -13872,7 +13872,7 @@
       </p:sp>
       <p:sp>
         <p:nvSpPr>
-          <p:cNvPr id="4" name="ZoneTexte 30">
+          <p:cNvPr id="4" name="slot.footer-copyright">
             <a:extLst>
               <a:ext uri="{FF2B5EF4-FFF2-40B4-BE49-F238E27FC236}">
                 <a16:creationId xmlns:a16="http://schemas.microsoft.com/office/drawing/2014/main" id="{15305BAF-50BD-584B-DC74-C009508EB3DC}"/>
@@ -13926,7 +13926,7 @@
       </p:sp>
       <p:sp>
         <p:nvSpPr>
-          <p:cNvPr id="9" name="ZoneTexte 8">
+          <p:cNvPr id="9" name="slot.footer-logo">
             <a:extLst>
               <a:ext uri="{FF2B5EF4-FFF2-40B4-BE49-F238E27FC236}">
                 <a16:creationId xmlns:a16="http://schemas.microsoft.com/office/drawing/2014/main" id="{746F6E4E-77DF-D5C8-6FC4-15CBB7325373}"/>
@@ -14291,7 +14291,7 @@
       </p:sp>
       <p:sp>
         <p:nvSpPr>
-          <p:cNvPr id="20" name="Espace réservé du texte 4">
+          <p:cNvPr id="20" name="slot.subtitle-2">
             <a:extLst>
               <a:ext uri="{FF2B5EF4-FFF2-40B4-BE49-F238E27FC236}">
                 <a16:creationId xmlns:a16="http://schemas.microsoft.com/office/drawing/2014/main" id="{310C5BB4-05F5-13FD-06D5-F7F90D3D7573}"/>
@@ -14382,7 +14382,7 @@
       </p:sp>
       <p:sp>
         <p:nvSpPr>
-          <p:cNvPr id="23" name="Espace réservé du contenu 5">
+          <p:cNvPr id="23" name="slot.body">
             <a:extLst>
               <a:ext uri="{FF2B5EF4-FFF2-40B4-BE49-F238E27FC236}">
                 <a16:creationId xmlns:a16="http://schemas.microsoft.com/office/drawing/2014/main" id="{75B3DDDB-0FFF-0BA0-DC0E-79048AFFC69C}"/>
@@ -14767,7 +14767,7 @@
       </p:sp>
       <p:sp>
         <p:nvSpPr>
-          <p:cNvPr id="4" name="ZoneTexte 30">
+          <p:cNvPr id="4" name="slot.footer-copyright">
             <a:extLst>
               <a:ext uri="{FF2B5EF4-FFF2-40B4-BE49-F238E27FC236}">
                 <a16:creationId xmlns:a16="http://schemas.microsoft.com/office/drawing/2014/main" id="{2DDB37EA-A3C9-8886-2554-B4F3286733E9}"/>
@@ -14821,7 +14821,7 @@
       </p:sp>
       <p:sp>
         <p:nvSpPr>
-          <p:cNvPr id="5" name="ZoneTexte 4">
+          <p:cNvPr id="5" name="slot.footer-logo">
             <a:extLst>
               <a:ext uri="{FF2B5EF4-FFF2-40B4-BE49-F238E27FC236}">
                 <a16:creationId xmlns:a16="http://schemas.microsoft.com/office/drawing/2014/main" id="{4171C2A4-A825-1321-2CCC-00A293AF826E}"/>
@@ -15467,7 +15467,7 @@
       </p:sp>
       <p:sp>
         <p:nvSpPr>
-          <p:cNvPr id="5" name="ZoneTexte 30">
+          <p:cNvPr id="5" name="slot.footer-copyright">
             <a:extLst>
               <a:ext uri="{FF2B5EF4-FFF2-40B4-BE49-F238E27FC236}">
                 <a16:creationId xmlns:a16="http://schemas.microsoft.com/office/drawing/2014/main" id="{E99671A2-29BC-C486-4FDD-535AB808C56F}"/>
@@ -15521,7 +15521,7 @@
       </p:sp>
       <p:sp>
         <p:nvSpPr>
-          <p:cNvPr id="6" name="ZoneTexte 5">
+          <p:cNvPr id="6" name="slot.footer-logo">
             <a:extLst>
               <a:ext uri="{FF2B5EF4-FFF2-40B4-BE49-F238E27FC236}">
                 <a16:creationId xmlns:a16="http://schemas.microsoft.com/office/drawing/2014/main" id="{1F03ADAA-DE4B-1668-3DA4-78AC64CFC6AC}"/>
@@ -16079,7 +16079,7 @@
       </p:sp>
       <p:sp>
         <p:nvSpPr>
-          <p:cNvPr id="6" name="ZoneTexte 30">
+          <p:cNvPr id="6" name="slot.footer-copyright">
             <a:extLst>
               <a:ext uri="{FF2B5EF4-FFF2-40B4-BE49-F238E27FC236}">
                 <a16:creationId xmlns:a16="http://schemas.microsoft.com/office/drawing/2014/main" id="{4DF8E504-CA60-F860-96A9-F4BC5E46CA41}"/>
@@ -16133,7 +16133,7 @@
       </p:sp>
       <p:sp>
         <p:nvSpPr>
-          <p:cNvPr id="7" name="ZoneTexte 6">
+          <p:cNvPr id="7" name="slot.footer-logo">
             <a:extLst>
               <a:ext uri="{FF2B5EF4-FFF2-40B4-BE49-F238E27FC236}">
                 <a16:creationId xmlns:a16="http://schemas.microsoft.com/office/drawing/2014/main" id="{BB9E44C8-0E14-E627-B39C-3CC292226220}"/>
@@ -16715,7 +16715,7 @@
       </p:cxnSp>
       <p:sp>
         <p:nvSpPr>
-          <p:cNvPr id="12" name="Espace réservé du numéro de diapositive 5">
+          <p:cNvPr id="12" name="slot.footer-page">
             <a:extLst>
               <a:ext uri="{FF2B5EF4-FFF2-40B4-BE49-F238E27FC236}">
                 <a16:creationId xmlns:a16="http://schemas.microsoft.com/office/drawing/2014/main" id="{B1FB7D05-838F-532B-0B3B-5466C302AAE2}"/>
@@ -16749,7 +16749,7 @@
       </p:sp>
       <p:sp>
         <p:nvSpPr>
-          <p:cNvPr id="18" name="Espace réservé du contenu 6">
+          <p:cNvPr id="18" name="slot.source">
             <a:extLst>
               <a:ext uri="{FF2B5EF4-FFF2-40B4-BE49-F238E27FC236}">
                 <a16:creationId xmlns:a16="http://schemas.microsoft.com/office/drawing/2014/main" id="{DD6D06F4-9510-38A2-079C-836FA0E25990}"/>
@@ -16816,7 +16816,7 @@
       </p:sp>
       <p:sp>
         <p:nvSpPr>
-          <p:cNvPr id="8" name="ZoneTexte 30">
+          <p:cNvPr id="8" name="slot.footer-copyright">
             <a:extLst>
               <a:ext uri="{FF2B5EF4-FFF2-40B4-BE49-F238E27FC236}">
                 <a16:creationId xmlns:a16="http://schemas.microsoft.com/office/drawing/2014/main" id="{3047539A-0BFC-5BB9-0072-5DE19483ABBF}"/>
@@ -16870,7 +16870,7 @@
       </p:sp>
       <p:sp>
         <p:nvSpPr>
-          <p:cNvPr id="9" name="ZoneTexte 8">
+          <p:cNvPr id="9" name="slot.footer-logo">
             <a:extLst>
               <a:ext uri="{FF2B5EF4-FFF2-40B4-BE49-F238E27FC236}">
                 <a16:creationId xmlns:a16="http://schemas.microsoft.com/office/drawing/2014/main" id="{247E3550-5CD6-33B5-5444-8A45D9F8FAC0}"/>
@@ -17653,7 +17653,7 @@
       </p:cxnSp>
       <p:sp>
         <p:nvSpPr>
-          <p:cNvPr id="16" name="Espace réservé du numéro de diapositive 5">
+          <p:cNvPr id="16" name="slot.footer-page">
             <a:extLst>
               <a:ext uri="{FF2B5EF4-FFF2-40B4-BE49-F238E27FC236}">
                 <a16:creationId xmlns:a16="http://schemas.microsoft.com/office/drawing/2014/main" id="{9591EC4D-D015-BB3F-B075-780ADAD4923D}"/>
@@ -17687,7 +17687,7 @@
       </p:sp>
       <p:sp>
         <p:nvSpPr>
-          <p:cNvPr id="23" name="Espace réservé du contenu 6">
+          <p:cNvPr id="23" name="slot.source">
             <a:extLst>
               <a:ext uri="{FF2B5EF4-FFF2-40B4-BE49-F238E27FC236}">
                 <a16:creationId xmlns:a16="http://schemas.microsoft.com/office/drawing/2014/main" id="{57B7AFE9-1481-AAAB-096A-34F44FCF4189}"/>
@@ -17754,7 +17754,7 @@
       </p:sp>
       <p:sp>
         <p:nvSpPr>
-          <p:cNvPr id="8" name="ZoneTexte 30">
+          <p:cNvPr id="8" name="slot.footer-copyright">
             <a:extLst>
               <a:ext uri="{FF2B5EF4-FFF2-40B4-BE49-F238E27FC236}">
                 <a16:creationId xmlns:a16="http://schemas.microsoft.com/office/drawing/2014/main" id="{AE48B899-D254-33FF-13F7-FB3591FAB6B1}"/>
@@ -17808,7 +17808,7 @@
       </p:sp>
       <p:sp>
         <p:nvSpPr>
-          <p:cNvPr id="9" name="ZoneTexte 8">
+          <p:cNvPr id="9" name="slot.footer-logo">
             <a:extLst>
               <a:ext uri="{FF2B5EF4-FFF2-40B4-BE49-F238E27FC236}">
                 <a16:creationId xmlns:a16="http://schemas.microsoft.com/office/drawing/2014/main" id="{5079D28D-C0D1-A414-D61D-CDD866EB1576}"/>
@@ -19902,7 +19902,7 @@
       </p:grpSpPr>
       <p:sp>
         <p:nvSpPr>
-          <p:cNvPr id="2" name="Espace réservé pour une image  1">
+          <p:cNvPr id="2" name="slot.image">
             <a:extLst>
               <a:ext uri="{FF2B5EF4-FFF2-40B4-BE49-F238E27FC236}">
                 <a16:creationId xmlns:a16="http://schemas.microsoft.com/office/drawing/2014/main" id="{E0BCE59B-D444-7A18-DCCB-70AFE1EA42FF}"/>
@@ -19927,7 +19927,7 @@
       </p:sp>
       <p:sp>
         <p:nvSpPr>
-          <p:cNvPr id="3" name="Titre 2">
+          <p:cNvPr id="3" name="slot.title">
             <a:extLst>
               <a:ext uri="{FF2B5EF4-FFF2-40B4-BE49-F238E27FC236}">
                 <a16:creationId xmlns:a16="http://schemas.microsoft.com/office/drawing/2014/main" id="{7ACAD432-3BA2-C857-1F08-57EFA4F2680E}"/>
@@ -19952,7 +19952,7 @@
       </p:sp>
       <p:sp>
         <p:nvSpPr>
-          <p:cNvPr id="4" name="Sous-titre 3">
+          <p:cNvPr id="4" name="slot.subtitle">
             <a:extLst>
               <a:ext uri="{FF2B5EF4-FFF2-40B4-BE49-F238E27FC236}">
                 <a16:creationId xmlns:a16="http://schemas.microsoft.com/office/drawing/2014/main" id="{A7B49F1B-6722-9095-525C-4E4E2657BDB4}"/>
@@ -19977,7 +19977,7 @@
       </p:sp>
       <p:sp>
         <p:nvSpPr>
-          <p:cNvPr id="5" name="Espace réservé du texte 4">
+          <p:cNvPr id="5" name="slot.body">
             <a:extLst>
               <a:ext uri="{FF2B5EF4-FFF2-40B4-BE49-F238E27FC236}">
                 <a16:creationId xmlns:a16="http://schemas.microsoft.com/office/drawing/2014/main" id="{4CBFC38C-423B-3DD8-A88D-A1A1A9C3A913}"/>
@@ -20038,7 +20038,7 @@
       </p:grpSpPr>
       <p:sp>
         <p:nvSpPr>
-          <p:cNvPr id="11" name="Titre 10">
+          <p:cNvPr id="11" name="slot.title">
             <a:extLst>
               <a:ext uri="{FF2B5EF4-FFF2-40B4-BE49-F238E27FC236}">
                 <a16:creationId xmlns:a16="http://schemas.microsoft.com/office/drawing/2014/main" id="{5B9B5EFF-D6C0-5F6D-B181-93D9A1EEA543}"/>
@@ -20063,7 +20063,7 @@
       </p:sp>
       <p:graphicFrame>
         <p:nvGraphicFramePr>
-          <p:cNvPr id="2" name="Espace réservé du contenu 1">
+          <p:cNvPr id="2" name="slot.chart">
             <a:extLst>
               <a:ext uri="{FF2B5EF4-FFF2-40B4-BE49-F238E27FC236}">
                 <a16:creationId xmlns:a16="http://schemas.microsoft.com/office/drawing/2014/main" id="{6856BEA8-6434-0F26-881F-058CB793B77E}"/>
@@ -20094,7 +20094,7 @@
       </p:graphicFrame>
       <p:sp>
         <p:nvSpPr>
-          <p:cNvPr id="4" name="Espace réservé du numéro de diapositive 3">
+          <p:cNvPr id="4" name="slot.footer-page">
             <a:extLst>
               <a:ext uri="{FF2B5EF4-FFF2-40B4-BE49-F238E27FC236}">
                 <a16:creationId xmlns:a16="http://schemas.microsoft.com/office/drawing/2014/main" id="{A97A835A-87A2-B939-1DD1-F196BE144C01}"/>
@@ -20123,7 +20123,7 @@
       </p:sp>
       <p:sp>
         <p:nvSpPr>
-          <p:cNvPr id="12" name="Espace réservé du contenu 11">
+          <p:cNvPr id="12" name="slot.source">
             <a:extLst>
               <a:ext uri="{FF2B5EF4-FFF2-40B4-BE49-F238E27FC236}">
                 <a16:creationId xmlns:a16="http://schemas.microsoft.com/office/drawing/2014/main" id="{BBB8D210-4F84-AB0E-C916-9C28A9514921}"/>
@@ -20148,7 +20148,7 @@
       </p:sp>
       <p:sp>
         <p:nvSpPr>
-          <p:cNvPr id="10" name="Espace réservé du contenu 5">
+          <p:cNvPr id="10" name="slot.body-right">
             <a:extLst>
               <a:ext uri="{FF2B5EF4-FFF2-40B4-BE49-F238E27FC236}">
                 <a16:creationId xmlns:a16="http://schemas.microsoft.com/office/drawing/2014/main" id="{12965206-88B4-0F47-8E28-3FA959B2EF16}"/>
@@ -20387,7 +20387,7 @@
       </p:sp>
       <p:sp>
         <p:nvSpPr>
-          <p:cNvPr id="13" name="Espace réservé du contenu 5">
+          <p:cNvPr id="13" name="slot.chart-title">
             <a:extLst>
               <a:ext uri="{FF2B5EF4-FFF2-40B4-BE49-F238E27FC236}">
                 <a16:creationId xmlns:a16="http://schemas.microsoft.com/office/drawing/2014/main" id="{4B04BF95-50FB-9DF2-7E0A-AC1BBEDAB16D}"/>
@@ -20675,7 +20675,7 @@
       </p:grpSpPr>
       <p:sp>
         <p:nvSpPr>
-          <p:cNvPr id="6" name="Titre 5">
+          <p:cNvPr id="6" name="slot.title">
             <a:extLst>
               <a:ext uri="{FF2B5EF4-FFF2-40B4-BE49-F238E27FC236}">
                 <a16:creationId xmlns:a16="http://schemas.microsoft.com/office/drawing/2014/main" id="{BBC5BA43-0109-A451-0B17-1344EBBD7B3B}"/>
@@ -20700,7 +20700,7 @@
       </p:sp>
       <p:sp>
         <p:nvSpPr>
-          <p:cNvPr id="7" name="Espace réservé du contenu 6">
+          <p:cNvPr id="7" name="slot.body-left">
             <a:extLst>
               <a:ext uri="{FF2B5EF4-FFF2-40B4-BE49-F238E27FC236}">
                 <a16:creationId xmlns:a16="http://schemas.microsoft.com/office/drawing/2014/main" id="{F9A39B9F-8FE3-C5E4-66EB-23D6B854B01A}"/>
@@ -20725,7 +20725,7 @@
       </p:sp>
       <p:sp>
         <p:nvSpPr>
-          <p:cNvPr id="8" name="Espace réservé du contenu 7">
+          <p:cNvPr id="8" name="slot.body-left">
             <a:extLst>
               <a:ext uri="{FF2B5EF4-FFF2-40B4-BE49-F238E27FC236}">
                 <a16:creationId xmlns:a16="http://schemas.microsoft.com/office/drawing/2014/main" id="{37886110-4BF1-3B19-47FC-1B3A623E68F4}"/>
@@ -20750,7 +20750,7 @@
       </p:sp>
       <p:sp>
         <p:nvSpPr>
-          <p:cNvPr id="4" name="Espace réservé du numéro de diapositive 3">
+          <p:cNvPr id="4" name="slot.footer-page">
             <a:extLst>
               <a:ext uri="{FF2B5EF4-FFF2-40B4-BE49-F238E27FC236}">
                 <a16:creationId xmlns:a16="http://schemas.microsoft.com/office/drawing/2014/main" id="{955021DA-9147-47DF-2270-FA79520AA834}"/>
@@ -20779,7 +20779,7 @@
       </p:sp>
       <p:sp>
         <p:nvSpPr>
-          <p:cNvPr id="9" name="Espace réservé du contenu 8">
+          <p:cNvPr id="9" name="slot.source">
             <a:extLst>
               <a:ext uri="{FF2B5EF4-FFF2-40B4-BE49-F238E27FC236}">
                 <a16:creationId xmlns:a16="http://schemas.microsoft.com/office/drawing/2014/main" id="{08669132-B2E9-C7FD-0E5A-195E1E90B39F}"/>
@@ -20834,7 +20834,7 @@
       </p:grpSpPr>
       <p:sp>
         <p:nvSpPr>
-          <p:cNvPr id="2" name="Titre 1">
+          <p:cNvPr id="2" name="slot.title">
             <a:extLst>
               <a:ext uri="{FF2B5EF4-FFF2-40B4-BE49-F238E27FC236}">
                 <a16:creationId xmlns:a16="http://schemas.microsoft.com/office/drawing/2014/main" id="{A1B13B95-550F-B65B-3507-ADE3B9DA9E32}"/>
@@ -20859,7 +20859,7 @@
       </p:sp>
       <p:sp>
         <p:nvSpPr>
-          <p:cNvPr id="3" name="Espace réservé du texte 2">
+          <p:cNvPr id="3" name="slot.subtitle-left">
             <a:extLst>
               <a:ext uri="{FF2B5EF4-FFF2-40B4-BE49-F238E27FC236}">
                 <a16:creationId xmlns:a16="http://schemas.microsoft.com/office/drawing/2014/main" id="{472AF4BA-3A94-A6AA-75ED-51F19EF10D87}"/>
@@ -20884,7 +20884,7 @@
       </p:sp>
       <p:sp>
         <p:nvSpPr>
-          <p:cNvPr id="4" name="Espace réservé du contenu 3">
+          <p:cNvPr id="4" name="slot.body-left">
             <a:extLst>
               <a:ext uri="{FF2B5EF4-FFF2-40B4-BE49-F238E27FC236}">
                 <a16:creationId xmlns:a16="http://schemas.microsoft.com/office/drawing/2014/main" id="{B0ABFD61-CD4F-EC1A-5115-45CDDC420BF3}"/>
@@ -20909,7 +20909,7 @@
       </p:sp>
       <p:sp>
         <p:nvSpPr>
-          <p:cNvPr id="5" name="Espace réservé du texte 4">
+          <p:cNvPr id="5" name="slot.subtitle-right">
             <a:extLst>
               <a:ext uri="{FF2B5EF4-FFF2-40B4-BE49-F238E27FC236}">
                 <a16:creationId xmlns:a16="http://schemas.microsoft.com/office/drawing/2014/main" id="{DE696CA1-6E07-520A-1327-ED245650AA9E}"/>
@@ -20934,7 +20934,7 @@
       </p:sp>
       <p:sp>
         <p:nvSpPr>
-          <p:cNvPr id="6" name="Espace réservé du contenu 5">
+          <p:cNvPr id="6" name="slot.body-right">
             <a:extLst>
               <a:ext uri="{FF2B5EF4-FFF2-40B4-BE49-F238E27FC236}">
                 <a16:creationId xmlns:a16="http://schemas.microsoft.com/office/drawing/2014/main" id="{8C3FD960-175C-64AD-76A4-03C56B091E11}"/>
@@ -21043,7 +21043,7 @@
       </p:grpSpPr>
       <p:sp>
         <p:nvSpPr>
-          <p:cNvPr id="2" name="Titre 1">
+          <p:cNvPr id="2" name="slot.title">
             <a:extLst>
               <a:ext uri="{FF2B5EF4-FFF2-40B4-BE49-F238E27FC236}">
                 <a16:creationId xmlns:a16="http://schemas.microsoft.com/office/drawing/2014/main" id="{96382BF3-A58D-9FCC-73D2-D23B8E3097D6}"/>
@@ -21068,7 +21068,7 @@
       </p:sp>
       <p:sp>
         <p:nvSpPr>
-          <p:cNvPr id="3" name="Espace réservé du texte 2">
+          <p:cNvPr id="3" name="slot.subtitle-left">
             <a:extLst>
               <a:ext uri="{FF2B5EF4-FFF2-40B4-BE49-F238E27FC236}">
                 <a16:creationId xmlns:a16="http://schemas.microsoft.com/office/drawing/2014/main" id="{507C86A9-5AA4-5FEE-279D-DB62E9AF5A84}"/>
@@ -21093,7 +21093,7 @@
       </p:sp>
       <p:sp>
         <p:nvSpPr>
-          <p:cNvPr id="4" name="Espace réservé du contenu 3">
+          <p:cNvPr id="4" name="slot.body-left">
             <a:extLst>
               <a:ext uri="{FF2B5EF4-FFF2-40B4-BE49-F238E27FC236}">
                 <a16:creationId xmlns:a16="http://schemas.microsoft.com/office/drawing/2014/main" id="{1615B9A0-C888-2906-494C-2BE85967A792}"/>
@@ -21118,7 +21118,7 @@
       </p:sp>
       <p:sp>
         <p:nvSpPr>
-          <p:cNvPr id="5" name="Espace réservé du texte 4">
+          <p:cNvPr id="5" name="slot.subtitle-center">
             <a:extLst>
               <a:ext uri="{FF2B5EF4-FFF2-40B4-BE49-F238E27FC236}">
                 <a16:creationId xmlns:a16="http://schemas.microsoft.com/office/drawing/2014/main" id="{899EBAB0-D7CA-FCF6-5AE7-F3182BDD73D7}"/>
@@ -21143,7 +21143,7 @@
       </p:sp>
       <p:sp>
         <p:nvSpPr>
-          <p:cNvPr id="6" name="Espace réservé du contenu 5">
+          <p:cNvPr id="6" name="slot.body-right">
             <a:extLst>
               <a:ext uri="{FF2B5EF4-FFF2-40B4-BE49-F238E27FC236}">
                 <a16:creationId xmlns:a16="http://schemas.microsoft.com/office/drawing/2014/main" id="{15A49452-0460-60CD-1237-4332D2B7D644}"/>
@@ -21252,7 +21252,7 @@
       </p:grpSpPr>
       <p:sp>
         <p:nvSpPr>
-          <p:cNvPr id="2" name="Titre 1">
+          <p:cNvPr id="2" name="slot.title">
             <a:extLst>
               <a:ext uri="{FF2B5EF4-FFF2-40B4-BE49-F238E27FC236}">
                 <a16:creationId xmlns:a16="http://schemas.microsoft.com/office/drawing/2014/main" id="{642C1C7A-2951-8460-E931-5812BA57EE8A}"/>
@@ -21277,7 +21277,7 @@
       </p:sp>
       <p:sp>
         <p:nvSpPr>
-          <p:cNvPr id="3" name="Espace réservé du texte 2">
+          <p:cNvPr id="3" name="slot.subtitle-1">
             <a:extLst>
               <a:ext uri="{FF2B5EF4-FFF2-40B4-BE49-F238E27FC236}">
                 <a16:creationId xmlns:a16="http://schemas.microsoft.com/office/drawing/2014/main" id="{4BE58D27-D33D-9A6A-261A-FC37592CCB76}"/>
@@ -21352,7 +21352,7 @@
       </p:sp>
       <p:sp>
         <p:nvSpPr>
-          <p:cNvPr id="6" name="Espace réservé du numéro de diapositive 5">
+          <p:cNvPr id="6" name="slot.footer-page">
             <a:extLst>
               <a:ext uri="{FF2B5EF4-FFF2-40B4-BE49-F238E27FC236}">
                 <a16:creationId xmlns:a16="http://schemas.microsoft.com/office/drawing/2014/main" id="{5A64BB6A-ABB8-43B5-C4FE-21B96FB0BB2E}"/>
@@ -21381,7 +21381,7 @@
       </p:sp>
       <p:sp>
         <p:nvSpPr>
-          <p:cNvPr id="7" name="Espace réservé du contenu 6">
+          <p:cNvPr id="7" name="slot.source">
             <a:extLst>
               <a:ext uri="{FF2B5EF4-FFF2-40B4-BE49-F238E27FC236}">
                 <a16:creationId xmlns:a16="http://schemas.microsoft.com/office/drawing/2014/main" id="{86E2B333-DEEF-7099-9A0E-5BCFE4306828}"/>
@@ -21436,7 +21436,7 @@
       </p:grpSpPr>
       <p:sp>
         <p:nvSpPr>
-          <p:cNvPr id="2" name="Titre 1">
+          <p:cNvPr id="2" name="slot.title">
             <a:extLst>
               <a:ext uri="{FF2B5EF4-FFF2-40B4-BE49-F238E27FC236}">
                 <a16:creationId xmlns:a16="http://schemas.microsoft.com/office/drawing/2014/main" id="{F04B6622-6B31-137C-3057-BEC114E1EA0A}"/>
@@ -21461,7 +21461,7 @@
       </p:sp>
       <p:sp>
         <p:nvSpPr>
-          <p:cNvPr id="3" name="Espace réservé du texte 2">
+          <p:cNvPr id="3" name="slot.subtitle-left">
             <a:extLst>
               <a:ext uri="{FF2B5EF4-FFF2-40B4-BE49-F238E27FC236}">
                 <a16:creationId xmlns:a16="http://schemas.microsoft.com/office/drawing/2014/main" id="{9BECFB8F-18AF-4F46-A86C-FEBFF34FBD84}"/>
@@ -21486,7 +21486,7 @@
       </p:sp>
       <p:sp>
         <p:nvSpPr>
-          <p:cNvPr id="4" name="Espace réservé du contenu 3">
+          <p:cNvPr id="4" name="slot.body-left">
             <a:extLst>
               <a:ext uri="{FF2B5EF4-FFF2-40B4-BE49-F238E27FC236}">
                 <a16:creationId xmlns:a16="http://schemas.microsoft.com/office/drawing/2014/main" id="{92B2C9B2-1C38-1A3B-A3B6-94D76323AA00}"/>
@@ -21511,7 +21511,7 @@
       </p:sp>
       <p:sp>
         <p:nvSpPr>
-          <p:cNvPr id="5" name="Espace réservé du texte 4">
+          <p:cNvPr id="5" name="slot.subtitle-right">
             <a:extLst>
               <a:ext uri="{FF2B5EF4-FFF2-40B4-BE49-F238E27FC236}">
                 <a16:creationId xmlns:a16="http://schemas.microsoft.com/office/drawing/2014/main" id="{F2F573AA-32F1-9474-AA0B-5F748B545775}"/>
@@ -21536,7 +21536,7 @@
       </p:sp>
       <p:sp>
         <p:nvSpPr>
-          <p:cNvPr id="6" name="Espace réservé du contenu 5">
+          <p:cNvPr id="6" name="slot.body-right">
             <a:extLst>
               <a:ext uri="{FF2B5EF4-FFF2-40B4-BE49-F238E27FC236}">
                 <a16:creationId xmlns:a16="http://schemas.microsoft.com/office/drawing/2014/main" id="{209746BB-053D-5EAC-CCE0-A0561FCC3E14}"/>
@@ -21561,7 +21561,7 @@
       </p:sp>
       <p:sp>
         <p:nvSpPr>
-          <p:cNvPr id="7" name="Espace réservé du texte 6">
+          <p:cNvPr id="7" name="slot.subtitle-middle">
             <a:extLst>
               <a:ext uri="{FF2B5EF4-FFF2-40B4-BE49-F238E27FC236}">
                 <a16:creationId xmlns:a16="http://schemas.microsoft.com/office/drawing/2014/main" id="{82EE0964-0DD7-A113-68C6-51DE83E049B7}"/>
@@ -21586,7 +21586,7 @@
       </p:sp>
       <p:sp>
         <p:nvSpPr>
-          <p:cNvPr id="8" name="Espace réservé du contenu 7">
+          <p:cNvPr id="8" name="slot.body-center">
             <a:extLst>
               <a:ext uri="{FF2B5EF4-FFF2-40B4-BE49-F238E27FC236}">
                 <a16:creationId xmlns:a16="http://schemas.microsoft.com/office/drawing/2014/main" id="{4E8625F8-C8B3-70DA-59F3-2E8F89562010}"/>
@@ -21695,7 +21695,7 @@
       </p:grpSpPr>
       <p:sp>
         <p:nvSpPr>
-          <p:cNvPr id="2" name="Titre 1">
+          <p:cNvPr id="2" name="slot.title">
             <a:extLst>
               <a:ext uri="{FF2B5EF4-FFF2-40B4-BE49-F238E27FC236}">
                 <a16:creationId xmlns:a16="http://schemas.microsoft.com/office/drawing/2014/main" id="{3F90EC06-30A6-F2AF-B561-806978C6E639}"/>
@@ -21720,7 +21720,7 @@
       </p:sp>
       <p:sp>
         <p:nvSpPr>
-          <p:cNvPr id="3" name="Espace réservé du contenu 2">
+          <p:cNvPr id="3" name="slot.body-left">
             <a:extLst>
               <a:ext uri="{FF2B5EF4-FFF2-40B4-BE49-F238E27FC236}">
                 <a16:creationId xmlns:a16="http://schemas.microsoft.com/office/drawing/2014/main" id="{BF51E751-4D1F-8AFF-4DDB-151A4B82F877}"/>
@@ -21745,7 +21745,7 @@
       </p:sp>
       <p:sp>
         <p:nvSpPr>
-          <p:cNvPr id="4" name="Espace réservé du numéro de diapositive 3">
+          <p:cNvPr id="4" name="slot.footer-page">
             <a:extLst>
               <a:ext uri="{FF2B5EF4-FFF2-40B4-BE49-F238E27FC236}">
                 <a16:creationId xmlns:a16="http://schemas.microsoft.com/office/drawing/2014/main" id="{0E735BF3-7AFE-76C1-631C-652548B2CDC7}"/>
@@ -21805,7 +21805,7 @@
       </p:grpSpPr>
       <p:sp>
         <p:nvSpPr>
-          <p:cNvPr id="2" name="Titre 1">
+          <p:cNvPr id="2" name="slot.title">
             <a:extLst>
               <a:ext uri="{FF2B5EF4-FFF2-40B4-BE49-F238E27FC236}">
                 <a16:creationId xmlns:a16="http://schemas.microsoft.com/office/drawing/2014/main" id="{09AD6002-5264-FF81-5C58-8257C5BE35E0}"/>
@@ -21830,7 +21830,7 @@
       </p:sp>
       <p:sp>
         <p:nvSpPr>
-          <p:cNvPr id="3" name="Espace réservé du texte 2">
+          <p:cNvPr id="3" name="slot.subtitle-left">
             <a:extLst>
               <a:ext uri="{FF2B5EF4-FFF2-40B4-BE49-F238E27FC236}">
                 <a16:creationId xmlns:a16="http://schemas.microsoft.com/office/drawing/2014/main" id="{3DA0BAAF-9233-FECD-C9A4-9D6BB9CB133F}"/>
@@ -21855,7 +21855,7 @@
       </p:sp>
       <p:sp>
         <p:nvSpPr>
-          <p:cNvPr id="4" name="Espace réservé du contenu 3">
+          <p:cNvPr id="4" name="slot.body-left">
             <a:extLst>
               <a:ext uri="{FF2B5EF4-FFF2-40B4-BE49-F238E27FC236}">
                 <a16:creationId xmlns:a16="http://schemas.microsoft.com/office/drawing/2014/main" id="{9F86A069-0F52-B4CB-EABB-F7F2BE1DDC39}"/>
@@ -21880,7 +21880,7 @@
       </p:sp>
       <p:sp>
         <p:nvSpPr>
-          <p:cNvPr id="5" name="Espace réservé du texte 4">
+          <p:cNvPr id="5" name="slot.subtitle-center">
             <a:extLst>
               <a:ext uri="{FF2B5EF4-FFF2-40B4-BE49-F238E27FC236}">
                 <a16:creationId xmlns:a16="http://schemas.microsoft.com/office/drawing/2014/main" id="{3F8F4092-5C55-47A8-80BF-15DB6F705E87}"/>
@@ -21905,7 +21905,7 @@
       </p:sp>
       <p:sp>
         <p:nvSpPr>
-          <p:cNvPr id="6" name="Espace réservé du contenu 5">
+          <p:cNvPr id="6" name="slot.body-right">
             <a:extLst>
               <a:ext uri="{FF2B5EF4-FFF2-40B4-BE49-F238E27FC236}">
                 <a16:creationId xmlns:a16="http://schemas.microsoft.com/office/drawing/2014/main" id="{4FD0BBC1-AF6B-7FB2-8131-9CFFE5B4F720}"/>
@@ -22014,7 +22014,7 @@
       </p:grpSpPr>
       <p:sp>
         <p:nvSpPr>
-          <p:cNvPr id="2" name="Espace réservé du numéro de diapositive 1">
+          <p:cNvPr id="2" name="slot.footer-page">
             <a:extLst>
               <a:ext uri="{FF2B5EF4-FFF2-40B4-BE49-F238E27FC236}">
                 <a16:creationId xmlns:a16="http://schemas.microsoft.com/office/drawing/2014/main" id="{F8C126C1-B24A-39D2-94A0-FFACD11454AA}"/>
@@ -22043,7 +22043,7 @@
       </p:sp>
       <p:sp>
         <p:nvSpPr>
-          <p:cNvPr id="3" name="Espace réservé du contenu 2">
+          <p:cNvPr id="3" name="slot.source">
             <a:extLst>
               <a:ext uri="{FF2B5EF4-FFF2-40B4-BE49-F238E27FC236}">
                 <a16:creationId xmlns:a16="http://schemas.microsoft.com/office/drawing/2014/main" id="{EDAB797B-BD47-F8EB-9C7B-5DD0CFEBADB8}"/>
@@ -22098,7 +22098,7 @@
       </p:grpSpPr>
       <p:sp>
         <p:nvSpPr>
-          <p:cNvPr id="2" name="Titre 1">
+          <p:cNvPr id="2" name="slot.title">
             <a:extLst>
               <a:ext uri="{FF2B5EF4-FFF2-40B4-BE49-F238E27FC236}">
                 <a16:creationId xmlns:a16="http://schemas.microsoft.com/office/drawing/2014/main" id="{374C00EF-B038-0C65-A241-7BA2006BD93D}"/>
@@ -22123,7 +22123,7 @@
       </p:sp>
       <p:sp>
         <p:nvSpPr>
-          <p:cNvPr id="3" name="Sous-titre 2">
+          <p:cNvPr id="3" name="slot.subtitle">
             <a:extLst>
               <a:ext uri="{FF2B5EF4-FFF2-40B4-BE49-F238E27FC236}">
                 <a16:creationId xmlns:a16="http://schemas.microsoft.com/office/drawing/2014/main" id="{B200C2F0-0A4E-E4B1-6889-CCD71BAA093E}"/>
@@ -22148,7 +22148,7 @@
       </p:sp>
       <p:sp>
         <p:nvSpPr>
-          <p:cNvPr id="4" name="Espace réservé du texte 3">
+          <p:cNvPr id="4" name="slot.body">
             <a:extLst>
               <a:ext uri="{FF2B5EF4-FFF2-40B4-BE49-F238E27FC236}">
                 <a16:creationId xmlns:a16="http://schemas.microsoft.com/office/drawing/2014/main" id="{64EDA83A-70CF-2093-E08B-6577F07B93B0}"/>
@@ -22173,7 +22173,7 @@
       </p:sp>
       <p:sp>
         <p:nvSpPr>
-          <p:cNvPr id="5" name="Espace réservé pour une image  4">
+          <p:cNvPr id="5" name="slot.image">
             <a:extLst>
               <a:ext uri="{FF2B5EF4-FFF2-40B4-BE49-F238E27FC236}">
                 <a16:creationId xmlns:a16="http://schemas.microsoft.com/office/drawing/2014/main" id="{03704343-FDF9-0B04-E26C-C52FDAC38AE3}"/>
@@ -22228,7 +22228,7 @@
       </p:grpSpPr>
       <p:sp>
         <p:nvSpPr>
-          <p:cNvPr id="2" name="Titre 1">
+          <p:cNvPr id="2" name="slot.section-title">
             <a:extLst>
               <a:ext uri="{FF2B5EF4-FFF2-40B4-BE49-F238E27FC236}">
                 <a16:creationId xmlns:a16="http://schemas.microsoft.com/office/drawing/2014/main" id="{F1BC0C3D-26C5-B176-7BFF-6520034413BA}"/>
@@ -22253,7 +22253,7 @@
       </p:sp>
       <p:sp>
         <p:nvSpPr>
-          <p:cNvPr id="3" name="Sous-titre 2">
+          <p:cNvPr id="3" name="slot.subtitle">
             <a:extLst>
               <a:ext uri="{FF2B5EF4-FFF2-40B4-BE49-F238E27FC236}">
                 <a16:creationId xmlns:a16="http://schemas.microsoft.com/office/drawing/2014/main" id="{72D99522-BBC2-339A-157B-E266188B49E5}"/>
@@ -22308,7 +22308,7 @@
       </p:grpSpPr>
       <p:sp>
         <p:nvSpPr>
-          <p:cNvPr id="2" name="Titre 1">
+          <p:cNvPr id="2" name="slot.section-title">
             <a:extLst>
               <a:ext uri="{FF2B5EF4-FFF2-40B4-BE49-F238E27FC236}">
                 <a16:creationId xmlns:a16="http://schemas.microsoft.com/office/drawing/2014/main" id="{7ABCA97C-1EB3-759D-152E-F5D49FB8B12D}"/>
@@ -22333,7 +22333,7 @@
       </p:sp>
       <p:sp>
         <p:nvSpPr>
-          <p:cNvPr id="3" name="Sous-titre 2">
+          <p:cNvPr id="3" name="slot.subtitle">
             <a:extLst>
               <a:ext uri="{FF2B5EF4-FFF2-40B4-BE49-F238E27FC236}">
                 <a16:creationId xmlns:a16="http://schemas.microsoft.com/office/drawing/2014/main" id="{10574AA7-F19E-53D0-15C6-BAED9DD9AE99}"/>
@@ -22388,7 +22388,7 @@
       </p:grpSpPr>
       <p:sp>
         <p:nvSpPr>
-          <p:cNvPr id="2" name="Titre 1">
+          <p:cNvPr id="2" name="slot.title">
             <a:extLst>
               <a:ext uri="{FF2B5EF4-FFF2-40B4-BE49-F238E27FC236}">
                 <a16:creationId xmlns:a16="http://schemas.microsoft.com/office/drawing/2014/main" id="{3557F5E2-DE24-B1BE-806A-41DFD0EA573B}"/>
@@ -22413,7 +22413,7 @@
       </p:sp>
       <p:sp>
         <p:nvSpPr>
-          <p:cNvPr id="3" name="Espace réservé du numéro de diapositive 2">
+          <p:cNvPr id="3" name="slot.footer-page">
             <a:extLst>
               <a:ext uri="{FF2B5EF4-FFF2-40B4-BE49-F238E27FC236}">
                 <a16:creationId xmlns:a16="http://schemas.microsoft.com/office/drawing/2014/main" id="{E389FC4E-69D2-CB98-99E0-8235C5DF4832}"/>
@@ -22442,7 +22442,7 @@
       </p:sp>
       <p:sp>
         <p:nvSpPr>
-          <p:cNvPr id="4" name="Espace réservé du contenu 3">
+          <p:cNvPr id="4" name="slot.body-left">
             <a:extLst>
               <a:ext uri="{FF2B5EF4-FFF2-40B4-BE49-F238E27FC236}">
                 <a16:creationId xmlns:a16="http://schemas.microsoft.com/office/drawing/2014/main" id="{57014636-1242-DAAA-256A-ED368B606BEC}"/>
@@ -22497,7 +22497,7 @@
       </p:grpSpPr>
       <p:sp>
         <p:nvSpPr>
-          <p:cNvPr id="2" name="Titre 1">
+          <p:cNvPr id="2" name="slot.title">
             <a:extLst>
               <a:ext uri="{FF2B5EF4-FFF2-40B4-BE49-F238E27FC236}">
                 <a16:creationId xmlns:a16="http://schemas.microsoft.com/office/drawing/2014/main" id="{AD338188-5DE4-C5CB-FE17-B4AE4BD42079}"/>
@@ -22522,7 +22522,7 @@
       </p:sp>
       <p:sp>
         <p:nvSpPr>
-          <p:cNvPr id="3" name="Espace réservé du texte 2">
+          <p:cNvPr id="3" name="slot.subtitle-1">
             <a:extLst>
               <a:ext uri="{FF2B5EF4-FFF2-40B4-BE49-F238E27FC236}">
                 <a16:creationId xmlns:a16="http://schemas.microsoft.com/office/drawing/2014/main" id="{57F5E41D-FE93-0A76-9D73-D1E1F79C27F3}"/>
@@ -22597,7 +22597,7 @@
       </p:sp>
       <p:sp>
         <p:nvSpPr>
-          <p:cNvPr id="6" name="Espace réservé du numéro de diapositive 5">
+          <p:cNvPr id="6" name="slot.footer-page">
             <a:extLst>
               <a:ext uri="{FF2B5EF4-FFF2-40B4-BE49-F238E27FC236}">
                 <a16:creationId xmlns:a16="http://schemas.microsoft.com/office/drawing/2014/main" id="{93029647-4684-D393-CF0A-BF12BF20539B}"/>
@@ -22626,7 +22626,7 @@
       </p:sp>
       <p:sp>
         <p:nvSpPr>
-          <p:cNvPr id="7" name="Espace réservé du contenu 6">
+          <p:cNvPr id="7" name="slot.source">
             <a:extLst>
               <a:ext uri="{FF2B5EF4-FFF2-40B4-BE49-F238E27FC236}">
                 <a16:creationId xmlns:a16="http://schemas.microsoft.com/office/drawing/2014/main" id="{7D007424-99FE-9625-45E0-4F3C4A8FB982}"/>
@@ -22681,7 +22681,7 @@
       </p:grpSpPr>
       <p:sp>
         <p:nvSpPr>
-          <p:cNvPr id="2" name="Titre 1">
+          <p:cNvPr id="2" name="slot.title">
             <a:extLst>
               <a:ext uri="{FF2B5EF4-FFF2-40B4-BE49-F238E27FC236}">
                 <a16:creationId xmlns:a16="http://schemas.microsoft.com/office/drawing/2014/main" id="{60196F93-28B3-0AC4-E12E-B919C02EDE9E}"/>
@@ -22706,7 +22706,7 @@
       </p:sp>
       <p:sp>
         <p:nvSpPr>
-          <p:cNvPr id="3" name="Espace réservé du texte 2">
+          <p:cNvPr id="3" name="slot.subtitle-left">
             <a:extLst>
               <a:ext uri="{FF2B5EF4-FFF2-40B4-BE49-F238E27FC236}">
                 <a16:creationId xmlns:a16="http://schemas.microsoft.com/office/drawing/2014/main" id="{F5334444-FCDF-1684-3FB8-353DDE1A56F3}"/>
@@ -22731,7 +22731,7 @@
       </p:sp>
       <p:sp>
         <p:nvSpPr>
-          <p:cNvPr id="4" name="Espace réservé du contenu 3">
+          <p:cNvPr id="4" name="slot.body-left">
             <a:extLst>
               <a:ext uri="{FF2B5EF4-FFF2-40B4-BE49-F238E27FC236}">
                 <a16:creationId xmlns:a16="http://schemas.microsoft.com/office/drawing/2014/main" id="{FD352B93-713D-7B29-0C96-707BE1CD5EB1}"/>
@@ -22756,7 +22756,7 @@
       </p:sp>
       <p:sp>
         <p:nvSpPr>
-          <p:cNvPr id="5" name="Espace réservé du texte 4">
+          <p:cNvPr id="5" name="slot.subtitle-right">
             <a:extLst>
               <a:ext uri="{FF2B5EF4-FFF2-40B4-BE49-F238E27FC236}">
                 <a16:creationId xmlns:a16="http://schemas.microsoft.com/office/drawing/2014/main" id="{2155886C-20D1-8079-4E2C-A73C6BE8B440}"/>
@@ -22781,7 +22781,7 @@
       </p:sp>
       <p:sp>
         <p:nvSpPr>
-          <p:cNvPr id="6" name="Espace réservé du contenu 5">
+          <p:cNvPr id="6" name="slot.body-right">
             <a:extLst>
               <a:ext uri="{FF2B5EF4-FFF2-40B4-BE49-F238E27FC236}">
                 <a16:creationId xmlns:a16="http://schemas.microsoft.com/office/drawing/2014/main" id="{F79C5220-BA0D-98C6-8A4B-CC116CD16EFD}"/>
@@ -22891,7 +22891,7 @@
       </p:grpSpPr>
       <p:sp>
         <p:nvSpPr>
-          <p:cNvPr id="2" name="Titre 1">
+          <p:cNvPr id="2" name="slot.title">
             <a:extLst>
               <a:ext uri="{FF2B5EF4-FFF2-40B4-BE49-F238E27FC236}">
                 <a16:creationId xmlns:a16="http://schemas.microsoft.com/office/drawing/2014/main" id="{A1CFCE2F-EEED-699F-16B7-14583F29EE31}"/>
@@ -22916,7 +22916,7 @@
       </p:sp>
       <p:sp>
         <p:nvSpPr>
-          <p:cNvPr id="3" name="Espace réservé du texte 2">
+          <p:cNvPr id="3" name="slot.subtitle-left">
             <a:extLst>
               <a:ext uri="{FF2B5EF4-FFF2-40B4-BE49-F238E27FC236}">
                 <a16:creationId xmlns:a16="http://schemas.microsoft.com/office/drawing/2014/main" id="{52EE0DEE-BE02-0E60-46F1-9B17BE9DCC2C}"/>
@@ -22941,7 +22941,7 @@
       </p:sp>
       <p:sp>
         <p:nvSpPr>
-          <p:cNvPr id="4" name="Espace réservé du contenu 3">
+          <p:cNvPr id="4" name="slot.body-left">
             <a:extLst>
               <a:ext uri="{FF2B5EF4-FFF2-40B4-BE49-F238E27FC236}">
                 <a16:creationId xmlns:a16="http://schemas.microsoft.com/office/drawing/2014/main" id="{6DEB6691-49FC-D5CD-00E2-956161A686E3}"/>
@@ -22966,7 +22966,7 @@
       </p:sp>
       <p:sp>
         <p:nvSpPr>
-          <p:cNvPr id="5" name="Espace réservé du texte 4">
+          <p:cNvPr id="5" name="slot.subtitle-center">
             <a:extLst>
               <a:ext uri="{FF2B5EF4-FFF2-40B4-BE49-F238E27FC236}">
                 <a16:creationId xmlns:a16="http://schemas.microsoft.com/office/drawing/2014/main" id="{A6481CB5-EAF6-34D0-38D2-004DF250D138}"/>
@@ -22991,7 +22991,7 @@
       </p:sp>
       <p:sp>
         <p:nvSpPr>
-          <p:cNvPr id="6" name="Espace réservé du contenu 5">
+          <p:cNvPr id="6" name="slot.body-right">
             <a:extLst>
               <a:ext uri="{FF2B5EF4-FFF2-40B4-BE49-F238E27FC236}">
                 <a16:creationId xmlns:a16="http://schemas.microsoft.com/office/drawing/2014/main" id="{CCBAEE9E-9656-7330-1450-08204C79A982}"/>
@@ -23101,7 +23101,7 @@
       </p:grpSpPr>
       <p:sp>
         <p:nvSpPr>
-          <p:cNvPr id="2" name="Titre 1">
+          <p:cNvPr id="2" name="slot.title">
             <a:extLst>
               <a:ext uri="{FF2B5EF4-FFF2-40B4-BE49-F238E27FC236}">
                 <a16:creationId xmlns:a16="http://schemas.microsoft.com/office/drawing/2014/main" id="{4E843E8F-F946-1ADE-FB37-0EBF4D9CBEF8}"/>
@@ -23126,7 +23126,7 @@
       </p:sp>
       <p:sp>
         <p:nvSpPr>
-          <p:cNvPr id="3" name="Espace réservé du texte 2">
+          <p:cNvPr id="3" name="slot.subtitle-1">
             <a:extLst>
               <a:ext uri="{FF2B5EF4-FFF2-40B4-BE49-F238E27FC236}">
                 <a16:creationId xmlns:a16="http://schemas.microsoft.com/office/drawing/2014/main" id="{1675CAD6-9E20-BF63-6D76-BAE57FC8D65D}"/>
@@ -23201,7 +23201,7 @@
       </p:sp>
       <p:sp>
         <p:nvSpPr>
-          <p:cNvPr id="6" name="Espace réservé du numéro de diapositive 5">
+          <p:cNvPr id="6" name="slot.footer-page">
             <a:extLst>
               <a:ext uri="{FF2B5EF4-FFF2-40B4-BE49-F238E27FC236}">
                 <a16:creationId xmlns:a16="http://schemas.microsoft.com/office/drawing/2014/main" id="{0CF94BA1-CADC-3BB5-F63F-E912932EAE7F}"/>
@@ -23231,7 +23231,7 @@
       </p:sp>
       <p:sp>
         <p:nvSpPr>
-          <p:cNvPr id="7" name="Espace réservé du contenu 6">
+          <p:cNvPr id="7" name="slot.source">
             <a:extLst>
               <a:ext uri="{FF2B5EF4-FFF2-40B4-BE49-F238E27FC236}">
                 <a16:creationId xmlns:a16="http://schemas.microsoft.com/office/drawing/2014/main" id="{DA655AE8-4AB0-E991-4F30-5F6219C4F5C4}"/>
@@ -23286,7 +23286,7 @@
       </p:grpSpPr>
       <p:sp>
         <p:nvSpPr>
-          <p:cNvPr id="2" name="Titre 1">
+          <p:cNvPr id="2" name="slot.title">
             <a:extLst>
               <a:ext uri="{FF2B5EF4-FFF2-40B4-BE49-F238E27FC236}">
                 <a16:creationId xmlns:a16="http://schemas.microsoft.com/office/drawing/2014/main" id="{A6D17A19-CAE4-FA2F-080D-DA17849C5916}"/>
@@ -23311,7 +23311,7 @@
       </p:sp>
       <p:sp>
         <p:nvSpPr>
-          <p:cNvPr id="3" name="Espace réservé du texte 2">
+          <p:cNvPr id="3" name="slot.subtitle-1">
             <a:extLst>
               <a:ext uri="{FF2B5EF4-FFF2-40B4-BE49-F238E27FC236}">
                 <a16:creationId xmlns:a16="http://schemas.microsoft.com/office/drawing/2014/main" id="{F6D07D73-8ACA-BC20-1ADF-744E20D84DFA}"/>
@@ -23386,7 +23386,7 @@
       </p:sp>
       <p:sp>
         <p:nvSpPr>
-          <p:cNvPr id="6" name="Espace réservé du numéro de diapositive 5">
+          <p:cNvPr id="6" name="slot.footer-page">
             <a:extLst>
               <a:ext uri="{FF2B5EF4-FFF2-40B4-BE49-F238E27FC236}">
                 <a16:creationId xmlns:a16="http://schemas.microsoft.com/office/drawing/2014/main" id="{BF5E0291-96D4-4AAD-9728-6D7882490A4F}"/>
@@ -23416,7 +23416,7 @@
       </p:sp>
       <p:sp>
         <p:nvSpPr>
-          <p:cNvPr id="7" name="Espace réservé du contenu 6">
+          <p:cNvPr id="7" name="slot.source">
             <a:extLst>
               <a:ext uri="{FF2B5EF4-FFF2-40B4-BE49-F238E27FC236}">
                 <a16:creationId xmlns:a16="http://schemas.microsoft.com/office/drawing/2014/main" id="{9414BBDE-DFC1-B1B1-CCB9-338AAFF2DAEB}"/>
@@ -23471,7 +23471,7 @@
       </p:grpSpPr>
       <p:sp>
         <p:nvSpPr>
-          <p:cNvPr id="2" name="Titre 1">
+          <p:cNvPr id="2" name="slot.title">
             <a:extLst>
               <a:ext uri="{FF2B5EF4-FFF2-40B4-BE49-F238E27FC236}">
                 <a16:creationId xmlns:a16="http://schemas.microsoft.com/office/drawing/2014/main" id="{C9860B66-4F97-16A2-5884-362D844D5186}"/>
@@ -23496,7 +23496,7 @@
       </p:sp>
       <p:sp>
         <p:nvSpPr>
-          <p:cNvPr id="3" name="Espace réservé du contenu 2">
+          <p:cNvPr id="3" name="slot.body-left">
             <a:extLst>
               <a:ext uri="{FF2B5EF4-FFF2-40B4-BE49-F238E27FC236}">
                 <a16:creationId xmlns:a16="http://schemas.microsoft.com/office/drawing/2014/main" id="{67D0980E-EC25-1F76-A0E7-024667E7F4A2}"/>
@@ -23521,7 +23521,7 @@
       </p:sp>
       <p:sp>
         <p:nvSpPr>
-          <p:cNvPr id="4" name="Espace réservé du numéro de diapositive 3">
+          <p:cNvPr id="4" name="slot.footer-page">
             <a:extLst>
               <a:ext uri="{FF2B5EF4-FFF2-40B4-BE49-F238E27FC236}">
                 <a16:creationId xmlns:a16="http://schemas.microsoft.com/office/drawing/2014/main" id="{EE0DA2D1-8508-AF08-321B-9DD6AB3193E9}"/>
@@ -23581,7 +23581,7 @@
       </p:grpSpPr>
       <p:sp>
         <p:nvSpPr>
-          <p:cNvPr id="2" name="Titre 1">
+          <p:cNvPr id="2" name="slot.title">
             <a:extLst>
               <a:ext uri="{FF2B5EF4-FFF2-40B4-BE49-F238E27FC236}">
                 <a16:creationId xmlns:a16="http://schemas.microsoft.com/office/drawing/2014/main" id="{8380E5D0-5026-EB71-0F67-47CE171B2266}"/>
@@ -23606,7 +23606,7 @@
       </p:sp>
       <p:sp>
         <p:nvSpPr>
-          <p:cNvPr id="3" name="Espace réservé du contenu 2">
+          <p:cNvPr id="3" name="slot.body-left">
             <a:extLst>
               <a:ext uri="{FF2B5EF4-FFF2-40B4-BE49-F238E27FC236}">
                 <a16:creationId xmlns:a16="http://schemas.microsoft.com/office/drawing/2014/main" id="{61F73BCE-7414-9647-031B-5E1E96589689}"/>
@@ -23631,7 +23631,7 @@
       </p:sp>
       <p:sp>
         <p:nvSpPr>
-          <p:cNvPr id="4" name="Espace réservé du numéro de diapositive 3">
+          <p:cNvPr id="4" name="slot.footer-page">
             <a:extLst>
               <a:ext uri="{FF2B5EF4-FFF2-40B4-BE49-F238E27FC236}">
                 <a16:creationId xmlns:a16="http://schemas.microsoft.com/office/drawing/2014/main" id="{CCB1391B-9E18-29A1-5039-16BED643ACED}"/>
@@ -23660,7 +23660,7 @@
       </p:sp>
       <p:sp>
         <p:nvSpPr>
-          <p:cNvPr id="5" name="Espace réservé du contenu 4">
+          <p:cNvPr id="5" name="slot.source">
             <a:extLst>
               <a:ext uri="{FF2B5EF4-FFF2-40B4-BE49-F238E27FC236}">
                 <a16:creationId xmlns:a16="http://schemas.microsoft.com/office/drawing/2014/main" id="{1FA08A71-20BC-F105-521A-0896E8DDCFEC}"/>
@@ -23715,7 +23715,7 @@
       </p:grpSpPr>
       <p:sp>
         <p:nvSpPr>
-          <p:cNvPr id="5" name="Titre 4">
+          <p:cNvPr id="5" name="slot.title">
             <a:extLst>
               <a:ext uri="{FF2B5EF4-FFF2-40B4-BE49-F238E27FC236}">
                 <a16:creationId xmlns:a16="http://schemas.microsoft.com/office/drawing/2014/main" id="{56AFBC28-EC91-4C6B-21FC-51452A2E0D5E}"/>
@@ -23740,7 +23740,7 @@
       </p:sp>
       <p:sp>
         <p:nvSpPr>
-          <p:cNvPr id="6" name="Espace réservé du contenu 5">
+          <p:cNvPr id="6" name="slot.source">
             <a:extLst>
               <a:ext uri="{FF2B5EF4-FFF2-40B4-BE49-F238E27FC236}">
                 <a16:creationId xmlns:a16="http://schemas.microsoft.com/office/drawing/2014/main" id="{7E4542B0-4EEC-FBEE-97E0-DC5D5E41CC6B}"/>
@@ -23765,7 +23765,7 @@
       </p:sp>
       <p:sp>
         <p:nvSpPr>
-          <p:cNvPr id="4" name="Espace réservé du numéro de diapositive 3">
+          <p:cNvPr id="4" name="slot.footer-page">
             <a:extLst>
               <a:ext uri="{FF2B5EF4-FFF2-40B4-BE49-F238E27FC236}">
                 <a16:creationId xmlns:a16="http://schemas.microsoft.com/office/drawing/2014/main" id="{6F138008-195A-9DF9-CDBA-4C150FA42D20}"/>
@@ -23824,7 +23824,7 @@
       </p:grpSpPr>
       <p:sp>
         <p:nvSpPr>
-          <p:cNvPr id="5" name="Titre 4">
+          <p:cNvPr id="5" name="slot.title">
             <a:extLst>
               <a:ext uri="{FF2B5EF4-FFF2-40B4-BE49-F238E27FC236}">
                 <a16:creationId xmlns:a16="http://schemas.microsoft.com/office/drawing/2014/main" id="{A78B4462-098A-BEFB-12A5-0B2130617E9E}"/>
@@ -23849,7 +23849,7 @@
       </p:sp>
       <p:sp>
         <p:nvSpPr>
-          <p:cNvPr id="6" name="Espace réservé du contenu 5">
+          <p:cNvPr id="6" name="slot.body-left">
             <a:extLst>
               <a:ext uri="{FF2B5EF4-FFF2-40B4-BE49-F238E27FC236}">
                 <a16:creationId xmlns:a16="http://schemas.microsoft.com/office/drawing/2014/main" id="{B2DBBAC5-9A7A-F9B1-7594-7A706C39E559}"/>
@@ -23874,7 +23874,7 @@
       </p:sp>
       <p:sp>
         <p:nvSpPr>
-          <p:cNvPr id="8" name="Sous-titre 7">
+          <p:cNvPr id="8" name="slot.subtitle">
             <a:extLst>
               <a:ext uri="{FF2B5EF4-FFF2-40B4-BE49-F238E27FC236}">
                 <a16:creationId xmlns:a16="http://schemas.microsoft.com/office/drawing/2014/main" id="{3C84BBC7-166F-A5FB-3EB4-D0E396C32405}"/>
@@ -23899,7 +23899,7 @@
       </p:sp>
       <p:sp>
         <p:nvSpPr>
-          <p:cNvPr id="4" name="Espace réservé du numéro de diapositive 3">
+          <p:cNvPr id="4" name="slot.footer-page">
             <a:extLst>
               <a:ext uri="{FF2B5EF4-FFF2-40B4-BE49-F238E27FC236}">
                 <a16:creationId xmlns:a16="http://schemas.microsoft.com/office/drawing/2014/main" id="{5C8601E0-E097-6F4C-1CB6-93C63DFC9604}"/>
@@ -23928,7 +23928,7 @@
       </p:sp>
       <p:sp>
         <p:nvSpPr>
-          <p:cNvPr id="7" name="Espace réservé du contenu 6">
+          <p:cNvPr id="7" name="slot.source">
             <a:extLst>
               <a:ext uri="{FF2B5EF4-FFF2-40B4-BE49-F238E27FC236}">
                 <a16:creationId xmlns:a16="http://schemas.microsoft.com/office/drawing/2014/main" id="{140ECFB3-DB91-97BB-BC3F-A41D4BC064F2}"/>
@@ -24229,7 +24229,7 @@
       </p:grpSpPr>
       <p:sp>
         <p:nvSpPr>
-          <p:cNvPr id="11" name="Titre 10">
+          <p:cNvPr id="11" name="slot.title">
             <a:extLst>
               <a:ext uri="{FF2B5EF4-FFF2-40B4-BE49-F238E27FC236}">
                 <a16:creationId xmlns:a16="http://schemas.microsoft.com/office/drawing/2014/main" id="{D1C5C7F7-F1BB-F645-9BFD-AC43D790CDB8}"/>
@@ -24254,7 +24254,7 @@
       </p:sp>
       <p:graphicFrame>
         <p:nvGraphicFramePr>
-          <p:cNvPr id="2" name="Espace réservé du contenu 1">
+          <p:cNvPr id="2" name="slot.chart">
             <a:extLst>
               <a:ext uri="{FF2B5EF4-FFF2-40B4-BE49-F238E27FC236}">
                 <a16:creationId xmlns:a16="http://schemas.microsoft.com/office/drawing/2014/main" id="{8B9A51C8-0821-CC8D-FE41-EC04560121EE}"/>
@@ -24285,7 +24285,7 @@
       </p:graphicFrame>
       <p:sp>
         <p:nvSpPr>
-          <p:cNvPr id="4" name="Espace réservé du numéro de diapositive 3">
+          <p:cNvPr id="4" name="slot.footer-page">
             <a:extLst>
               <a:ext uri="{FF2B5EF4-FFF2-40B4-BE49-F238E27FC236}">
                 <a16:creationId xmlns:a16="http://schemas.microsoft.com/office/drawing/2014/main" id="{ACA357C0-33AA-F8BB-B7C0-8DFBCE7B96BC}"/>
@@ -24314,7 +24314,7 @@
       </p:sp>
       <p:sp>
         <p:nvSpPr>
-          <p:cNvPr id="12" name="Espace réservé du contenu 11">
+          <p:cNvPr id="12" name="slot.source">
             <a:extLst>
               <a:ext uri="{FF2B5EF4-FFF2-40B4-BE49-F238E27FC236}">
                 <a16:creationId xmlns:a16="http://schemas.microsoft.com/office/drawing/2014/main" id="{3C2A6227-568F-E980-735B-9E2C7525D872}"/>
@@ -24339,7 +24339,7 @@
       </p:sp>
       <p:sp>
         <p:nvSpPr>
-          <p:cNvPr id="3" name="Espace réservé du contenu 5">
+          <p:cNvPr id="3" name="slot.body-right">
             <a:extLst>
               <a:ext uri="{FF2B5EF4-FFF2-40B4-BE49-F238E27FC236}">
                 <a16:creationId xmlns:a16="http://schemas.microsoft.com/office/drawing/2014/main" id="{8D0B1F2F-2950-2FED-2CF1-55AA8817ED3F}"/>
@@ -24578,7 +24578,7 @@
       </p:sp>
       <p:sp>
         <p:nvSpPr>
-          <p:cNvPr id="13" name="Espace réservé du contenu 5">
+          <p:cNvPr id="13" name="slot.chart-title">
             <a:extLst>
               <a:ext uri="{FF2B5EF4-FFF2-40B4-BE49-F238E27FC236}">
                 <a16:creationId xmlns:a16="http://schemas.microsoft.com/office/drawing/2014/main" id="{945984DF-2BDC-B335-76E3-4D1A5C06727A}"/>
@@ -24872,7 +24872,7 @@
       </p:grpSpPr>
       <p:sp>
         <p:nvSpPr>
-          <p:cNvPr id="11" name="Titre 10">
+          <p:cNvPr id="11" name="slot.title">
             <a:extLst>
               <a:ext uri="{FF2B5EF4-FFF2-40B4-BE49-F238E27FC236}">
                 <a16:creationId xmlns:a16="http://schemas.microsoft.com/office/drawing/2014/main" id="{9BD6B52A-FF19-78CF-A935-E133AB89A4BB}"/>
@@ -24897,7 +24897,7 @@
       </p:sp>
       <p:graphicFrame>
         <p:nvGraphicFramePr>
-          <p:cNvPr id="2" name="Espace réservé du contenu 1">
+          <p:cNvPr id="2" name="slot.chart">
             <a:extLst>
               <a:ext uri="{FF2B5EF4-FFF2-40B4-BE49-F238E27FC236}">
                 <a16:creationId xmlns:a16="http://schemas.microsoft.com/office/drawing/2014/main" id="{43A9A298-18DF-1A43-C8A6-AF4C2F808ABB}"/>
@@ -24928,7 +24928,7 @@
       </p:graphicFrame>
       <p:sp>
         <p:nvSpPr>
-          <p:cNvPr id="4" name="Espace réservé du numéro de diapositive 3">
+          <p:cNvPr id="4" name="slot.footer-page">
             <a:extLst>
               <a:ext uri="{FF2B5EF4-FFF2-40B4-BE49-F238E27FC236}">
                 <a16:creationId xmlns:a16="http://schemas.microsoft.com/office/drawing/2014/main" id="{F4B4F2E0-11FD-0E6A-3E72-DE65E7BF7B3C}"/>
@@ -24957,7 +24957,7 @@
       </p:sp>
       <p:sp>
         <p:nvSpPr>
-          <p:cNvPr id="12" name="Espace réservé du contenu 11">
+          <p:cNvPr id="12" name="slot.source">
             <a:extLst>
               <a:ext uri="{FF2B5EF4-FFF2-40B4-BE49-F238E27FC236}">
                 <a16:creationId xmlns:a16="http://schemas.microsoft.com/office/drawing/2014/main" id="{4FFBAF71-AAF1-3782-E97A-9AE70D79E6AF}"/>
@@ -24982,7 +24982,7 @@
       </p:sp>
       <p:sp>
         <p:nvSpPr>
-          <p:cNvPr id="10" name="Espace réservé du contenu 5">
+          <p:cNvPr id="10" name="slot.body-right">
             <a:extLst>
               <a:ext uri="{FF2B5EF4-FFF2-40B4-BE49-F238E27FC236}">
                 <a16:creationId xmlns:a16="http://schemas.microsoft.com/office/drawing/2014/main" id="{E47B0D7A-5F90-F7D3-A811-E1A7AEE96FB1}"/>
@@ -25221,7 +25221,7 @@
       </p:sp>
       <p:sp>
         <p:nvSpPr>
-          <p:cNvPr id="13" name="Espace réservé du contenu 5">
+          <p:cNvPr id="13" name="slot.chart-title">
             <a:extLst>
               <a:ext uri="{FF2B5EF4-FFF2-40B4-BE49-F238E27FC236}">
                 <a16:creationId xmlns:a16="http://schemas.microsoft.com/office/drawing/2014/main" id="{997B11C3-8955-D64A-329E-B0AA8D59C74C}"/>
@@ -25515,7 +25515,7 @@
       </p:grpSpPr>
       <p:sp>
         <p:nvSpPr>
-          <p:cNvPr id="11" name="Titre 10">
+          <p:cNvPr id="11" name="slot.title">
             <a:extLst>
               <a:ext uri="{FF2B5EF4-FFF2-40B4-BE49-F238E27FC236}">
                 <a16:creationId xmlns:a16="http://schemas.microsoft.com/office/drawing/2014/main" id="{E6BA610B-9EE9-45A1-B28B-47B1ECDE0349}"/>
@@ -25540,7 +25540,7 @@
       </p:sp>
       <p:graphicFrame>
         <p:nvGraphicFramePr>
-          <p:cNvPr id="2" name="Espace réservé du contenu 1">
+          <p:cNvPr id="2" name="slot.chart">
             <a:extLst>
               <a:ext uri="{FF2B5EF4-FFF2-40B4-BE49-F238E27FC236}">
                 <a16:creationId xmlns:a16="http://schemas.microsoft.com/office/drawing/2014/main" id="{9C81EFE1-097D-C671-2766-C25389738490}"/>
@@ -25571,7 +25571,7 @@
       </p:graphicFrame>
       <p:sp>
         <p:nvSpPr>
-          <p:cNvPr id="4" name="Espace réservé du numéro de diapositive 3">
+          <p:cNvPr id="4" name="slot.footer-page">
             <a:extLst>
               <a:ext uri="{FF2B5EF4-FFF2-40B4-BE49-F238E27FC236}">
                 <a16:creationId xmlns:a16="http://schemas.microsoft.com/office/drawing/2014/main" id="{EC42C37B-CB35-17E7-8EE5-6ED39227D43E}"/>
@@ -25600,7 +25600,7 @@
       </p:sp>
       <p:sp>
         <p:nvSpPr>
-          <p:cNvPr id="12" name="Espace réservé du contenu 11">
+          <p:cNvPr id="12" name="slot.source">
             <a:extLst>
               <a:ext uri="{FF2B5EF4-FFF2-40B4-BE49-F238E27FC236}">
                 <a16:creationId xmlns:a16="http://schemas.microsoft.com/office/drawing/2014/main" id="{190093B9-4BCE-CCC2-2DCD-4F71A64766E9}"/>
@@ -25625,7 +25625,7 @@
       </p:sp>
       <p:sp>
         <p:nvSpPr>
-          <p:cNvPr id="10" name="Espace réservé du contenu 5">
+          <p:cNvPr id="10" name="slot.body-right">
             <a:extLst>
               <a:ext uri="{FF2B5EF4-FFF2-40B4-BE49-F238E27FC236}">
                 <a16:creationId xmlns:a16="http://schemas.microsoft.com/office/drawing/2014/main" id="{9B4B49E6-ACBD-1A9F-8953-1EB368346C96}"/>
@@ -25864,7 +25864,7 @@
       </p:sp>
       <p:sp>
         <p:nvSpPr>
-          <p:cNvPr id="13" name="Espace réservé du contenu 5">
+          <p:cNvPr id="13" name="slot.chart-title">
             <a:extLst>
               <a:ext uri="{FF2B5EF4-FFF2-40B4-BE49-F238E27FC236}">
                 <a16:creationId xmlns:a16="http://schemas.microsoft.com/office/drawing/2014/main" id="{33F8A7A2-5825-1682-27AF-955BF8FEC5B1}"/>

</xml_diff>

<commit_message>
fix(setup): rename remaining French placeholders + delete slide 6 artifact
Match slide-level instances by placeholder type (not just cNvPr number),
sweep legacy Espace réservé names on slide and layout parts, delete the
stray txBox on slide 6, and fail validation if any legacy placeholder
names survive.

Co-authored-by: Cursor <cursoragent@cursor.com>
</commit_message>
<xml_diff>
--- a/templates/report.master.pptx
+++ b/templates/report.master.pptx
@@ -4903,7 +4903,7 @@
       </p:graphicFrame>
       <p:sp>
         <p:nvSpPr>
-          <p:cNvPr id="2" name="Titre 1">
+          <p:cNvPr id="2" name="slot.title">
             <a:extLst>
               <a:ext uri="{FF2B5EF4-FFF2-40B4-BE49-F238E27FC236}">
                 <a16:creationId xmlns:a16="http://schemas.microsoft.com/office/drawing/2014/main" id="{FCE45F8B-6B35-4416-DE1A-36DAC87E84D7}"/>
@@ -4947,7 +4947,7 @@
       </p:sp>
       <p:sp>
         <p:nvSpPr>
-          <p:cNvPr id="3" name="Espace réservé du contenu 2">
+          <p:cNvPr id="3" name="slot.body-left">
             <a:extLst>
               <a:ext uri="{FF2B5EF4-FFF2-40B4-BE49-F238E27FC236}">
                 <a16:creationId xmlns:a16="http://schemas.microsoft.com/office/drawing/2014/main" id="{DD259420-A1F5-B3E7-FA1E-AF141FA30A75}"/>
@@ -5033,7 +5033,7 @@
       </p:sp>
       <p:sp>
         <p:nvSpPr>
-          <p:cNvPr id="6" name="Espace réservé du numéro de diapositive 5">
+          <p:cNvPr id="6" name="slot.footer-page">
             <a:extLst>
               <a:ext uri="{FF2B5EF4-FFF2-40B4-BE49-F238E27FC236}">
                 <a16:creationId xmlns:a16="http://schemas.microsoft.com/office/drawing/2014/main" id="{C0B19DAE-9253-B1E3-C9A1-BAD7328324FA}"/>
@@ -5067,7 +5067,7 @@
       </p:sp>
       <p:sp>
         <p:nvSpPr>
-          <p:cNvPr id="20" name="Espace réservé du contenu 6">
+          <p:cNvPr id="20" name="slot.source">
             <a:extLst>
               <a:ext uri="{FF2B5EF4-FFF2-40B4-BE49-F238E27FC236}">
                 <a16:creationId xmlns:a16="http://schemas.microsoft.com/office/drawing/2014/main" id="{A0EE391D-69CD-DBA5-462B-AEF51D098FA6}"/>
@@ -5443,7 +5443,7 @@
       </p:pic>
       <p:sp>
         <p:nvSpPr>
-          <p:cNvPr id="4" name="Titre 1">
+          <p:cNvPr id="4" name="slot.title">
             <a:extLst>
               <a:ext uri="{FF2B5EF4-FFF2-40B4-BE49-F238E27FC236}">
                 <a16:creationId xmlns:a16="http://schemas.microsoft.com/office/drawing/2014/main" id="{5021812E-4666-EE7A-00F0-B822BDC95294}"/>
@@ -5489,7 +5489,7 @@
       </p:sp>
       <p:sp>
         <p:nvSpPr>
-          <p:cNvPr id="5" name="Espace réservé du contenu 3">
+          <p:cNvPr id="5" name="slot.body-left">
             <a:extLst>
               <a:ext uri="{FF2B5EF4-FFF2-40B4-BE49-F238E27FC236}">
                 <a16:creationId xmlns:a16="http://schemas.microsoft.com/office/drawing/2014/main" id="{664EE6FE-7213-D8B4-C52F-792F747C9C0B}"/>
@@ -5715,7 +5715,7 @@
       </p:cxnSp>
       <p:sp>
         <p:nvSpPr>
-          <p:cNvPr id="10" name="Espace réservé du numéro de diapositive 5">
+          <p:cNvPr id="10" name="slot.footer-page">
             <a:extLst>
               <a:ext uri="{FF2B5EF4-FFF2-40B4-BE49-F238E27FC236}">
                 <a16:creationId xmlns:a16="http://schemas.microsoft.com/office/drawing/2014/main" id="{D522E3A2-42AA-2228-2F55-67BD9734EC15}"/>
@@ -6117,7 +6117,7 @@
       </p:graphicFrame>
       <p:sp>
         <p:nvSpPr>
-          <p:cNvPr id="5" name="Titre 1">
+          <p:cNvPr id="5" name="slot.title">
             <a:extLst>
               <a:ext uri="{FF2B5EF4-FFF2-40B4-BE49-F238E27FC236}">
                 <a16:creationId xmlns:a16="http://schemas.microsoft.com/office/drawing/2014/main" id="{00E8F29D-6980-4830-A056-57FFB127FFBD}"/>
@@ -6161,7 +6161,7 @@
       </p:sp>
       <p:sp>
         <p:nvSpPr>
-          <p:cNvPr id="9" name="Sous-titre 2">
+          <p:cNvPr id="9" name="slot.subtitle">
             <a:extLst>
               <a:ext uri="{FF2B5EF4-FFF2-40B4-BE49-F238E27FC236}">
                 <a16:creationId xmlns:a16="http://schemas.microsoft.com/office/drawing/2014/main" id="{D92A2739-22B5-D8C9-22C3-AB9ACCB8111C}"/>
@@ -6778,7 +6778,7 @@
       </p:graphicFrame>
       <p:sp>
         <p:nvSpPr>
-          <p:cNvPr id="2" name="Titre 1">
+          <p:cNvPr id="2" name="slot.section-title">
             <a:extLst>
               <a:ext uri="{FF2B5EF4-FFF2-40B4-BE49-F238E27FC236}">
                 <a16:creationId xmlns:a16="http://schemas.microsoft.com/office/drawing/2014/main" id="{1FAAFAE6-D60C-93B1-4819-060D20F8BFF4}"/>
@@ -6822,7 +6822,7 @@
       </p:sp>
       <p:sp>
         <p:nvSpPr>
-          <p:cNvPr id="3" name="Sous-titre 2">
+          <p:cNvPr id="3" name="slot.subtitle">
             <a:extLst>
               <a:ext uri="{FF2B5EF4-FFF2-40B4-BE49-F238E27FC236}">
                 <a16:creationId xmlns:a16="http://schemas.microsoft.com/office/drawing/2014/main" id="{B989298A-8D13-336B-A448-1CB247CE6E4F}"/>
@@ -7014,7 +7014,7 @@
       </p:graphicFrame>
       <p:sp>
         <p:nvSpPr>
-          <p:cNvPr id="2" name="Titre 1">
+          <p:cNvPr id="2" name="slot.title">
             <a:extLst>
               <a:ext uri="{FF2B5EF4-FFF2-40B4-BE49-F238E27FC236}">
                 <a16:creationId xmlns:a16="http://schemas.microsoft.com/office/drawing/2014/main" id="{02A78A85-561E-020D-C7F8-40BBB3F191CA}"/>
@@ -7098,7 +7098,7 @@
       </p:cxnSp>
       <p:sp>
         <p:nvSpPr>
-          <p:cNvPr id="3" name="Espace réservé du numéro de diapositive 5">
+          <p:cNvPr id="3" name="slot.footer-page">
             <a:extLst>
               <a:ext uri="{FF2B5EF4-FFF2-40B4-BE49-F238E27FC236}">
                 <a16:creationId xmlns:a16="http://schemas.microsoft.com/office/drawing/2014/main" id="{D39FA986-AFFA-D470-697F-282E932DA97D}"/>
@@ -7132,7 +7132,7 @@
       </p:sp>
       <p:sp>
         <p:nvSpPr>
-          <p:cNvPr id="5" name="Espace réservé du contenu 3">
+          <p:cNvPr id="5" name="slot.body-left">
             <a:extLst>
               <a:ext uri="{FF2B5EF4-FFF2-40B4-BE49-F238E27FC236}">
                 <a16:creationId xmlns:a16="http://schemas.microsoft.com/office/drawing/2014/main" id="{FCB803A9-272C-4119-092B-F5D7EE4021F0}"/>
@@ -7523,7 +7523,7 @@
       </p:pic>
       <p:sp>
         <p:nvSpPr>
-          <p:cNvPr id="2" name="Titre 1">
+          <p:cNvPr id="2" name="slot.title">
             <a:extLst>
               <a:ext uri="{FF2B5EF4-FFF2-40B4-BE49-F238E27FC236}">
                 <a16:creationId xmlns:a16="http://schemas.microsoft.com/office/drawing/2014/main" id="{02A78A85-561E-020D-C7F8-40BBB3F191CA}"/>
@@ -7565,7 +7565,7 @@
       </p:sp>
       <p:sp>
         <p:nvSpPr>
-          <p:cNvPr id="3" name="Espace réservé du texte 2">
+          <p:cNvPr id="3" name="slot.subtitle-left">
             <a:extLst>
               <a:ext uri="{FF2B5EF4-FFF2-40B4-BE49-F238E27FC236}">
                 <a16:creationId xmlns:a16="http://schemas.microsoft.com/office/drawing/2014/main" id="{E43735A6-6302-B3D2-6BB7-6309454C5C3A}"/>
@@ -7659,7 +7659,7 @@
       </p:sp>
       <p:sp>
         <p:nvSpPr>
-          <p:cNvPr id="4" name="Espace réservé du contenu 3">
+          <p:cNvPr id="4" name="slot.body-left">
             <a:extLst>
               <a:ext uri="{FF2B5EF4-FFF2-40B4-BE49-F238E27FC236}">
                 <a16:creationId xmlns:a16="http://schemas.microsoft.com/office/drawing/2014/main" id="{2D3E2C40-4C7F-6E36-C2FB-962C73150210}"/>
@@ -7772,7 +7772,7 @@
       </p:sp>
       <p:sp>
         <p:nvSpPr>
-          <p:cNvPr id="5" name="Espace réservé du texte 4">
+          <p:cNvPr id="5" name="slot.subtitle-left">
             <a:extLst>
               <a:ext uri="{FF2B5EF4-FFF2-40B4-BE49-F238E27FC236}">
                 <a16:creationId xmlns:a16="http://schemas.microsoft.com/office/drawing/2014/main" id="{2D35804D-7044-B129-7E2C-ED3868BD4F80}"/>
@@ -7863,7 +7863,7 @@
       </p:sp>
       <p:sp>
         <p:nvSpPr>
-          <p:cNvPr id="6" name="Espace réservé du contenu 5">
+          <p:cNvPr id="6" name="slot.body-right">
             <a:extLst>
               <a:ext uri="{FF2B5EF4-FFF2-40B4-BE49-F238E27FC236}">
                 <a16:creationId xmlns:a16="http://schemas.microsoft.com/office/drawing/2014/main" id="{C56BF488-D9DF-64BA-30D9-77D4A3CB1561}"/>
@@ -8421,7 +8421,7 @@
       </p:pic>
       <p:sp>
         <p:nvSpPr>
-          <p:cNvPr id="2" name="Titre 1">
+          <p:cNvPr id="2" name="slot.title">
             <a:extLst>
               <a:ext uri="{FF2B5EF4-FFF2-40B4-BE49-F238E27FC236}">
                 <a16:creationId xmlns:a16="http://schemas.microsoft.com/office/drawing/2014/main" id="{02A78A85-561E-020D-C7F8-40BBB3F191CA}"/>
@@ -8463,7 +8463,7 @@
       </p:sp>
       <p:sp>
         <p:nvSpPr>
-          <p:cNvPr id="3" name="Espace réservé du texte 2">
+          <p:cNvPr id="3" name="slot.subtitle-left">
             <a:extLst>
               <a:ext uri="{FF2B5EF4-FFF2-40B4-BE49-F238E27FC236}">
                 <a16:creationId xmlns:a16="http://schemas.microsoft.com/office/drawing/2014/main" id="{E43735A6-6302-B3D2-6BB7-6309454C5C3A}"/>
@@ -8557,7 +8557,7 @@
       </p:sp>
       <p:sp>
         <p:nvSpPr>
-          <p:cNvPr id="4" name="Espace réservé du contenu 3">
+          <p:cNvPr id="4" name="slot.body-left">
             <a:extLst>
               <a:ext uri="{FF2B5EF4-FFF2-40B4-BE49-F238E27FC236}">
                 <a16:creationId xmlns:a16="http://schemas.microsoft.com/office/drawing/2014/main" id="{2D3E2C40-4C7F-6E36-C2FB-962C73150210}"/>
@@ -8670,7 +8670,7 @@
       </p:sp>
       <p:sp>
         <p:nvSpPr>
-          <p:cNvPr id="5" name="Espace réservé du texte 4">
+          <p:cNvPr id="5" name="slot.subtitle-left">
             <a:extLst>
               <a:ext uri="{FF2B5EF4-FFF2-40B4-BE49-F238E27FC236}">
                 <a16:creationId xmlns:a16="http://schemas.microsoft.com/office/drawing/2014/main" id="{2D35804D-7044-B129-7E2C-ED3868BD4F80}"/>
@@ -8761,7 +8761,7 @@
       </p:sp>
       <p:sp>
         <p:nvSpPr>
-          <p:cNvPr id="6" name="Espace réservé du contenu 5">
+          <p:cNvPr id="6" name="slot.body-right">
             <a:extLst>
               <a:ext uri="{FF2B5EF4-FFF2-40B4-BE49-F238E27FC236}">
                 <a16:creationId xmlns:a16="http://schemas.microsoft.com/office/drawing/2014/main" id="{C56BF488-D9DF-64BA-30D9-77D4A3CB1561}"/>
@@ -9314,7 +9314,7 @@
       </p:pic>
       <p:sp>
         <p:nvSpPr>
-          <p:cNvPr id="2" name="Titre 1">
+          <p:cNvPr id="2" name="slot.title">
             <a:extLst>
               <a:ext uri="{FF2B5EF4-FFF2-40B4-BE49-F238E27FC236}">
                 <a16:creationId xmlns:a16="http://schemas.microsoft.com/office/drawing/2014/main" id="{02A78A85-561E-020D-C7F8-40BBB3F191CA}"/>
@@ -9356,7 +9356,7 @@
       </p:sp>
       <p:sp>
         <p:nvSpPr>
-          <p:cNvPr id="3" name="Espace réservé du texte 2">
+          <p:cNvPr id="3" name="slot.subtitle-1">
             <a:extLst>
               <a:ext uri="{FF2B5EF4-FFF2-40B4-BE49-F238E27FC236}">
                 <a16:creationId xmlns:a16="http://schemas.microsoft.com/office/drawing/2014/main" id="{E43735A6-6302-B3D2-6BB7-6309454C5C3A}"/>
@@ -9770,7 +9770,7 @@
       </p:cxnSp>
       <p:sp>
         <p:nvSpPr>
-          <p:cNvPr id="15" name="Espace réservé du numéro de diapositive 5">
+          <p:cNvPr id="15" name="slot.footer-page">
             <a:extLst>
               <a:ext uri="{FF2B5EF4-FFF2-40B4-BE49-F238E27FC236}">
                 <a16:creationId xmlns:a16="http://schemas.microsoft.com/office/drawing/2014/main" id="{24F11CE2-041F-6445-F54A-56AAFFD76115}"/>
@@ -9804,7 +9804,7 @@
       </p:sp>
       <p:sp>
         <p:nvSpPr>
-          <p:cNvPr id="20" name="Espace réservé du contenu 6">
+          <p:cNvPr id="20" name="slot.source">
             <a:extLst>
               <a:ext uri="{FF2B5EF4-FFF2-40B4-BE49-F238E27FC236}">
                 <a16:creationId xmlns:a16="http://schemas.microsoft.com/office/drawing/2014/main" id="{95AC962B-733D-ABAE-17E4-E513BAC8B9E1}"/>
@@ -10144,7 +10144,7 @@
       </p:pic>
       <p:sp>
         <p:nvSpPr>
-          <p:cNvPr id="2" name="Titre 1">
+          <p:cNvPr id="2" name="slot.title">
             <a:extLst>
               <a:ext uri="{FF2B5EF4-FFF2-40B4-BE49-F238E27FC236}">
                 <a16:creationId xmlns:a16="http://schemas.microsoft.com/office/drawing/2014/main" id="{02A78A85-561E-020D-C7F8-40BBB3F191CA}"/>
@@ -10186,7 +10186,7 @@
       </p:sp>
       <p:sp>
         <p:nvSpPr>
-          <p:cNvPr id="3" name="Espace réservé du texte 2">
+          <p:cNvPr id="3" name="slot.subtitle-1">
             <a:extLst>
               <a:ext uri="{FF2B5EF4-FFF2-40B4-BE49-F238E27FC236}">
                 <a16:creationId xmlns:a16="http://schemas.microsoft.com/office/drawing/2014/main" id="{E43735A6-6302-B3D2-6BB7-6309454C5C3A}"/>
@@ -10514,7 +10514,7 @@
       </p:cxnSp>
       <p:sp>
         <p:nvSpPr>
-          <p:cNvPr id="15" name="Espace réservé du numéro de diapositive 5">
+          <p:cNvPr id="15" name="slot.footer-page">
             <a:extLst>
               <a:ext uri="{FF2B5EF4-FFF2-40B4-BE49-F238E27FC236}">
                 <a16:creationId xmlns:a16="http://schemas.microsoft.com/office/drawing/2014/main" id="{24F11CE2-041F-6445-F54A-56AAFFD76115}"/>
@@ -10548,7 +10548,7 @@
       </p:sp>
       <p:sp>
         <p:nvSpPr>
-          <p:cNvPr id="20" name="Espace réservé du contenu 6">
+          <p:cNvPr id="20" name="slot.source">
             <a:extLst>
               <a:ext uri="{FF2B5EF4-FFF2-40B4-BE49-F238E27FC236}">
                 <a16:creationId xmlns:a16="http://schemas.microsoft.com/office/drawing/2014/main" id="{95AC962B-733D-ABAE-17E4-E513BAC8B9E1}"/>
@@ -11021,7 +11021,7 @@
       </p:sp>
       <p:sp>
         <p:nvSpPr>
-          <p:cNvPr id="2" name="Titre 1">
+          <p:cNvPr id="2" name="slot.title">
             <a:extLst>
               <a:ext uri="{FF2B5EF4-FFF2-40B4-BE49-F238E27FC236}">
                 <a16:creationId xmlns:a16="http://schemas.microsoft.com/office/drawing/2014/main" id="{02A78A85-561E-020D-C7F8-40BBB3F191CA}"/>
@@ -11063,7 +11063,7 @@
       </p:sp>
       <p:sp>
         <p:nvSpPr>
-          <p:cNvPr id="3" name="Espace réservé du texte 2">
+          <p:cNvPr id="3" name="slot.subtitle-left">
             <a:extLst>
               <a:ext uri="{FF2B5EF4-FFF2-40B4-BE49-F238E27FC236}">
                 <a16:creationId xmlns:a16="http://schemas.microsoft.com/office/drawing/2014/main" id="{E43735A6-6302-B3D2-6BB7-6309454C5C3A}"/>
@@ -11157,7 +11157,7 @@
       </p:sp>
       <p:sp>
         <p:nvSpPr>
-          <p:cNvPr id="4" name="Espace réservé du contenu 3">
+          <p:cNvPr id="4" name="slot.body-left">
             <a:extLst>
               <a:ext uri="{FF2B5EF4-FFF2-40B4-BE49-F238E27FC236}">
                 <a16:creationId xmlns:a16="http://schemas.microsoft.com/office/drawing/2014/main" id="{2D3E2C40-4C7F-6E36-C2FB-962C73150210}"/>
@@ -11270,7 +11270,7 @@
       </p:sp>
       <p:sp>
         <p:nvSpPr>
-          <p:cNvPr id="5" name="Espace réservé du texte 4">
+          <p:cNvPr id="5" name="slot.subtitle-left">
             <a:extLst>
               <a:ext uri="{FF2B5EF4-FFF2-40B4-BE49-F238E27FC236}">
                 <a16:creationId xmlns:a16="http://schemas.microsoft.com/office/drawing/2014/main" id="{2D35804D-7044-B129-7E2C-ED3868BD4F80}"/>
@@ -11361,7 +11361,7 @@
       </p:sp>
       <p:sp>
         <p:nvSpPr>
-          <p:cNvPr id="6" name="Espace réservé du contenu 5">
+          <p:cNvPr id="6" name="slot.body-right">
             <a:extLst>
               <a:ext uri="{FF2B5EF4-FFF2-40B4-BE49-F238E27FC236}">
                 <a16:creationId xmlns:a16="http://schemas.microsoft.com/office/drawing/2014/main" id="{C56BF488-D9DF-64BA-30D9-77D4A3CB1561}"/>
@@ -11995,7 +11995,7 @@
       </p:sp>
       <p:sp>
         <p:nvSpPr>
-          <p:cNvPr id="2" name="Titre 1">
+          <p:cNvPr id="2" name="slot.title">
             <a:extLst>
               <a:ext uri="{FF2B5EF4-FFF2-40B4-BE49-F238E27FC236}">
                 <a16:creationId xmlns:a16="http://schemas.microsoft.com/office/drawing/2014/main" id="{02A78A85-561E-020D-C7F8-40BBB3F191CA}"/>
@@ -12037,7 +12037,7 @@
       </p:sp>
       <p:sp>
         <p:nvSpPr>
-          <p:cNvPr id="3" name="Espace réservé du texte 2">
+          <p:cNvPr id="3" name="slot.subtitle-left">
             <a:extLst>
               <a:ext uri="{FF2B5EF4-FFF2-40B4-BE49-F238E27FC236}">
                 <a16:creationId xmlns:a16="http://schemas.microsoft.com/office/drawing/2014/main" id="{E43735A6-6302-B3D2-6BB7-6309454C5C3A}"/>
@@ -12131,7 +12131,7 @@
       </p:sp>
       <p:sp>
         <p:nvSpPr>
-          <p:cNvPr id="4" name="Espace réservé du contenu 3">
+          <p:cNvPr id="4" name="slot.body-left">
             <a:extLst>
               <a:ext uri="{FF2B5EF4-FFF2-40B4-BE49-F238E27FC236}">
                 <a16:creationId xmlns:a16="http://schemas.microsoft.com/office/drawing/2014/main" id="{2D3E2C40-4C7F-6E36-C2FB-962C73150210}"/>
@@ -12244,7 +12244,7 @@
       </p:sp>
       <p:sp>
         <p:nvSpPr>
-          <p:cNvPr id="5" name="Espace réservé du texte 4">
+          <p:cNvPr id="5" name="slot.subtitle-left">
             <a:extLst>
               <a:ext uri="{FF2B5EF4-FFF2-40B4-BE49-F238E27FC236}">
                 <a16:creationId xmlns:a16="http://schemas.microsoft.com/office/drawing/2014/main" id="{2D35804D-7044-B129-7E2C-ED3868BD4F80}"/>
@@ -12335,7 +12335,7 @@
       </p:sp>
       <p:sp>
         <p:nvSpPr>
-          <p:cNvPr id="6" name="Espace réservé du contenu 5">
+          <p:cNvPr id="6" name="slot.body-right">
             <a:extLst>
               <a:ext uri="{FF2B5EF4-FFF2-40B4-BE49-F238E27FC236}">
                 <a16:creationId xmlns:a16="http://schemas.microsoft.com/office/drawing/2014/main" id="{C56BF488-D9DF-64BA-30D9-77D4A3CB1561}"/>
@@ -12923,7 +12923,7 @@
       </p:graphicFrame>
       <p:sp>
         <p:nvSpPr>
-          <p:cNvPr id="2" name="Titre 1">
+          <p:cNvPr id="2" name="slot.title">
             <a:extLst>
               <a:ext uri="{FF2B5EF4-FFF2-40B4-BE49-F238E27FC236}">
                 <a16:creationId xmlns:a16="http://schemas.microsoft.com/office/drawing/2014/main" id="{8E7A6757-C645-3EC5-79F9-70135F48F1F5}"/>
@@ -12993,7 +12993,7 @@
       </p:cxnSp>
       <p:sp>
         <p:nvSpPr>
-          <p:cNvPr id="16" name="Espace réservé du contenu 6">
+          <p:cNvPr id="16" name="slot.source">
             <a:extLst>
               <a:ext uri="{FF2B5EF4-FFF2-40B4-BE49-F238E27FC236}">
                 <a16:creationId xmlns:a16="http://schemas.microsoft.com/office/drawing/2014/main" id="{1EAE700C-AA3D-B07B-6407-A28618C99CA3}"/>
@@ -13060,7 +13060,7 @@
       </p:sp>
       <p:sp>
         <p:nvSpPr>
-          <p:cNvPr id="17" name="Espace réservé du numéro de diapositive 5">
+          <p:cNvPr id="17" name="slot.footer-page">
             <a:extLst>
               <a:ext uri="{FF2B5EF4-FFF2-40B4-BE49-F238E27FC236}">
                 <a16:creationId xmlns:a16="http://schemas.microsoft.com/office/drawing/2014/main" id="{30471A69-7D18-731A-528E-0F5C73D3278C}"/>
@@ -13379,7 +13379,7 @@
       </p:sp>
       <p:sp>
         <p:nvSpPr>
-          <p:cNvPr id="2" name="Titre 1">
+          <p:cNvPr id="2" name="slot.title">
             <a:extLst>
               <a:ext uri="{FF2B5EF4-FFF2-40B4-BE49-F238E27FC236}">
                 <a16:creationId xmlns:a16="http://schemas.microsoft.com/office/drawing/2014/main" id="{02A78A85-561E-020D-C7F8-40BBB3F191CA}"/>
@@ -13421,7 +13421,7 @@
       </p:sp>
       <p:sp>
         <p:nvSpPr>
-          <p:cNvPr id="3" name="Espace réservé du texte 2">
+          <p:cNvPr id="3" name="slot.subtitle-1">
             <a:extLst>
               <a:ext uri="{FF2B5EF4-FFF2-40B4-BE49-F238E27FC236}">
                 <a16:creationId xmlns:a16="http://schemas.microsoft.com/office/drawing/2014/main" id="{E43735A6-6302-B3D2-6BB7-6309454C5C3A}"/>
@@ -13762,7 +13762,7 @@
       </p:cxnSp>
       <p:sp>
         <p:nvSpPr>
-          <p:cNvPr id="7" name="Espace réservé du numéro de diapositive 5">
+          <p:cNvPr id="7" name="slot.footer-page">
             <a:extLst>
               <a:ext uri="{FF2B5EF4-FFF2-40B4-BE49-F238E27FC236}">
                 <a16:creationId xmlns:a16="http://schemas.microsoft.com/office/drawing/2014/main" id="{1A58D0F3-933B-44A0-AA4E-059DFC9A693F}"/>
@@ -13805,7 +13805,7 @@
       </p:sp>
       <p:sp>
         <p:nvSpPr>
-          <p:cNvPr id="16" name="Espace réservé du contenu 6">
+          <p:cNvPr id="16" name="slot.source">
             <a:extLst>
               <a:ext uri="{FF2B5EF4-FFF2-40B4-BE49-F238E27FC236}">
                 <a16:creationId xmlns:a16="http://schemas.microsoft.com/office/drawing/2014/main" id="{90BAEBC7-9C13-C823-651C-6CF5BCB1CA2C}"/>
@@ -14155,7 +14155,7 @@
       </p:sp>
       <p:sp>
         <p:nvSpPr>
-          <p:cNvPr id="15" name="Titre 1">
+          <p:cNvPr id="15" name="slot.title">
             <a:extLst>
               <a:ext uri="{FF2B5EF4-FFF2-40B4-BE49-F238E27FC236}">
                 <a16:creationId xmlns:a16="http://schemas.microsoft.com/office/drawing/2014/main" id="{011ADB7C-2BFE-5201-7E80-4A7CB5B2A9D7}"/>
@@ -14197,7 +14197,7 @@
       </p:sp>
       <p:sp>
         <p:nvSpPr>
-          <p:cNvPr id="16" name="Espace réservé du texte 2">
+          <p:cNvPr id="16" name="slot.subtitle-1">
             <a:extLst>
               <a:ext uri="{FF2B5EF4-FFF2-40B4-BE49-F238E27FC236}">
                 <a16:creationId xmlns:a16="http://schemas.microsoft.com/office/drawing/2014/main" id="{A6C2B456-2FBB-0CCF-35AD-10F95452A42E}"/>
@@ -14538,7 +14538,7 @@
       </p:cxnSp>
       <p:sp>
         <p:nvSpPr>
-          <p:cNvPr id="25" name="Espace réservé du numéro de diapositive 5">
+          <p:cNvPr id="25" name="slot.footer-page">
             <a:extLst>
               <a:ext uri="{FF2B5EF4-FFF2-40B4-BE49-F238E27FC236}">
                 <a16:creationId xmlns:a16="http://schemas.microsoft.com/office/drawing/2014/main" id="{E7E2C119-EF2B-38F6-0525-06C871F99DB2}"/>
@@ -14581,7 +14581,7 @@
       </p:sp>
       <p:sp>
         <p:nvSpPr>
-          <p:cNvPr id="27" name="Espace réservé du contenu 6">
+          <p:cNvPr id="27" name="slot.source">
             <a:extLst>
               <a:ext uri="{FF2B5EF4-FFF2-40B4-BE49-F238E27FC236}">
                 <a16:creationId xmlns:a16="http://schemas.microsoft.com/office/drawing/2014/main" id="{86608BDE-897C-79A9-D915-0BB179DBABCE}"/>
@@ -15150,7 +15150,7 @@
       </p:graphicFrame>
       <p:sp>
         <p:nvSpPr>
-          <p:cNvPr id="2" name="Titre 1">
+          <p:cNvPr id="2" name="slot.title">
             <a:extLst>
               <a:ext uri="{FF2B5EF4-FFF2-40B4-BE49-F238E27FC236}">
                 <a16:creationId xmlns:a16="http://schemas.microsoft.com/office/drawing/2014/main" id="{FCE45F8B-6B35-4416-DE1A-36DAC87E84D7}"/>
@@ -15184,7 +15184,7 @@
       </p:sp>
       <p:sp>
         <p:nvSpPr>
-          <p:cNvPr id="3" name="Espace réservé du contenu 2">
+          <p:cNvPr id="3" name="slot.body-left">
             <a:extLst>
               <a:ext uri="{FF2B5EF4-FFF2-40B4-BE49-F238E27FC236}">
                 <a16:creationId xmlns:a16="http://schemas.microsoft.com/office/drawing/2014/main" id="{DD259420-A1F5-B3E7-FA1E-AF141FA30A75}"/>
@@ -15247,7 +15247,7 @@
       </p:sp>
       <p:sp>
         <p:nvSpPr>
-          <p:cNvPr id="4" name="Sous-titre 2">
+          <p:cNvPr id="4" name="slot.subtitle">
             <a:extLst>
               <a:ext uri="{FF2B5EF4-FFF2-40B4-BE49-F238E27FC236}">
                 <a16:creationId xmlns:a16="http://schemas.microsoft.com/office/drawing/2014/main" id="{0BD151FF-774C-0F45-1C17-D35CEB240F37}"/>
@@ -15366,7 +15366,7 @@
       </p:cxnSp>
       <p:sp>
         <p:nvSpPr>
-          <p:cNvPr id="7" name="Espace réservé du numéro de diapositive 5">
+          <p:cNvPr id="7" name="slot.footer-page">
             <a:extLst>
               <a:ext uri="{FF2B5EF4-FFF2-40B4-BE49-F238E27FC236}">
                 <a16:creationId xmlns:a16="http://schemas.microsoft.com/office/drawing/2014/main" id="{E93BE603-3A6B-82E8-B096-333EF0F29FF1}"/>
@@ -15400,7 +15400,7 @@
       </p:sp>
       <p:sp>
         <p:nvSpPr>
-          <p:cNvPr id="16" name="Espace réservé du contenu 6">
+          <p:cNvPr id="16" name="slot.source">
             <a:extLst>
               <a:ext uri="{FF2B5EF4-FFF2-40B4-BE49-F238E27FC236}">
                 <a16:creationId xmlns:a16="http://schemas.microsoft.com/office/drawing/2014/main" id="{30FB613D-2E4E-C892-5E41-010F534973BA}"/>
@@ -15703,7 +15703,7 @@
       </p:graphicFrame>
       <p:sp>
         <p:nvSpPr>
-          <p:cNvPr id="2" name="Titre 1">
+          <p:cNvPr id="2" name="slot.title">
             <a:extLst>
               <a:ext uri="{FF2B5EF4-FFF2-40B4-BE49-F238E27FC236}">
                 <a16:creationId xmlns:a16="http://schemas.microsoft.com/office/drawing/2014/main" id="{2177F37C-BE34-28C6-E3CA-11B0B3A1A2C2}"/>
@@ -15732,7 +15732,7 @@
       </p:sp>
       <p:sp>
         <p:nvSpPr>
-          <p:cNvPr id="3" name="Espace réservé du contenu 2">
+          <p:cNvPr id="3" name="slot.body-left">
             <a:extLst>
               <a:ext uri="{FF2B5EF4-FFF2-40B4-BE49-F238E27FC236}">
                 <a16:creationId xmlns:a16="http://schemas.microsoft.com/office/drawing/2014/main" id="{1F024AAB-E748-56F5-69CF-8D668412B46A}"/>
@@ -15831,7 +15831,7 @@
       </p:sp>
       <p:sp>
         <p:nvSpPr>
-          <p:cNvPr id="4" name="Espace réservé du contenu 3">
+          <p:cNvPr id="4" name="slot.body-left">
             <a:extLst>
               <a:ext uri="{FF2B5EF4-FFF2-40B4-BE49-F238E27FC236}">
                 <a16:creationId xmlns:a16="http://schemas.microsoft.com/office/drawing/2014/main" id="{8EB565A4-3D20-0C08-E4EA-AB81725F7D5D}"/>
@@ -15978,7 +15978,7 @@
       </p:cxnSp>
       <p:sp>
         <p:nvSpPr>
-          <p:cNvPr id="11" name="Espace réservé du numéro de diapositive 5">
+          <p:cNvPr id="11" name="slot.footer-page">
             <a:extLst>
               <a:ext uri="{FF2B5EF4-FFF2-40B4-BE49-F238E27FC236}">
                 <a16:creationId xmlns:a16="http://schemas.microsoft.com/office/drawing/2014/main" id="{1382F4B7-187B-8A42-30AA-40FBAC1ED43E}"/>
@@ -16012,7 +16012,7 @@
       </p:sp>
       <p:sp>
         <p:nvSpPr>
-          <p:cNvPr id="18" name="Espace réservé du contenu 6">
+          <p:cNvPr id="18" name="slot.body-left">
             <a:extLst>
               <a:ext uri="{FF2B5EF4-FFF2-40B4-BE49-F238E27FC236}">
                 <a16:creationId xmlns:a16="http://schemas.microsoft.com/office/drawing/2014/main" id="{134DD0FE-B05A-6304-7865-C88149104BD6}"/>
@@ -16315,7 +16315,7 @@
       </p:graphicFrame>
       <p:sp>
         <p:nvSpPr>
-          <p:cNvPr id="2" name="Titre 1">
+          <p:cNvPr id="2" name="slot.title">
             <a:extLst>
               <a:ext uri="{FF2B5EF4-FFF2-40B4-BE49-F238E27FC236}">
                 <a16:creationId xmlns:a16="http://schemas.microsoft.com/office/drawing/2014/main" id="{02A78A85-561E-020D-C7F8-40BBB3F191CA}"/>
@@ -16349,7 +16349,7 @@
       </p:sp>
       <p:sp>
         <p:nvSpPr>
-          <p:cNvPr id="3" name="Espace réservé du texte 2">
+          <p:cNvPr id="3" name="slot.subtitle-left">
             <a:extLst>
               <a:ext uri="{FF2B5EF4-FFF2-40B4-BE49-F238E27FC236}">
                 <a16:creationId xmlns:a16="http://schemas.microsoft.com/office/drawing/2014/main" id="{E43735A6-6302-B3D2-6BB7-6309454C5C3A}"/>
@@ -16427,7 +16427,7 @@
       </p:sp>
       <p:sp>
         <p:nvSpPr>
-          <p:cNvPr id="4" name="Espace réservé du contenu 3">
+          <p:cNvPr id="4" name="slot.body-left">
             <a:extLst>
               <a:ext uri="{FF2B5EF4-FFF2-40B4-BE49-F238E27FC236}">
                 <a16:creationId xmlns:a16="http://schemas.microsoft.com/office/drawing/2014/main" id="{2D3E2C40-4C7F-6E36-C2FB-962C73150210}"/>
@@ -16490,7 +16490,7 @@
       </p:sp>
       <p:sp>
         <p:nvSpPr>
-          <p:cNvPr id="5" name="Espace réservé du texte 4">
+          <p:cNvPr id="5" name="slot.subtitle-left">
             <a:extLst>
               <a:ext uri="{FF2B5EF4-FFF2-40B4-BE49-F238E27FC236}">
                 <a16:creationId xmlns:a16="http://schemas.microsoft.com/office/drawing/2014/main" id="{2D35804D-7044-B129-7E2C-ED3868BD4F80}"/>
@@ -16568,7 +16568,7 @@
       </p:sp>
       <p:sp>
         <p:nvSpPr>
-          <p:cNvPr id="6" name="Espace réservé du contenu 5">
+          <p:cNvPr id="6" name="slot.body-right">
             <a:extLst>
               <a:ext uri="{FF2B5EF4-FFF2-40B4-BE49-F238E27FC236}">
                 <a16:creationId xmlns:a16="http://schemas.microsoft.com/office/drawing/2014/main" id="{C56BF488-D9DF-64BA-30D9-77D4A3CB1561}"/>
@@ -17052,7 +17052,7 @@
       </p:graphicFrame>
       <p:sp>
         <p:nvSpPr>
-          <p:cNvPr id="2" name="Titre 1">
+          <p:cNvPr id="2" name="slot.title">
             <a:extLst>
               <a:ext uri="{FF2B5EF4-FFF2-40B4-BE49-F238E27FC236}">
                 <a16:creationId xmlns:a16="http://schemas.microsoft.com/office/drawing/2014/main" id="{02A78A85-561E-020D-C7F8-40BBB3F191CA}"/>
@@ -17086,7 +17086,7 @@
       </p:sp>
       <p:sp>
         <p:nvSpPr>
-          <p:cNvPr id="3" name="Espace réservé du texte 2">
+          <p:cNvPr id="3" name="slot.subtitle-left">
             <a:extLst>
               <a:ext uri="{FF2B5EF4-FFF2-40B4-BE49-F238E27FC236}">
                 <a16:creationId xmlns:a16="http://schemas.microsoft.com/office/drawing/2014/main" id="{E43735A6-6302-B3D2-6BB7-6309454C5C3A}"/>
@@ -17164,7 +17164,7 @@
       </p:sp>
       <p:sp>
         <p:nvSpPr>
-          <p:cNvPr id="4" name="Espace réservé du contenu 3">
+          <p:cNvPr id="4" name="slot.body-left">
             <a:extLst>
               <a:ext uri="{FF2B5EF4-FFF2-40B4-BE49-F238E27FC236}">
                 <a16:creationId xmlns:a16="http://schemas.microsoft.com/office/drawing/2014/main" id="{2D3E2C40-4C7F-6E36-C2FB-962C73150210}"/>
@@ -17227,7 +17227,7 @@
       </p:sp>
       <p:sp>
         <p:nvSpPr>
-          <p:cNvPr id="5" name="Espace réservé du texte 4">
+          <p:cNvPr id="5" name="slot.subtitle-left">
             <a:extLst>
               <a:ext uri="{FF2B5EF4-FFF2-40B4-BE49-F238E27FC236}">
                 <a16:creationId xmlns:a16="http://schemas.microsoft.com/office/drawing/2014/main" id="{2D35804D-7044-B129-7E2C-ED3868BD4F80}"/>
@@ -17305,7 +17305,7 @@
       </p:sp>
       <p:sp>
         <p:nvSpPr>
-          <p:cNvPr id="6" name="Espace réservé du contenu 5">
+          <p:cNvPr id="6" name="slot.body-right">
             <a:extLst>
               <a:ext uri="{FF2B5EF4-FFF2-40B4-BE49-F238E27FC236}">
                 <a16:creationId xmlns:a16="http://schemas.microsoft.com/office/drawing/2014/main" id="{C56BF488-D9DF-64BA-30D9-77D4A3CB1561}"/>
@@ -17368,7 +17368,7 @@
       </p:sp>
       <p:sp>
         <p:nvSpPr>
-          <p:cNvPr id="7" name="Espace réservé du texte 2">
+          <p:cNvPr id="7" name="slot.subtitle-left">
             <a:extLst>
               <a:ext uri="{FF2B5EF4-FFF2-40B4-BE49-F238E27FC236}">
                 <a16:creationId xmlns:a16="http://schemas.microsoft.com/office/drawing/2014/main" id="{5E8252F0-DE57-E2EB-BE2E-BAD06505AF77}"/>
@@ -17446,7 +17446,7 @@
       </p:sp>
       <p:sp>
         <p:nvSpPr>
-          <p:cNvPr id="11" name="Espace réservé du contenu 3">
+          <p:cNvPr id="11" name="slot.body-left">
             <a:extLst>
               <a:ext uri="{FF2B5EF4-FFF2-40B4-BE49-F238E27FC236}">
                 <a16:creationId xmlns:a16="http://schemas.microsoft.com/office/drawing/2014/main" id="{AF4E5750-BDEC-4328-0B8F-9525E2496CFD}"/>
@@ -17990,7 +17990,7 @@
       </p:graphicFrame>
       <p:sp>
         <p:nvSpPr>
-          <p:cNvPr id="3" name="Espace réservé du numéro de diapositive 5">
+          <p:cNvPr id="3" name="slot.footer-page">
             <a:extLst>
               <a:ext uri="{FF2B5EF4-FFF2-40B4-BE49-F238E27FC236}">
                 <a16:creationId xmlns:a16="http://schemas.microsoft.com/office/drawing/2014/main" id="{AC98BCD7-B4BD-45F0-A1DC-E597AD321024}"/>
@@ -18024,7 +18024,7 @@
       </p:sp>
       <p:sp>
         <p:nvSpPr>
-          <p:cNvPr id="10" name="Espace réservé du contenu 6">
+          <p:cNvPr id="10" name="slot.source">
             <a:extLst>
               <a:ext uri="{FF2B5EF4-FFF2-40B4-BE49-F238E27FC236}">
                 <a16:creationId xmlns:a16="http://schemas.microsoft.com/office/drawing/2014/main" id="{DE645C6A-CC14-E4D3-22C9-E154707F3FF7}"/>
@@ -18384,7 +18384,7 @@
       </p:sp>
       <p:sp>
         <p:nvSpPr>
-          <p:cNvPr id="5" name="Titre 1">
+          <p:cNvPr id="5" name="slot.title">
             <a:extLst>
               <a:ext uri="{FF2B5EF4-FFF2-40B4-BE49-F238E27FC236}">
                 <a16:creationId xmlns:a16="http://schemas.microsoft.com/office/drawing/2014/main" id="{3A8C9D35-E503-FE8C-69EA-8B619E0CB8DB}"/>
@@ -18428,7 +18428,7 @@
       </p:sp>
       <p:sp>
         <p:nvSpPr>
-          <p:cNvPr id="7" name="Sous-titre 2">
+          <p:cNvPr id="7" name="slot.subtitle">
             <a:extLst>
               <a:ext uri="{FF2B5EF4-FFF2-40B4-BE49-F238E27FC236}">
                 <a16:creationId xmlns:a16="http://schemas.microsoft.com/office/drawing/2014/main" id="{C9E991B4-3678-BE6E-9D33-B6480825BFEA}"/>
@@ -18952,7 +18952,7 @@
       </p:pic>
       <p:sp>
         <p:nvSpPr>
-          <p:cNvPr id="2" name="Titre 1">
+          <p:cNvPr id="2" name="slot.section-title">
             <a:extLst>
               <a:ext uri="{FF2B5EF4-FFF2-40B4-BE49-F238E27FC236}">
                 <a16:creationId xmlns:a16="http://schemas.microsoft.com/office/drawing/2014/main" id="{1FAAFAE6-D60C-93B1-4819-060D20F8BFF4}"/>
@@ -18996,7 +18996,7 @@
       </p:sp>
       <p:sp>
         <p:nvSpPr>
-          <p:cNvPr id="3" name="Sous-titre 2">
+          <p:cNvPr id="3" name="slot.subtitle">
             <a:extLst>
               <a:ext uri="{FF2B5EF4-FFF2-40B4-BE49-F238E27FC236}">
                 <a16:creationId xmlns:a16="http://schemas.microsoft.com/office/drawing/2014/main" id="{B989298A-8D13-336B-A448-1CB247CE6E4F}"/>
@@ -20959,7 +20959,7 @@
       </p:sp>
       <p:sp>
         <p:nvSpPr>
-          <p:cNvPr id="7" name="Espace réservé du numéro de diapositive 6">
+          <p:cNvPr id="7" name="slot.footer-page">
             <a:extLst>
               <a:ext uri="{FF2B5EF4-FFF2-40B4-BE49-F238E27FC236}">
                 <a16:creationId xmlns:a16="http://schemas.microsoft.com/office/drawing/2014/main" id="{AD7EC4A8-8CF5-8C79-BAB5-0AA6E55EAE76}"/>
@@ -20988,7 +20988,7 @@
       </p:sp>
       <p:sp>
         <p:nvSpPr>
-          <p:cNvPr id="8" name="Espace réservé du contenu 7">
+          <p:cNvPr id="8" name="slot.source">
             <a:extLst>
               <a:ext uri="{FF2B5EF4-FFF2-40B4-BE49-F238E27FC236}">
                 <a16:creationId xmlns:a16="http://schemas.microsoft.com/office/drawing/2014/main" id="{78FA1B2A-92F7-40FB-F965-CA4A4804D578}"/>
@@ -21168,7 +21168,7 @@
       </p:sp>
       <p:sp>
         <p:nvSpPr>
-          <p:cNvPr id="7" name="Espace réservé du numéro de diapositive 6">
+          <p:cNvPr id="7" name="slot.footer-page">
             <a:extLst>
               <a:ext uri="{FF2B5EF4-FFF2-40B4-BE49-F238E27FC236}">
                 <a16:creationId xmlns:a16="http://schemas.microsoft.com/office/drawing/2014/main" id="{244EFA7C-21AE-6C7D-FAC2-7D19DE421203}"/>
@@ -21197,7 +21197,7 @@
       </p:sp>
       <p:sp>
         <p:nvSpPr>
-          <p:cNvPr id="8" name="Espace réservé du contenu 7">
+          <p:cNvPr id="8" name="slot.source">
             <a:extLst>
               <a:ext uri="{FF2B5EF4-FFF2-40B4-BE49-F238E27FC236}">
                 <a16:creationId xmlns:a16="http://schemas.microsoft.com/office/drawing/2014/main" id="{B421CB7E-7CF9-8773-A8E0-CBC5497D8F78}"/>
@@ -21302,7 +21302,7 @@
       </p:sp>
       <p:sp>
         <p:nvSpPr>
-          <p:cNvPr id="4" name="Espace réservé du texte 3">
+          <p:cNvPr id="4" name="slot.subtitle-2">
             <a:extLst>
               <a:ext uri="{FF2B5EF4-FFF2-40B4-BE49-F238E27FC236}">
                 <a16:creationId xmlns:a16="http://schemas.microsoft.com/office/drawing/2014/main" id="{4358881E-4F55-3D28-CF02-3F4E9115E333}"/>
@@ -21327,7 +21327,7 @@
       </p:sp>
       <p:sp>
         <p:nvSpPr>
-          <p:cNvPr id="5" name="Espace réservé du contenu 4">
+          <p:cNvPr id="5" name="slot.body">
             <a:extLst>
               <a:ext uri="{FF2B5EF4-FFF2-40B4-BE49-F238E27FC236}">
                 <a16:creationId xmlns:a16="http://schemas.microsoft.com/office/drawing/2014/main" id="{8705FAFD-60FB-F8C7-491E-8FB862F9C8A6}"/>
@@ -21611,7 +21611,7 @@
       </p:sp>
       <p:sp>
         <p:nvSpPr>
-          <p:cNvPr id="9" name="Espace réservé du numéro de diapositive 8">
+          <p:cNvPr id="9" name="slot.footer-page">
             <a:extLst>
               <a:ext uri="{FF2B5EF4-FFF2-40B4-BE49-F238E27FC236}">
                 <a16:creationId xmlns:a16="http://schemas.microsoft.com/office/drawing/2014/main" id="{56BA1548-2B85-A72F-BEF1-2AF72880F211}"/>
@@ -21640,7 +21640,7 @@
       </p:sp>
       <p:sp>
         <p:nvSpPr>
-          <p:cNvPr id="10" name="Espace réservé du contenu 9">
+          <p:cNvPr id="10" name="slot.source">
             <a:extLst>
               <a:ext uri="{FF2B5EF4-FFF2-40B4-BE49-F238E27FC236}">
                 <a16:creationId xmlns:a16="http://schemas.microsoft.com/office/drawing/2014/main" id="{94A0CC14-B06D-8574-9642-42CAE0EDB56C}"/>
@@ -21930,7 +21930,7 @@
       </p:sp>
       <p:sp>
         <p:nvSpPr>
-          <p:cNvPr id="7" name="Espace réservé du numéro de diapositive 6">
+          <p:cNvPr id="7" name="slot.footer-page">
             <a:extLst>
               <a:ext uri="{FF2B5EF4-FFF2-40B4-BE49-F238E27FC236}">
                 <a16:creationId xmlns:a16="http://schemas.microsoft.com/office/drawing/2014/main" id="{85C13A4A-3651-3F41-649E-1290DB09A996}"/>
@@ -21959,7 +21959,7 @@
       </p:sp>
       <p:sp>
         <p:nvSpPr>
-          <p:cNvPr id="8" name="Espace réservé du contenu 7">
+          <p:cNvPr id="8" name="slot.source">
             <a:extLst>
               <a:ext uri="{FF2B5EF4-FFF2-40B4-BE49-F238E27FC236}">
                 <a16:creationId xmlns:a16="http://schemas.microsoft.com/office/drawing/2014/main" id="{DBFFDC8F-D14C-28D8-B388-6724C21B4BA1}"/>
@@ -22547,7 +22547,7 @@
       </p:sp>
       <p:sp>
         <p:nvSpPr>
-          <p:cNvPr id="4" name="Espace réservé du texte 3">
+          <p:cNvPr id="4" name="slot.subtitle-2">
             <a:extLst>
               <a:ext uri="{FF2B5EF4-FFF2-40B4-BE49-F238E27FC236}">
                 <a16:creationId xmlns:a16="http://schemas.microsoft.com/office/drawing/2014/main" id="{FE9D7C8C-FA55-7BC1-9885-70240B5F619E}"/>
@@ -22572,7 +22572,7 @@
       </p:sp>
       <p:sp>
         <p:nvSpPr>
-          <p:cNvPr id="5" name="Espace réservé du contenu 4">
+          <p:cNvPr id="5" name="slot.body">
             <a:extLst>
               <a:ext uri="{FF2B5EF4-FFF2-40B4-BE49-F238E27FC236}">
                 <a16:creationId xmlns:a16="http://schemas.microsoft.com/office/drawing/2014/main" id="{F04F6FA0-64EA-A96F-77DB-DC9007910239}"/>
@@ -22806,7 +22806,7 @@
       </p:sp>
       <p:sp>
         <p:nvSpPr>
-          <p:cNvPr id="7" name="Espace réservé du numéro de diapositive 6">
+          <p:cNvPr id="7" name="slot.footer-page">
             <a:extLst>
               <a:ext uri="{FF2B5EF4-FFF2-40B4-BE49-F238E27FC236}">
                 <a16:creationId xmlns:a16="http://schemas.microsoft.com/office/drawing/2014/main" id="{3F8D98DD-0E84-F6F8-641C-DE30A625FDBA}"/>
@@ -22836,7 +22836,7 @@
       </p:sp>
       <p:sp>
         <p:nvSpPr>
-          <p:cNvPr id="8" name="Espace réservé du contenu 7">
+          <p:cNvPr id="8" name="slot.source">
             <a:extLst>
               <a:ext uri="{FF2B5EF4-FFF2-40B4-BE49-F238E27FC236}">
                 <a16:creationId xmlns:a16="http://schemas.microsoft.com/office/drawing/2014/main" id="{B74E6D85-D63B-5397-6C95-9A1C410A807A}"/>
@@ -23016,7 +23016,7 @@
       </p:sp>
       <p:sp>
         <p:nvSpPr>
-          <p:cNvPr id="7" name="Espace réservé du numéro de diapositive 6">
+          <p:cNvPr id="7" name="slot.footer-page">
             <a:extLst>
               <a:ext uri="{FF2B5EF4-FFF2-40B4-BE49-F238E27FC236}">
                 <a16:creationId xmlns:a16="http://schemas.microsoft.com/office/drawing/2014/main" id="{C737C2DD-0597-C781-B47B-9ED87A6858D2}"/>
@@ -23046,7 +23046,7 @@
       </p:sp>
       <p:sp>
         <p:nvSpPr>
-          <p:cNvPr id="8" name="Espace réservé du contenu 7">
+          <p:cNvPr id="8" name="slot.source">
             <a:extLst>
               <a:ext uri="{FF2B5EF4-FFF2-40B4-BE49-F238E27FC236}">
                 <a16:creationId xmlns:a16="http://schemas.microsoft.com/office/drawing/2014/main" id="{E45008B4-06ED-42AB-99A0-FF2AA10C8FC1}"/>
@@ -23151,7 +23151,7 @@
       </p:sp>
       <p:sp>
         <p:nvSpPr>
-          <p:cNvPr id="4" name="Espace réservé du texte 3">
+          <p:cNvPr id="4" name="slot.subtitle-2">
             <a:extLst>
               <a:ext uri="{FF2B5EF4-FFF2-40B4-BE49-F238E27FC236}">
                 <a16:creationId xmlns:a16="http://schemas.microsoft.com/office/drawing/2014/main" id="{103ADEE2-BB69-96C8-ECF0-FBB50E9BFEA1}"/>
@@ -23176,7 +23176,7 @@
       </p:sp>
       <p:sp>
         <p:nvSpPr>
-          <p:cNvPr id="5" name="Espace réservé du contenu 4">
+          <p:cNvPr id="5" name="slot.body">
             <a:extLst>
               <a:ext uri="{FF2B5EF4-FFF2-40B4-BE49-F238E27FC236}">
                 <a16:creationId xmlns:a16="http://schemas.microsoft.com/office/drawing/2014/main" id="{491EAC36-2BCB-A68E-5176-6D64BE2064F7}"/>
@@ -23336,7 +23336,7 @@
       </p:sp>
       <p:sp>
         <p:nvSpPr>
-          <p:cNvPr id="4" name="Espace réservé du texte 3">
+          <p:cNvPr id="4" name="slot.subtitle-2">
             <a:extLst>
               <a:ext uri="{FF2B5EF4-FFF2-40B4-BE49-F238E27FC236}">
                 <a16:creationId xmlns:a16="http://schemas.microsoft.com/office/drawing/2014/main" id="{F6D383B4-B0C9-D409-F9B1-C9DF0C4ED39B}"/>
@@ -23361,7 +23361,7 @@
       </p:sp>
       <p:sp>
         <p:nvSpPr>
-          <p:cNvPr id="5" name="Espace réservé du contenu 4">
+          <p:cNvPr id="5" name="slot.body">
             <a:extLst>
               <a:ext uri="{FF2B5EF4-FFF2-40B4-BE49-F238E27FC236}">
                 <a16:creationId xmlns:a16="http://schemas.microsoft.com/office/drawing/2014/main" id="{8682BE46-4ADD-712E-693C-56A5CC4DE5D0}"/>
@@ -23948,246 +23948,6 @@
           <a:lstStyle/>
           <a:p>
             <a:endParaRPr lang="fr-FR"/>
-          </a:p>
-        </p:txBody>
-      </p:sp>
-      <p:sp>
-        <p:nvSpPr>
-          <p:cNvPr id="2" name="Espace réservé du contenu 5">
-            <a:extLst>
-              <a:ext uri="{FF2B5EF4-FFF2-40B4-BE49-F238E27FC236}">
-                <a16:creationId xmlns:a16="http://schemas.microsoft.com/office/drawing/2014/main" id="{1CDF13B5-C492-7E19-E47D-AF5DEC25A9CD}"/>
-              </a:ext>
-            </a:extLst>
-          </p:cNvPr>
-          <p:cNvSpPr txBox="1">
-            <a:spLocks/>
-          </p:cNvSpPr>
-          <p:nvPr/>
-        </p:nvSpPr>
-        <p:spPr>
-          <a:xfrm>
-            <a:off x="1947271" y="2356821"/>
-            <a:ext cx="11090275" cy="4723984"/>
-          </a:xfrm>
-          <a:prstGeom prst="rect">
-            <a:avLst/>
-          </a:prstGeom>
-        </p:spPr>
-        <p:txBody>
-          <a:bodyPr vert="horz" lIns="0" tIns="0" rIns="0" bIns="0" rtlCol="0">
-            <a:noAutofit/>
-          </a:bodyPr>
-          <a:lstStyle>
-            <a:lvl1pPr marL="136525" indent="-133350" algn="l" defTabSz="914400" rtl="0" eaLnBrk="1" latinLnBrk="0" hangingPunct="1">
-              <a:lnSpc>
-                <a:spcPct val="100000"/>
-              </a:lnSpc>
-              <a:spcBef>
-                <a:spcPts val="0"/>
-              </a:spcBef>
-              <a:spcAft>
-                <a:spcPts val="200"/>
-              </a:spcAft>
-              <a:buClr>
-                <a:schemeClr val="tx2"/>
-              </a:buClr>
-              <a:buSzPct val="100000"/>
-              <a:buFont typeface="System Font Regular"/>
-              <a:buChar char="•"/>
-              <a:tabLst/>
-              <a:defRPr sz="1200" kern="1200">
-                <a:solidFill>
-                  <a:schemeClr val="tx1"/>
-                </a:solidFill>
-                <a:latin typeface="Arial" panose="020B0604020202020204" pitchFamily="34" charset="0"/>
-                <a:ea typeface="+mn-ea"/>
-                <a:cs typeface="Arial" panose="020B0604020202020204" pitchFamily="34" charset="0"/>
-              </a:defRPr>
-            </a:lvl1pPr>
-            <a:lvl2pPr marL="273050" indent="-136525" algn="l" defTabSz="914400" rtl="0" eaLnBrk="1" latinLnBrk="0" hangingPunct="1">
-              <a:lnSpc>
-                <a:spcPct val="100000"/>
-              </a:lnSpc>
-              <a:spcBef>
-                <a:spcPts val="0"/>
-              </a:spcBef>
-              <a:spcAft>
-                <a:spcPts val="200"/>
-              </a:spcAft>
-              <a:buClr>
-                <a:schemeClr val="tx2"/>
-              </a:buClr>
-              <a:buSzPct val="100000"/>
-              <a:buFont typeface="System Font Regular"/>
-              <a:buChar char="−"/>
-              <a:tabLst/>
-              <a:defRPr sz="1200" kern="1200">
-                <a:solidFill>
-                  <a:schemeClr val="tx1"/>
-                </a:solidFill>
-                <a:latin typeface="Arial" panose="020B0604020202020204" pitchFamily="34" charset="0"/>
-                <a:ea typeface="+mn-ea"/>
-                <a:cs typeface="Arial" panose="020B0604020202020204" pitchFamily="34" charset="0"/>
-              </a:defRPr>
-            </a:lvl2pPr>
-            <a:lvl3pPr marL="401638" indent="-128588" algn="l" defTabSz="914400" rtl="0" eaLnBrk="1" latinLnBrk="0" hangingPunct="1">
-              <a:lnSpc>
-                <a:spcPct val="100000"/>
-              </a:lnSpc>
-              <a:spcBef>
-                <a:spcPts val="0"/>
-              </a:spcBef>
-              <a:spcAft>
-                <a:spcPts val="200"/>
-              </a:spcAft>
-              <a:buClr>
-                <a:schemeClr val="tx2"/>
-              </a:buClr>
-              <a:buSzPct val="100000"/>
-              <a:buFont typeface="System Font Regular"/>
-              <a:buChar char="◦"/>
-              <a:tabLst/>
-              <a:defRPr sz="1200" kern="1200">
-                <a:solidFill>
-                  <a:schemeClr val="tx1"/>
-                </a:solidFill>
-                <a:latin typeface="Arial" panose="020B0604020202020204" pitchFamily="34" charset="0"/>
-                <a:ea typeface="+mn-ea"/>
-                <a:cs typeface="Arial" panose="020B0604020202020204" pitchFamily="34" charset="0"/>
-              </a:defRPr>
-            </a:lvl3pPr>
-            <a:lvl4pPr marL="534988" indent="-133350" algn="l" defTabSz="914400" rtl="0" eaLnBrk="1" latinLnBrk="0" hangingPunct="1">
-              <a:lnSpc>
-                <a:spcPct val="100000"/>
-              </a:lnSpc>
-              <a:spcBef>
-                <a:spcPts val="0"/>
-              </a:spcBef>
-              <a:spcAft>
-                <a:spcPts val="200"/>
-              </a:spcAft>
-              <a:buClr>
-                <a:schemeClr val="tx2"/>
-              </a:buClr>
-              <a:buSzPct val="100000"/>
-              <a:buFont typeface="Wingdings" pitchFamily="2" charset="2"/>
-              <a:buChar char="§"/>
-              <a:tabLst/>
-              <a:defRPr sz="1200" kern="1200">
-                <a:solidFill>
-                  <a:schemeClr val="tx1"/>
-                </a:solidFill>
-                <a:latin typeface="Arial" panose="020B0604020202020204" pitchFamily="34" charset="0"/>
-                <a:ea typeface="+mn-ea"/>
-                <a:cs typeface="Arial" panose="020B0604020202020204" pitchFamily="34" charset="0"/>
-              </a:defRPr>
-            </a:lvl4pPr>
-            <a:lvl5pPr marL="668338" indent="-133350" algn="l" defTabSz="914400" rtl="0" eaLnBrk="1" latinLnBrk="0" hangingPunct="1">
-              <a:lnSpc>
-                <a:spcPct val="100000"/>
-              </a:lnSpc>
-              <a:spcBef>
-                <a:spcPts val="0"/>
-              </a:spcBef>
-              <a:spcAft>
-                <a:spcPts val="200"/>
-              </a:spcAft>
-              <a:buClr>
-                <a:schemeClr val="tx2"/>
-              </a:buClr>
-              <a:buSzPct val="100000"/>
-              <a:buFont typeface="System Font Regular"/>
-              <a:buChar char="▫"/>
-              <a:tabLst/>
-              <a:defRPr sz="1200" kern="1200">
-                <a:solidFill>
-                  <a:schemeClr val="tx1"/>
-                </a:solidFill>
-                <a:latin typeface="Arial" panose="020B0604020202020204" pitchFamily="34" charset="0"/>
-                <a:ea typeface="+mn-ea"/>
-                <a:cs typeface="Arial" panose="020B0604020202020204" pitchFamily="34" charset="0"/>
-              </a:defRPr>
-            </a:lvl5pPr>
-            <a:lvl6pPr marL="2514600" indent="-228600" algn="l" defTabSz="914400" rtl="0" eaLnBrk="1" latinLnBrk="0" hangingPunct="1">
-              <a:lnSpc>
-                <a:spcPct val="90000"/>
-              </a:lnSpc>
-              <a:spcBef>
-                <a:spcPts val="500"/>
-              </a:spcBef>
-              <a:buFont typeface="Arial" panose="020B0604020202020204" pitchFamily="34" charset="0"/>
-              <a:buChar char="•"/>
-              <a:defRPr sz="1800" kern="1200">
-                <a:solidFill>
-                  <a:schemeClr val="tx1"/>
-                </a:solidFill>
-                <a:latin typeface="+mn-lt"/>
-                <a:ea typeface="+mn-ea"/>
-                <a:cs typeface="+mn-cs"/>
-              </a:defRPr>
-            </a:lvl6pPr>
-            <a:lvl7pPr marL="2971800" indent="-228600" algn="l" defTabSz="914400" rtl="0" eaLnBrk="1" latinLnBrk="0" hangingPunct="1">
-              <a:lnSpc>
-                <a:spcPct val="90000"/>
-              </a:lnSpc>
-              <a:spcBef>
-                <a:spcPts val="500"/>
-              </a:spcBef>
-              <a:buFont typeface="Arial" panose="020B0604020202020204" pitchFamily="34" charset="0"/>
-              <a:buChar char="•"/>
-              <a:defRPr sz="1800" kern="1200">
-                <a:solidFill>
-                  <a:schemeClr val="tx1"/>
-                </a:solidFill>
-                <a:latin typeface="+mn-lt"/>
-                <a:ea typeface="+mn-ea"/>
-                <a:cs typeface="+mn-cs"/>
-              </a:defRPr>
-            </a:lvl7pPr>
-            <a:lvl8pPr marL="3429000" indent="-228600" algn="l" defTabSz="914400" rtl="0" eaLnBrk="1" latinLnBrk="0" hangingPunct="1">
-              <a:lnSpc>
-                <a:spcPct val="90000"/>
-              </a:lnSpc>
-              <a:spcBef>
-                <a:spcPts val="500"/>
-              </a:spcBef>
-              <a:buFont typeface="Arial" panose="020B0604020202020204" pitchFamily="34" charset="0"/>
-              <a:buChar char="•"/>
-              <a:defRPr sz="1800" kern="1200">
-                <a:solidFill>
-                  <a:schemeClr val="tx1"/>
-                </a:solidFill>
-                <a:latin typeface="+mn-lt"/>
-                <a:ea typeface="+mn-ea"/>
-                <a:cs typeface="+mn-cs"/>
-              </a:defRPr>
-            </a:lvl8pPr>
-            <a:lvl9pPr marL="3886200" indent="-228600" algn="l" defTabSz="914400" rtl="0" eaLnBrk="1" latinLnBrk="0" hangingPunct="1">
-              <a:lnSpc>
-                <a:spcPct val="90000"/>
-              </a:lnSpc>
-              <a:spcBef>
-                <a:spcPts val="500"/>
-              </a:spcBef>
-              <a:buFont typeface="Arial" panose="020B0604020202020204" pitchFamily="34" charset="0"/>
-              <a:buChar char="•"/>
-              <a:defRPr sz="1800" kern="1200">
-                <a:solidFill>
-                  <a:schemeClr val="tx1"/>
-                </a:solidFill>
-                <a:latin typeface="+mn-lt"/>
-                <a:ea typeface="+mn-ea"/>
-                <a:cs typeface="+mn-cs"/>
-              </a:defRPr>
-            </a:lvl9pPr>
-          </a:lstStyle>
-          <a:p>
-            <a:r>
-              <a:rPr lang="fr-FR" dirty="0" err="1"/>
-              <a:t>qsdf</a:t>
-            </a:r>
-            <a:endParaRPr lang="fr-FR" dirty="0"/>
           </a:p>
         </p:txBody>
       </p:sp>

</xml_diff>

<commit_message>
feat(setup): apply slot names to real master + shapes≡slots validator (Phase 2) (#14)
* feat(setup): apply slot names to real master + shapes≡slots validator (Phase 2)

Fix sidebar-callout layoutId collisions, emit layout-spec.json from the
approved naming table, mechanically rename 164 shapes in report.master.pptx,
and add a shapes≡slots validator wired into npm run validate.

Co-authored-by: Cursor <cursoragent@cursor.com>

* fix(setup): rename remaining French placeholders + delete slide 6 artifact

Match slide-level instances by placeholder type (not just cNvPr number),
sweep legacy Espace réservé names on slide and layout parts, delete the
stray txBox on slide 6, and fail validation if any legacy placeholder
names survive.

Co-authored-by: Cursor <cursoragent@cursor.com>

---------

Co-authored-by: Cursor <cursoragent@cursor.com>
</commit_message>
<xml_diff>
--- a/templates/report.master.pptx
+++ b/templates/report.master.pptx
@@ -4903,7 +4903,7 @@
       </p:graphicFrame>
       <p:sp>
         <p:nvSpPr>
-          <p:cNvPr id="2" name="Titre 1">
+          <p:cNvPr id="2" name="slot.title">
             <a:extLst>
               <a:ext uri="{FF2B5EF4-FFF2-40B4-BE49-F238E27FC236}">
                 <a16:creationId xmlns:a16="http://schemas.microsoft.com/office/drawing/2014/main" id="{FCE45F8B-6B35-4416-DE1A-36DAC87E84D7}"/>
@@ -4947,7 +4947,7 @@
       </p:sp>
       <p:sp>
         <p:nvSpPr>
-          <p:cNvPr id="3" name="Espace réservé du contenu 2">
+          <p:cNvPr id="3" name="slot.body-left">
             <a:extLst>
               <a:ext uri="{FF2B5EF4-FFF2-40B4-BE49-F238E27FC236}">
                 <a16:creationId xmlns:a16="http://schemas.microsoft.com/office/drawing/2014/main" id="{DD259420-A1F5-B3E7-FA1E-AF141FA30A75}"/>
@@ -5033,7 +5033,7 @@
       </p:sp>
       <p:sp>
         <p:nvSpPr>
-          <p:cNvPr id="6" name="Espace réservé du numéro de diapositive 5">
+          <p:cNvPr id="6" name="slot.footer-page">
             <a:extLst>
               <a:ext uri="{FF2B5EF4-FFF2-40B4-BE49-F238E27FC236}">
                 <a16:creationId xmlns:a16="http://schemas.microsoft.com/office/drawing/2014/main" id="{C0B19DAE-9253-B1E3-C9A1-BAD7328324FA}"/>
@@ -5067,7 +5067,7 @@
       </p:sp>
       <p:sp>
         <p:nvSpPr>
-          <p:cNvPr id="20" name="Espace réservé du contenu 6">
+          <p:cNvPr id="20" name="slot.source">
             <a:extLst>
               <a:ext uri="{FF2B5EF4-FFF2-40B4-BE49-F238E27FC236}">
                 <a16:creationId xmlns:a16="http://schemas.microsoft.com/office/drawing/2014/main" id="{A0EE391D-69CD-DBA5-462B-AEF51D098FA6}"/>
@@ -5175,7 +5175,7 @@
       </p:cxnSp>
       <p:sp>
         <p:nvSpPr>
-          <p:cNvPr id="5" name="ZoneTexte 30">
+          <p:cNvPr id="5" name="slot.footer-copyright">
             <a:extLst>
               <a:ext uri="{FF2B5EF4-FFF2-40B4-BE49-F238E27FC236}">
                 <a16:creationId xmlns:a16="http://schemas.microsoft.com/office/drawing/2014/main" id="{A2FEA1FF-9F37-6219-3F4E-99D834B28FEB}"/>
@@ -5229,7 +5229,7 @@
       </p:sp>
       <p:sp>
         <p:nvSpPr>
-          <p:cNvPr id="8" name="ZoneTexte 7">
+          <p:cNvPr id="8" name="slot.footer-logo">
             <a:extLst>
               <a:ext uri="{FF2B5EF4-FFF2-40B4-BE49-F238E27FC236}">
                 <a16:creationId xmlns:a16="http://schemas.microsoft.com/office/drawing/2014/main" id="{E8981164-199B-BE71-F7D8-B1188DFC07F2}"/>
@@ -5443,7 +5443,7 @@
       </p:pic>
       <p:sp>
         <p:nvSpPr>
-          <p:cNvPr id="4" name="Titre 1">
+          <p:cNvPr id="4" name="slot.title">
             <a:extLst>
               <a:ext uri="{FF2B5EF4-FFF2-40B4-BE49-F238E27FC236}">
                 <a16:creationId xmlns:a16="http://schemas.microsoft.com/office/drawing/2014/main" id="{5021812E-4666-EE7A-00F0-B822BDC95294}"/>
@@ -5489,7 +5489,7 @@
       </p:sp>
       <p:sp>
         <p:nvSpPr>
-          <p:cNvPr id="5" name="Espace réservé du contenu 3">
+          <p:cNvPr id="5" name="slot.body-left">
             <a:extLst>
               <a:ext uri="{FF2B5EF4-FFF2-40B4-BE49-F238E27FC236}">
                 <a16:creationId xmlns:a16="http://schemas.microsoft.com/office/drawing/2014/main" id="{664EE6FE-7213-D8B4-C52F-792F747C9C0B}"/>
@@ -5715,7 +5715,7 @@
       </p:cxnSp>
       <p:sp>
         <p:nvSpPr>
-          <p:cNvPr id="10" name="Espace réservé du numéro de diapositive 5">
+          <p:cNvPr id="10" name="slot.footer-page">
             <a:extLst>
               <a:ext uri="{FF2B5EF4-FFF2-40B4-BE49-F238E27FC236}">
                 <a16:creationId xmlns:a16="http://schemas.microsoft.com/office/drawing/2014/main" id="{D522E3A2-42AA-2228-2F55-67BD9734EC15}"/>
@@ -5881,7 +5881,7 @@
       </p:sp>
       <p:sp>
         <p:nvSpPr>
-          <p:cNvPr id="8" name="ZoneTexte 30">
+          <p:cNvPr id="8" name="slot.footer-copyright">
             <a:extLst>
               <a:ext uri="{FF2B5EF4-FFF2-40B4-BE49-F238E27FC236}">
                 <a16:creationId xmlns:a16="http://schemas.microsoft.com/office/drawing/2014/main" id="{E150FD5F-C13D-5321-DE4B-E1FDA4387569}"/>
@@ -5935,7 +5935,7 @@
       </p:sp>
       <p:sp>
         <p:nvSpPr>
-          <p:cNvPr id="12" name="ZoneTexte 11">
+          <p:cNvPr id="12" name="slot.footer-logo">
             <a:extLst>
               <a:ext uri="{FF2B5EF4-FFF2-40B4-BE49-F238E27FC236}">
                 <a16:creationId xmlns:a16="http://schemas.microsoft.com/office/drawing/2014/main" id="{8AF61725-8811-F4AA-3B06-802B815FDF5F}"/>
@@ -6117,7 +6117,7 @@
       </p:graphicFrame>
       <p:sp>
         <p:nvSpPr>
-          <p:cNvPr id="5" name="Titre 1">
+          <p:cNvPr id="5" name="slot.title">
             <a:extLst>
               <a:ext uri="{FF2B5EF4-FFF2-40B4-BE49-F238E27FC236}">
                 <a16:creationId xmlns:a16="http://schemas.microsoft.com/office/drawing/2014/main" id="{00E8F29D-6980-4830-A056-57FFB127FFBD}"/>
@@ -6161,7 +6161,7 @@
       </p:sp>
       <p:sp>
         <p:nvSpPr>
-          <p:cNvPr id="9" name="Sous-titre 2">
+          <p:cNvPr id="9" name="slot.subtitle">
             <a:extLst>
               <a:ext uri="{FF2B5EF4-FFF2-40B4-BE49-F238E27FC236}">
                 <a16:creationId xmlns:a16="http://schemas.microsoft.com/office/drawing/2014/main" id="{D92A2739-22B5-D8C9-22C3-AB9ACCB8111C}"/>
@@ -6778,7 +6778,7 @@
       </p:graphicFrame>
       <p:sp>
         <p:nvSpPr>
-          <p:cNvPr id="2" name="Titre 1">
+          <p:cNvPr id="2" name="slot.section-title">
             <a:extLst>
               <a:ext uri="{FF2B5EF4-FFF2-40B4-BE49-F238E27FC236}">
                 <a16:creationId xmlns:a16="http://schemas.microsoft.com/office/drawing/2014/main" id="{1FAAFAE6-D60C-93B1-4819-060D20F8BFF4}"/>
@@ -6822,7 +6822,7 @@
       </p:sp>
       <p:sp>
         <p:nvSpPr>
-          <p:cNvPr id="3" name="Sous-titre 2">
+          <p:cNvPr id="3" name="slot.subtitle">
             <a:extLst>
               <a:ext uri="{FF2B5EF4-FFF2-40B4-BE49-F238E27FC236}">
                 <a16:creationId xmlns:a16="http://schemas.microsoft.com/office/drawing/2014/main" id="{B989298A-8D13-336B-A448-1CB247CE6E4F}"/>
@@ -7014,7 +7014,7 @@
       </p:graphicFrame>
       <p:sp>
         <p:nvSpPr>
-          <p:cNvPr id="2" name="Titre 1">
+          <p:cNvPr id="2" name="slot.title">
             <a:extLst>
               <a:ext uri="{FF2B5EF4-FFF2-40B4-BE49-F238E27FC236}">
                 <a16:creationId xmlns:a16="http://schemas.microsoft.com/office/drawing/2014/main" id="{02A78A85-561E-020D-C7F8-40BBB3F191CA}"/>
@@ -7098,7 +7098,7 @@
       </p:cxnSp>
       <p:sp>
         <p:nvSpPr>
-          <p:cNvPr id="3" name="Espace réservé du numéro de diapositive 5">
+          <p:cNvPr id="3" name="slot.footer-page">
             <a:extLst>
               <a:ext uri="{FF2B5EF4-FFF2-40B4-BE49-F238E27FC236}">
                 <a16:creationId xmlns:a16="http://schemas.microsoft.com/office/drawing/2014/main" id="{D39FA986-AFFA-D470-697F-282E932DA97D}"/>
@@ -7132,7 +7132,7 @@
       </p:sp>
       <p:sp>
         <p:nvSpPr>
-          <p:cNvPr id="5" name="Espace réservé du contenu 3">
+          <p:cNvPr id="5" name="slot.body-left">
             <a:extLst>
               <a:ext uri="{FF2B5EF4-FFF2-40B4-BE49-F238E27FC236}">
                 <a16:creationId xmlns:a16="http://schemas.microsoft.com/office/drawing/2014/main" id="{FCB803A9-272C-4119-092B-F5D7EE4021F0}"/>
@@ -7250,7 +7250,7 @@
       </p:sp>
       <p:sp>
         <p:nvSpPr>
-          <p:cNvPr id="4" name="ZoneTexte 30">
+          <p:cNvPr id="4" name="slot.footer-copyright">
             <a:extLst>
               <a:ext uri="{FF2B5EF4-FFF2-40B4-BE49-F238E27FC236}">
                 <a16:creationId xmlns:a16="http://schemas.microsoft.com/office/drawing/2014/main" id="{C6A98321-E2FB-BA54-2C7C-C6FAE635B1A9}"/>
@@ -7304,7 +7304,7 @@
       </p:sp>
       <p:sp>
         <p:nvSpPr>
-          <p:cNvPr id="8" name="ZoneTexte 7">
+          <p:cNvPr id="8" name="slot.footer-logo">
             <a:extLst>
               <a:ext uri="{FF2B5EF4-FFF2-40B4-BE49-F238E27FC236}">
                 <a16:creationId xmlns:a16="http://schemas.microsoft.com/office/drawing/2014/main" id="{EF472C68-8BBB-B295-F133-C34823F6F4A8}"/>
@@ -7523,7 +7523,7 @@
       </p:pic>
       <p:sp>
         <p:nvSpPr>
-          <p:cNvPr id="2" name="Titre 1">
+          <p:cNvPr id="2" name="slot.title">
             <a:extLst>
               <a:ext uri="{FF2B5EF4-FFF2-40B4-BE49-F238E27FC236}">
                 <a16:creationId xmlns:a16="http://schemas.microsoft.com/office/drawing/2014/main" id="{02A78A85-561E-020D-C7F8-40BBB3F191CA}"/>
@@ -7565,7 +7565,7 @@
       </p:sp>
       <p:sp>
         <p:nvSpPr>
-          <p:cNvPr id="3" name="Espace réservé du texte 2">
+          <p:cNvPr id="3" name="slot.subtitle-left">
             <a:extLst>
               <a:ext uri="{FF2B5EF4-FFF2-40B4-BE49-F238E27FC236}">
                 <a16:creationId xmlns:a16="http://schemas.microsoft.com/office/drawing/2014/main" id="{E43735A6-6302-B3D2-6BB7-6309454C5C3A}"/>
@@ -7659,7 +7659,7 @@
       </p:sp>
       <p:sp>
         <p:nvSpPr>
-          <p:cNvPr id="4" name="Espace réservé du contenu 3">
+          <p:cNvPr id="4" name="slot.body-left">
             <a:extLst>
               <a:ext uri="{FF2B5EF4-FFF2-40B4-BE49-F238E27FC236}">
                 <a16:creationId xmlns:a16="http://schemas.microsoft.com/office/drawing/2014/main" id="{2D3E2C40-4C7F-6E36-C2FB-962C73150210}"/>
@@ -7772,7 +7772,7 @@
       </p:sp>
       <p:sp>
         <p:nvSpPr>
-          <p:cNvPr id="5" name="Espace réservé du texte 4">
+          <p:cNvPr id="5" name="slot.subtitle-left">
             <a:extLst>
               <a:ext uri="{FF2B5EF4-FFF2-40B4-BE49-F238E27FC236}">
                 <a16:creationId xmlns:a16="http://schemas.microsoft.com/office/drawing/2014/main" id="{2D35804D-7044-B129-7E2C-ED3868BD4F80}"/>
@@ -7863,7 +7863,7 @@
       </p:sp>
       <p:sp>
         <p:nvSpPr>
-          <p:cNvPr id="6" name="Espace réservé du contenu 5">
+          <p:cNvPr id="6" name="slot.body-right">
             <a:extLst>
               <a:ext uri="{FF2B5EF4-FFF2-40B4-BE49-F238E27FC236}">
                 <a16:creationId xmlns:a16="http://schemas.microsoft.com/office/drawing/2014/main" id="{C56BF488-D9DF-64BA-30D9-77D4A3CB1561}"/>
@@ -8047,7 +8047,7 @@
       </p:cxnSp>
       <p:sp>
         <p:nvSpPr>
-          <p:cNvPr id="8" name="Espace réservé du numéro de diapositive 5">
+          <p:cNvPr id="8" name="slot.footer-page">
             <a:extLst>
               <a:ext uri="{FF2B5EF4-FFF2-40B4-BE49-F238E27FC236}">
                 <a16:creationId xmlns:a16="http://schemas.microsoft.com/office/drawing/2014/main" id="{510C2F0B-2799-67BD-FD30-3323FE6E8D3F}"/>
@@ -8081,7 +8081,7 @@
       </p:sp>
       <p:sp>
         <p:nvSpPr>
-          <p:cNvPr id="15" name="Espace réservé du contenu 6">
+          <p:cNvPr id="15" name="slot.source">
             <a:extLst>
               <a:ext uri="{FF2B5EF4-FFF2-40B4-BE49-F238E27FC236}">
                 <a16:creationId xmlns:a16="http://schemas.microsoft.com/office/drawing/2014/main" id="{BB6B3779-78D5-9210-1459-E20DFD83BF8E}"/>
@@ -8148,7 +8148,7 @@
       </p:sp>
       <p:sp>
         <p:nvSpPr>
-          <p:cNvPr id="7" name="ZoneTexte 30">
+          <p:cNvPr id="7" name="slot.footer-copyright">
             <a:extLst>
               <a:ext uri="{FF2B5EF4-FFF2-40B4-BE49-F238E27FC236}">
                 <a16:creationId xmlns:a16="http://schemas.microsoft.com/office/drawing/2014/main" id="{9A6DF3F5-8564-E129-6554-B6EDA6853068}"/>
@@ -8202,7 +8202,7 @@
       </p:sp>
       <p:sp>
         <p:nvSpPr>
-          <p:cNvPr id="9" name="ZoneTexte 8">
+          <p:cNvPr id="9" name="slot.footer-logo">
             <a:extLst>
               <a:ext uri="{FF2B5EF4-FFF2-40B4-BE49-F238E27FC236}">
                 <a16:creationId xmlns:a16="http://schemas.microsoft.com/office/drawing/2014/main" id="{06395C06-3B11-8812-966B-5A6B6AA95084}"/>
@@ -8421,7 +8421,7 @@
       </p:pic>
       <p:sp>
         <p:nvSpPr>
-          <p:cNvPr id="2" name="Titre 1">
+          <p:cNvPr id="2" name="slot.title">
             <a:extLst>
               <a:ext uri="{FF2B5EF4-FFF2-40B4-BE49-F238E27FC236}">
                 <a16:creationId xmlns:a16="http://schemas.microsoft.com/office/drawing/2014/main" id="{02A78A85-561E-020D-C7F8-40BBB3F191CA}"/>
@@ -8463,7 +8463,7 @@
       </p:sp>
       <p:sp>
         <p:nvSpPr>
-          <p:cNvPr id="3" name="Espace réservé du texte 2">
+          <p:cNvPr id="3" name="slot.subtitle-left">
             <a:extLst>
               <a:ext uri="{FF2B5EF4-FFF2-40B4-BE49-F238E27FC236}">
                 <a16:creationId xmlns:a16="http://schemas.microsoft.com/office/drawing/2014/main" id="{E43735A6-6302-B3D2-6BB7-6309454C5C3A}"/>
@@ -8557,7 +8557,7 @@
       </p:sp>
       <p:sp>
         <p:nvSpPr>
-          <p:cNvPr id="4" name="Espace réservé du contenu 3">
+          <p:cNvPr id="4" name="slot.body-left">
             <a:extLst>
               <a:ext uri="{FF2B5EF4-FFF2-40B4-BE49-F238E27FC236}">
                 <a16:creationId xmlns:a16="http://schemas.microsoft.com/office/drawing/2014/main" id="{2D3E2C40-4C7F-6E36-C2FB-962C73150210}"/>
@@ -8670,7 +8670,7 @@
       </p:sp>
       <p:sp>
         <p:nvSpPr>
-          <p:cNvPr id="5" name="Espace réservé du texte 4">
+          <p:cNvPr id="5" name="slot.subtitle-left">
             <a:extLst>
               <a:ext uri="{FF2B5EF4-FFF2-40B4-BE49-F238E27FC236}">
                 <a16:creationId xmlns:a16="http://schemas.microsoft.com/office/drawing/2014/main" id="{2D35804D-7044-B129-7E2C-ED3868BD4F80}"/>
@@ -8761,7 +8761,7 @@
       </p:sp>
       <p:sp>
         <p:nvSpPr>
-          <p:cNvPr id="6" name="Espace réservé du contenu 5">
+          <p:cNvPr id="6" name="slot.body-right">
             <a:extLst>
               <a:ext uri="{FF2B5EF4-FFF2-40B4-BE49-F238E27FC236}">
                 <a16:creationId xmlns:a16="http://schemas.microsoft.com/office/drawing/2014/main" id="{C56BF488-D9DF-64BA-30D9-77D4A3CB1561}"/>
@@ -8945,7 +8945,7 @@
       </p:cxnSp>
       <p:sp>
         <p:nvSpPr>
-          <p:cNvPr id="11" name="Espace réservé du numéro de diapositive 5">
+          <p:cNvPr id="11" name="slot.footer-page">
             <a:extLst>
               <a:ext uri="{FF2B5EF4-FFF2-40B4-BE49-F238E27FC236}">
                 <a16:creationId xmlns:a16="http://schemas.microsoft.com/office/drawing/2014/main" id="{B083480F-4AEB-CC56-9E28-75B8E7A55047}"/>
@@ -8979,7 +8979,7 @@
       </p:sp>
       <p:sp>
         <p:nvSpPr>
-          <p:cNvPr id="19" name="Espace réservé du contenu 6">
+          <p:cNvPr id="19" name="slot.source">
             <a:extLst>
               <a:ext uri="{FF2B5EF4-FFF2-40B4-BE49-F238E27FC236}">
                 <a16:creationId xmlns:a16="http://schemas.microsoft.com/office/drawing/2014/main" id="{47DD7148-9127-86A3-6944-6DF6931A959F}"/>
@@ -9046,7 +9046,7 @@
       </p:sp>
       <p:sp>
         <p:nvSpPr>
-          <p:cNvPr id="7" name="ZoneTexte 30">
+          <p:cNvPr id="7" name="slot.footer-copyright">
             <a:extLst>
               <a:ext uri="{FF2B5EF4-FFF2-40B4-BE49-F238E27FC236}">
                 <a16:creationId xmlns:a16="http://schemas.microsoft.com/office/drawing/2014/main" id="{69C38BEF-2317-F24E-C3B1-1AA0A6810398}"/>
@@ -9100,7 +9100,7 @@
       </p:sp>
       <p:sp>
         <p:nvSpPr>
-          <p:cNvPr id="8" name="ZoneTexte 7">
+          <p:cNvPr id="8" name="slot.footer-logo">
             <a:extLst>
               <a:ext uri="{FF2B5EF4-FFF2-40B4-BE49-F238E27FC236}">
                 <a16:creationId xmlns:a16="http://schemas.microsoft.com/office/drawing/2014/main" id="{A2FB2DD0-93CC-F92C-4E8C-5BA3458E25C3}"/>
@@ -9314,7 +9314,7 @@
       </p:pic>
       <p:sp>
         <p:nvSpPr>
-          <p:cNvPr id="2" name="Titre 1">
+          <p:cNvPr id="2" name="slot.title">
             <a:extLst>
               <a:ext uri="{FF2B5EF4-FFF2-40B4-BE49-F238E27FC236}">
                 <a16:creationId xmlns:a16="http://schemas.microsoft.com/office/drawing/2014/main" id="{02A78A85-561E-020D-C7F8-40BBB3F191CA}"/>
@@ -9356,7 +9356,7 @@
       </p:sp>
       <p:sp>
         <p:nvSpPr>
-          <p:cNvPr id="3" name="Espace réservé du texte 2">
+          <p:cNvPr id="3" name="slot.subtitle-1">
             <a:extLst>
               <a:ext uri="{FF2B5EF4-FFF2-40B4-BE49-F238E27FC236}">
                 <a16:creationId xmlns:a16="http://schemas.microsoft.com/office/drawing/2014/main" id="{E43735A6-6302-B3D2-6BB7-6309454C5C3A}"/>
@@ -9450,7 +9450,7 @@
       </p:sp>
       <p:sp>
         <p:nvSpPr>
-          <p:cNvPr id="5" name="Espace réservé du texte 4">
+          <p:cNvPr id="5" name="slot.subtitle-2">
             <a:extLst>
               <a:ext uri="{FF2B5EF4-FFF2-40B4-BE49-F238E27FC236}">
                 <a16:creationId xmlns:a16="http://schemas.microsoft.com/office/drawing/2014/main" id="{2D35804D-7044-B129-7E2C-ED3868BD4F80}"/>
@@ -9541,7 +9541,7 @@
       </p:sp>
       <p:sp>
         <p:nvSpPr>
-          <p:cNvPr id="6" name="Espace réservé du contenu 5">
+          <p:cNvPr id="6" name="slot.body">
             <a:extLst>
               <a:ext uri="{FF2B5EF4-FFF2-40B4-BE49-F238E27FC236}">
                 <a16:creationId xmlns:a16="http://schemas.microsoft.com/office/drawing/2014/main" id="{C56BF488-D9DF-64BA-30D9-77D4A3CB1561}"/>
@@ -9770,7 +9770,7 @@
       </p:cxnSp>
       <p:sp>
         <p:nvSpPr>
-          <p:cNvPr id="15" name="Espace réservé du numéro de diapositive 5">
+          <p:cNvPr id="15" name="slot.footer-page">
             <a:extLst>
               <a:ext uri="{FF2B5EF4-FFF2-40B4-BE49-F238E27FC236}">
                 <a16:creationId xmlns:a16="http://schemas.microsoft.com/office/drawing/2014/main" id="{24F11CE2-041F-6445-F54A-56AAFFD76115}"/>
@@ -9804,7 +9804,7 @@
       </p:sp>
       <p:sp>
         <p:nvSpPr>
-          <p:cNvPr id="20" name="Espace réservé du contenu 6">
+          <p:cNvPr id="20" name="slot.source">
             <a:extLst>
               <a:ext uri="{FF2B5EF4-FFF2-40B4-BE49-F238E27FC236}">
                 <a16:creationId xmlns:a16="http://schemas.microsoft.com/office/drawing/2014/main" id="{95AC962B-733D-ABAE-17E4-E513BAC8B9E1}"/>
@@ -9871,7 +9871,7 @@
       </p:sp>
       <p:sp>
         <p:nvSpPr>
-          <p:cNvPr id="4" name="ZoneTexte 30">
+          <p:cNvPr id="4" name="slot.footer-copyright">
             <a:extLst>
               <a:ext uri="{FF2B5EF4-FFF2-40B4-BE49-F238E27FC236}">
                 <a16:creationId xmlns:a16="http://schemas.microsoft.com/office/drawing/2014/main" id="{B9EA91B6-6CF2-5B80-F0AE-B0ED5165D982}"/>
@@ -9925,7 +9925,7 @@
       </p:sp>
       <p:sp>
         <p:nvSpPr>
-          <p:cNvPr id="7" name="ZoneTexte 6">
+          <p:cNvPr id="7" name="slot.footer-logo">
             <a:extLst>
               <a:ext uri="{FF2B5EF4-FFF2-40B4-BE49-F238E27FC236}">
                 <a16:creationId xmlns:a16="http://schemas.microsoft.com/office/drawing/2014/main" id="{4C9F5E73-E5D7-0B11-9227-681DA930D820}"/>
@@ -10144,7 +10144,7 @@
       </p:pic>
       <p:sp>
         <p:nvSpPr>
-          <p:cNvPr id="2" name="Titre 1">
+          <p:cNvPr id="2" name="slot.title">
             <a:extLst>
               <a:ext uri="{FF2B5EF4-FFF2-40B4-BE49-F238E27FC236}">
                 <a16:creationId xmlns:a16="http://schemas.microsoft.com/office/drawing/2014/main" id="{02A78A85-561E-020D-C7F8-40BBB3F191CA}"/>
@@ -10186,7 +10186,7 @@
       </p:sp>
       <p:sp>
         <p:nvSpPr>
-          <p:cNvPr id="3" name="Espace réservé du texte 2">
+          <p:cNvPr id="3" name="slot.subtitle-1">
             <a:extLst>
               <a:ext uri="{FF2B5EF4-FFF2-40B4-BE49-F238E27FC236}">
                 <a16:creationId xmlns:a16="http://schemas.microsoft.com/office/drawing/2014/main" id="{E43735A6-6302-B3D2-6BB7-6309454C5C3A}"/>
@@ -10280,7 +10280,7 @@
       </p:sp>
       <p:sp>
         <p:nvSpPr>
-          <p:cNvPr id="5" name="Espace réservé du texte 4">
+          <p:cNvPr id="5" name="slot.subtitle-2">
             <a:extLst>
               <a:ext uri="{FF2B5EF4-FFF2-40B4-BE49-F238E27FC236}">
                 <a16:creationId xmlns:a16="http://schemas.microsoft.com/office/drawing/2014/main" id="{2D35804D-7044-B129-7E2C-ED3868BD4F80}"/>
@@ -10371,7 +10371,7 @@
       </p:sp>
       <p:sp>
         <p:nvSpPr>
-          <p:cNvPr id="6" name="Espace réservé du contenu 5">
+          <p:cNvPr id="6" name="slot.body">
             <a:extLst>
               <a:ext uri="{FF2B5EF4-FFF2-40B4-BE49-F238E27FC236}">
                 <a16:creationId xmlns:a16="http://schemas.microsoft.com/office/drawing/2014/main" id="{C56BF488-D9DF-64BA-30D9-77D4A3CB1561}"/>
@@ -10514,7 +10514,7 @@
       </p:cxnSp>
       <p:sp>
         <p:nvSpPr>
-          <p:cNvPr id="15" name="Espace réservé du numéro de diapositive 5">
+          <p:cNvPr id="15" name="slot.footer-page">
             <a:extLst>
               <a:ext uri="{FF2B5EF4-FFF2-40B4-BE49-F238E27FC236}">
                 <a16:creationId xmlns:a16="http://schemas.microsoft.com/office/drawing/2014/main" id="{24F11CE2-041F-6445-F54A-56AAFFD76115}"/>
@@ -10548,7 +10548,7 @@
       </p:sp>
       <p:sp>
         <p:nvSpPr>
-          <p:cNvPr id="20" name="Espace réservé du contenu 6">
+          <p:cNvPr id="20" name="slot.source">
             <a:extLst>
               <a:ext uri="{FF2B5EF4-FFF2-40B4-BE49-F238E27FC236}">
                 <a16:creationId xmlns:a16="http://schemas.microsoft.com/office/drawing/2014/main" id="{95AC962B-733D-ABAE-17E4-E513BAC8B9E1}"/>
@@ -10738,7 +10738,7 @@
       </p:sp>
       <p:sp>
         <p:nvSpPr>
-          <p:cNvPr id="7" name="ZoneTexte 30">
+          <p:cNvPr id="7" name="slot.footer-copyright">
             <a:extLst>
               <a:ext uri="{FF2B5EF4-FFF2-40B4-BE49-F238E27FC236}">
                 <a16:creationId xmlns:a16="http://schemas.microsoft.com/office/drawing/2014/main" id="{1BF41F40-595B-48CD-E781-95878742749D}"/>
@@ -10792,7 +10792,7 @@
       </p:sp>
       <p:sp>
         <p:nvSpPr>
-          <p:cNvPr id="9" name="ZoneTexte 8">
+          <p:cNvPr id="9" name="slot.footer-logo">
             <a:extLst>
               <a:ext uri="{FF2B5EF4-FFF2-40B4-BE49-F238E27FC236}">
                 <a16:creationId xmlns:a16="http://schemas.microsoft.com/office/drawing/2014/main" id="{EEBE6346-AC0F-95D1-CFD8-CB8054A615A5}"/>
@@ -11021,7 +11021,7 @@
       </p:sp>
       <p:sp>
         <p:nvSpPr>
-          <p:cNvPr id="2" name="Titre 1">
+          <p:cNvPr id="2" name="slot.title">
             <a:extLst>
               <a:ext uri="{FF2B5EF4-FFF2-40B4-BE49-F238E27FC236}">
                 <a16:creationId xmlns:a16="http://schemas.microsoft.com/office/drawing/2014/main" id="{02A78A85-561E-020D-C7F8-40BBB3F191CA}"/>
@@ -11063,7 +11063,7 @@
       </p:sp>
       <p:sp>
         <p:nvSpPr>
-          <p:cNvPr id="3" name="Espace réservé du texte 2">
+          <p:cNvPr id="3" name="slot.subtitle-left">
             <a:extLst>
               <a:ext uri="{FF2B5EF4-FFF2-40B4-BE49-F238E27FC236}">
                 <a16:creationId xmlns:a16="http://schemas.microsoft.com/office/drawing/2014/main" id="{E43735A6-6302-B3D2-6BB7-6309454C5C3A}"/>
@@ -11157,7 +11157,7 @@
       </p:sp>
       <p:sp>
         <p:nvSpPr>
-          <p:cNvPr id="4" name="Espace réservé du contenu 3">
+          <p:cNvPr id="4" name="slot.body-left">
             <a:extLst>
               <a:ext uri="{FF2B5EF4-FFF2-40B4-BE49-F238E27FC236}">
                 <a16:creationId xmlns:a16="http://schemas.microsoft.com/office/drawing/2014/main" id="{2D3E2C40-4C7F-6E36-C2FB-962C73150210}"/>
@@ -11270,7 +11270,7 @@
       </p:sp>
       <p:sp>
         <p:nvSpPr>
-          <p:cNvPr id="5" name="Espace réservé du texte 4">
+          <p:cNvPr id="5" name="slot.subtitle-left">
             <a:extLst>
               <a:ext uri="{FF2B5EF4-FFF2-40B4-BE49-F238E27FC236}">
                 <a16:creationId xmlns:a16="http://schemas.microsoft.com/office/drawing/2014/main" id="{2D35804D-7044-B129-7E2C-ED3868BD4F80}"/>
@@ -11361,7 +11361,7 @@
       </p:sp>
       <p:sp>
         <p:nvSpPr>
-          <p:cNvPr id="6" name="Espace réservé du contenu 5">
+          <p:cNvPr id="6" name="slot.body-right">
             <a:extLst>
               <a:ext uri="{FF2B5EF4-FFF2-40B4-BE49-F238E27FC236}">
                 <a16:creationId xmlns:a16="http://schemas.microsoft.com/office/drawing/2014/main" id="{C56BF488-D9DF-64BA-30D9-77D4A3CB1561}"/>
@@ -11602,7 +11602,7 @@
       </p:cxnSp>
       <p:sp>
         <p:nvSpPr>
-          <p:cNvPr id="11" name="Espace réservé du numéro de diapositive 5">
+          <p:cNvPr id="11" name="slot.footer-page">
             <a:extLst>
               <a:ext uri="{FF2B5EF4-FFF2-40B4-BE49-F238E27FC236}">
                 <a16:creationId xmlns:a16="http://schemas.microsoft.com/office/drawing/2014/main" id="{EF3FC79F-B88C-8E01-0898-E0B4EFE85FEE}"/>
@@ -11645,7 +11645,7 @@
       </p:sp>
       <p:sp>
         <p:nvSpPr>
-          <p:cNvPr id="22" name="Espace réservé du contenu 6">
+          <p:cNvPr id="22" name="slot.source">
             <a:extLst>
               <a:ext uri="{FF2B5EF4-FFF2-40B4-BE49-F238E27FC236}">
                 <a16:creationId xmlns:a16="http://schemas.microsoft.com/office/drawing/2014/main" id="{BD45DD6B-1B35-99CF-127B-561BE4952E16}"/>
@@ -11712,7 +11712,7 @@
       </p:sp>
       <p:sp>
         <p:nvSpPr>
-          <p:cNvPr id="9" name="ZoneTexte 30">
+          <p:cNvPr id="9" name="slot.footer-copyright">
             <a:extLst>
               <a:ext uri="{FF2B5EF4-FFF2-40B4-BE49-F238E27FC236}">
                 <a16:creationId xmlns:a16="http://schemas.microsoft.com/office/drawing/2014/main" id="{E76FB809-1B2B-CCF6-24BB-429FDD2D7B24}"/>
@@ -11766,7 +11766,7 @@
       </p:sp>
       <p:sp>
         <p:nvSpPr>
-          <p:cNvPr id="14" name="ZoneTexte 13">
+          <p:cNvPr id="14" name="slot.footer-logo">
             <a:extLst>
               <a:ext uri="{FF2B5EF4-FFF2-40B4-BE49-F238E27FC236}">
                 <a16:creationId xmlns:a16="http://schemas.microsoft.com/office/drawing/2014/main" id="{003096E9-3812-E7EE-F73E-A45B1A3882EE}"/>
@@ -11995,7 +11995,7 @@
       </p:sp>
       <p:sp>
         <p:nvSpPr>
-          <p:cNvPr id="2" name="Titre 1">
+          <p:cNvPr id="2" name="slot.title">
             <a:extLst>
               <a:ext uri="{FF2B5EF4-FFF2-40B4-BE49-F238E27FC236}">
                 <a16:creationId xmlns:a16="http://schemas.microsoft.com/office/drawing/2014/main" id="{02A78A85-561E-020D-C7F8-40BBB3F191CA}"/>
@@ -12037,7 +12037,7 @@
       </p:sp>
       <p:sp>
         <p:nvSpPr>
-          <p:cNvPr id="3" name="Espace réservé du texte 2">
+          <p:cNvPr id="3" name="slot.subtitle-left">
             <a:extLst>
               <a:ext uri="{FF2B5EF4-FFF2-40B4-BE49-F238E27FC236}">
                 <a16:creationId xmlns:a16="http://schemas.microsoft.com/office/drawing/2014/main" id="{E43735A6-6302-B3D2-6BB7-6309454C5C3A}"/>
@@ -12131,7 +12131,7 @@
       </p:sp>
       <p:sp>
         <p:nvSpPr>
-          <p:cNvPr id="4" name="Espace réservé du contenu 3">
+          <p:cNvPr id="4" name="slot.body-left">
             <a:extLst>
               <a:ext uri="{FF2B5EF4-FFF2-40B4-BE49-F238E27FC236}">
                 <a16:creationId xmlns:a16="http://schemas.microsoft.com/office/drawing/2014/main" id="{2D3E2C40-4C7F-6E36-C2FB-962C73150210}"/>
@@ -12244,7 +12244,7 @@
       </p:sp>
       <p:sp>
         <p:nvSpPr>
-          <p:cNvPr id="5" name="Espace réservé du texte 4">
+          <p:cNvPr id="5" name="slot.subtitle-left">
             <a:extLst>
               <a:ext uri="{FF2B5EF4-FFF2-40B4-BE49-F238E27FC236}">
                 <a16:creationId xmlns:a16="http://schemas.microsoft.com/office/drawing/2014/main" id="{2D35804D-7044-B129-7E2C-ED3868BD4F80}"/>
@@ -12335,7 +12335,7 @@
       </p:sp>
       <p:sp>
         <p:nvSpPr>
-          <p:cNvPr id="6" name="Espace réservé du contenu 5">
+          <p:cNvPr id="6" name="slot.body-right">
             <a:extLst>
               <a:ext uri="{FF2B5EF4-FFF2-40B4-BE49-F238E27FC236}">
                 <a16:creationId xmlns:a16="http://schemas.microsoft.com/office/drawing/2014/main" id="{C56BF488-D9DF-64BA-30D9-77D4A3CB1561}"/>
@@ -12577,7 +12577,7 @@
       </p:cxnSp>
       <p:sp>
         <p:nvSpPr>
-          <p:cNvPr id="8" name="Espace réservé du numéro de diapositive 5">
+          <p:cNvPr id="8" name="slot.footer-page">
             <a:extLst>
               <a:ext uri="{FF2B5EF4-FFF2-40B4-BE49-F238E27FC236}">
                 <a16:creationId xmlns:a16="http://schemas.microsoft.com/office/drawing/2014/main" id="{CF0FD329-A27E-51A3-480F-9C04DED50C30}"/>
@@ -12620,7 +12620,7 @@
       </p:sp>
       <p:sp>
         <p:nvSpPr>
-          <p:cNvPr id="20" name="Espace réservé du contenu 6">
+          <p:cNvPr id="20" name="slot.source">
             <a:extLst>
               <a:ext uri="{FF2B5EF4-FFF2-40B4-BE49-F238E27FC236}">
                 <a16:creationId xmlns:a16="http://schemas.microsoft.com/office/drawing/2014/main" id="{19D01319-1A5E-43BA-3540-3F52885879BC}"/>
@@ -12687,7 +12687,7 @@
       </p:sp>
       <p:sp>
         <p:nvSpPr>
-          <p:cNvPr id="9" name="ZoneTexte 30">
+          <p:cNvPr id="9" name="slot.footer-copyright">
             <a:extLst>
               <a:ext uri="{FF2B5EF4-FFF2-40B4-BE49-F238E27FC236}">
                 <a16:creationId xmlns:a16="http://schemas.microsoft.com/office/drawing/2014/main" id="{39D24033-DF4D-0ED7-1A57-92CACF576185}"/>
@@ -12741,7 +12741,7 @@
       </p:sp>
       <p:sp>
         <p:nvSpPr>
-          <p:cNvPr id="12" name="ZoneTexte 11">
+          <p:cNvPr id="12" name="slot.footer-logo">
             <a:extLst>
               <a:ext uri="{FF2B5EF4-FFF2-40B4-BE49-F238E27FC236}">
                 <a16:creationId xmlns:a16="http://schemas.microsoft.com/office/drawing/2014/main" id="{378E3F20-EC2E-870A-570B-4022DDD01109}"/>
@@ -12923,7 +12923,7 @@
       </p:graphicFrame>
       <p:sp>
         <p:nvSpPr>
-          <p:cNvPr id="2" name="Titre 1">
+          <p:cNvPr id="2" name="slot.title">
             <a:extLst>
               <a:ext uri="{FF2B5EF4-FFF2-40B4-BE49-F238E27FC236}">
                 <a16:creationId xmlns:a16="http://schemas.microsoft.com/office/drawing/2014/main" id="{8E7A6757-C645-3EC5-79F9-70135F48F1F5}"/>
@@ -12993,7 +12993,7 @@
       </p:cxnSp>
       <p:sp>
         <p:nvSpPr>
-          <p:cNvPr id="16" name="Espace réservé du contenu 6">
+          <p:cNvPr id="16" name="slot.source">
             <a:extLst>
               <a:ext uri="{FF2B5EF4-FFF2-40B4-BE49-F238E27FC236}">
                 <a16:creationId xmlns:a16="http://schemas.microsoft.com/office/drawing/2014/main" id="{1EAE700C-AA3D-B07B-6407-A28618C99CA3}"/>
@@ -13060,7 +13060,7 @@
       </p:sp>
       <p:sp>
         <p:nvSpPr>
-          <p:cNvPr id="17" name="Espace réservé du numéro de diapositive 5">
+          <p:cNvPr id="17" name="slot.footer-page">
             <a:extLst>
               <a:ext uri="{FF2B5EF4-FFF2-40B4-BE49-F238E27FC236}">
                 <a16:creationId xmlns:a16="http://schemas.microsoft.com/office/drawing/2014/main" id="{30471A69-7D18-731A-528E-0F5C73D3278C}"/>
@@ -13094,7 +13094,7 @@
       </p:sp>
       <p:sp>
         <p:nvSpPr>
-          <p:cNvPr id="4" name="ZoneTexte 30">
+          <p:cNvPr id="4" name="slot.footer-copyright">
             <a:extLst>
               <a:ext uri="{FF2B5EF4-FFF2-40B4-BE49-F238E27FC236}">
                 <a16:creationId xmlns:a16="http://schemas.microsoft.com/office/drawing/2014/main" id="{6F36171D-B542-2086-9241-E71F1886F35F}"/>
@@ -13148,7 +13148,7 @@
       </p:sp>
       <p:sp>
         <p:nvSpPr>
-          <p:cNvPr id="5" name="ZoneTexte 4">
+          <p:cNvPr id="5" name="slot.footer-logo">
             <a:extLst>
               <a:ext uri="{FF2B5EF4-FFF2-40B4-BE49-F238E27FC236}">
                 <a16:creationId xmlns:a16="http://schemas.microsoft.com/office/drawing/2014/main" id="{D41DD35C-CF64-510B-4D2D-9A5073A838A6}"/>
@@ -13379,7 +13379,7 @@
       </p:sp>
       <p:sp>
         <p:nvSpPr>
-          <p:cNvPr id="2" name="Titre 1">
+          <p:cNvPr id="2" name="slot.title">
             <a:extLst>
               <a:ext uri="{FF2B5EF4-FFF2-40B4-BE49-F238E27FC236}">
                 <a16:creationId xmlns:a16="http://schemas.microsoft.com/office/drawing/2014/main" id="{02A78A85-561E-020D-C7F8-40BBB3F191CA}"/>
@@ -13421,7 +13421,7 @@
       </p:sp>
       <p:sp>
         <p:nvSpPr>
-          <p:cNvPr id="3" name="Espace réservé du texte 2">
+          <p:cNvPr id="3" name="slot.subtitle-1">
             <a:extLst>
               <a:ext uri="{FF2B5EF4-FFF2-40B4-BE49-F238E27FC236}">
                 <a16:creationId xmlns:a16="http://schemas.microsoft.com/office/drawing/2014/main" id="{E43735A6-6302-B3D2-6BB7-6309454C5C3A}"/>
@@ -13515,7 +13515,7 @@
       </p:sp>
       <p:sp>
         <p:nvSpPr>
-          <p:cNvPr id="5" name="Espace réservé du texte 4">
+          <p:cNvPr id="5" name="slot.subtitle-2">
             <a:extLst>
               <a:ext uri="{FF2B5EF4-FFF2-40B4-BE49-F238E27FC236}">
                 <a16:creationId xmlns:a16="http://schemas.microsoft.com/office/drawing/2014/main" id="{2D35804D-7044-B129-7E2C-ED3868BD4F80}"/>
@@ -13606,7 +13606,7 @@
       </p:sp>
       <p:sp>
         <p:nvSpPr>
-          <p:cNvPr id="6" name="Espace réservé du contenu 5">
+          <p:cNvPr id="6" name="slot.body">
             <a:extLst>
               <a:ext uri="{FF2B5EF4-FFF2-40B4-BE49-F238E27FC236}">
                 <a16:creationId xmlns:a16="http://schemas.microsoft.com/office/drawing/2014/main" id="{C56BF488-D9DF-64BA-30D9-77D4A3CB1561}"/>
@@ -13762,7 +13762,7 @@
       </p:cxnSp>
       <p:sp>
         <p:nvSpPr>
-          <p:cNvPr id="7" name="Espace réservé du numéro de diapositive 5">
+          <p:cNvPr id="7" name="slot.footer-page">
             <a:extLst>
               <a:ext uri="{FF2B5EF4-FFF2-40B4-BE49-F238E27FC236}">
                 <a16:creationId xmlns:a16="http://schemas.microsoft.com/office/drawing/2014/main" id="{1A58D0F3-933B-44A0-AA4E-059DFC9A693F}"/>
@@ -13805,7 +13805,7 @@
       </p:sp>
       <p:sp>
         <p:nvSpPr>
-          <p:cNvPr id="16" name="Espace réservé du contenu 6">
+          <p:cNvPr id="16" name="slot.source">
             <a:extLst>
               <a:ext uri="{FF2B5EF4-FFF2-40B4-BE49-F238E27FC236}">
                 <a16:creationId xmlns:a16="http://schemas.microsoft.com/office/drawing/2014/main" id="{90BAEBC7-9C13-C823-651C-6CF5BCB1CA2C}"/>
@@ -13872,7 +13872,7 @@
       </p:sp>
       <p:sp>
         <p:nvSpPr>
-          <p:cNvPr id="4" name="ZoneTexte 30">
+          <p:cNvPr id="4" name="slot.footer-copyright">
             <a:extLst>
               <a:ext uri="{FF2B5EF4-FFF2-40B4-BE49-F238E27FC236}">
                 <a16:creationId xmlns:a16="http://schemas.microsoft.com/office/drawing/2014/main" id="{15305BAF-50BD-584B-DC74-C009508EB3DC}"/>
@@ -13926,7 +13926,7 @@
       </p:sp>
       <p:sp>
         <p:nvSpPr>
-          <p:cNvPr id="9" name="ZoneTexte 8">
+          <p:cNvPr id="9" name="slot.footer-logo">
             <a:extLst>
               <a:ext uri="{FF2B5EF4-FFF2-40B4-BE49-F238E27FC236}">
                 <a16:creationId xmlns:a16="http://schemas.microsoft.com/office/drawing/2014/main" id="{746F6E4E-77DF-D5C8-6FC4-15CBB7325373}"/>
@@ -14155,7 +14155,7 @@
       </p:sp>
       <p:sp>
         <p:nvSpPr>
-          <p:cNvPr id="15" name="Titre 1">
+          <p:cNvPr id="15" name="slot.title">
             <a:extLst>
               <a:ext uri="{FF2B5EF4-FFF2-40B4-BE49-F238E27FC236}">
                 <a16:creationId xmlns:a16="http://schemas.microsoft.com/office/drawing/2014/main" id="{011ADB7C-2BFE-5201-7E80-4A7CB5B2A9D7}"/>
@@ -14197,7 +14197,7 @@
       </p:sp>
       <p:sp>
         <p:nvSpPr>
-          <p:cNvPr id="16" name="Espace réservé du texte 2">
+          <p:cNvPr id="16" name="slot.subtitle-1">
             <a:extLst>
               <a:ext uri="{FF2B5EF4-FFF2-40B4-BE49-F238E27FC236}">
                 <a16:creationId xmlns:a16="http://schemas.microsoft.com/office/drawing/2014/main" id="{A6C2B456-2FBB-0CCF-35AD-10F95452A42E}"/>
@@ -14291,7 +14291,7 @@
       </p:sp>
       <p:sp>
         <p:nvSpPr>
-          <p:cNvPr id="20" name="Espace réservé du texte 4">
+          <p:cNvPr id="20" name="slot.subtitle-2">
             <a:extLst>
               <a:ext uri="{FF2B5EF4-FFF2-40B4-BE49-F238E27FC236}">
                 <a16:creationId xmlns:a16="http://schemas.microsoft.com/office/drawing/2014/main" id="{310C5BB4-05F5-13FD-06D5-F7F90D3D7573}"/>
@@ -14382,7 +14382,7 @@
       </p:sp>
       <p:sp>
         <p:nvSpPr>
-          <p:cNvPr id="23" name="Espace réservé du contenu 5">
+          <p:cNvPr id="23" name="slot.body">
             <a:extLst>
               <a:ext uri="{FF2B5EF4-FFF2-40B4-BE49-F238E27FC236}">
                 <a16:creationId xmlns:a16="http://schemas.microsoft.com/office/drawing/2014/main" id="{75B3DDDB-0FFF-0BA0-DC0E-79048AFFC69C}"/>
@@ -14538,7 +14538,7 @@
       </p:cxnSp>
       <p:sp>
         <p:nvSpPr>
-          <p:cNvPr id="25" name="Espace réservé du numéro de diapositive 5">
+          <p:cNvPr id="25" name="slot.footer-page">
             <a:extLst>
               <a:ext uri="{FF2B5EF4-FFF2-40B4-BE49-F238E27FC236}">
                 <a16:creationId xmlns:a16="http://schemas.microsoft.com/office/drawing/2014/main" id="{E7E2C119-EF2B-38F6-0525-06C871F99DB2}"/>
@@ -14581,7 +14581,7 @@
       </p:sp>
       <p:sp>
         <p:nvSpPr>
-          <p:cNvPr id="27" name="Espace réservé du contenu 6">
+          <p:cNvPr id="27" name="slot.source">
             <a:extLst>
               <a:ext uri="{FF2B5EF4-FFF2-40B4-BE49-F238E27FC236}">
                 <a16:creationId xmlns:a16="http://schemas.microsoft.com/office/drawing/2014/main" id="{86608BDE-897C-79A9-D915-0BB179DBABCE}"/>
@@ -14767,7 +14767,7 @@
       </p:sp>
       <p:sp>
         <p:nvSpPr>
-          <p:cNvPr id="4" name="ZoneTexte 30">
+          <p:cNvPr id="4" name="slot.footer-copyright">
             <a:extLst>
               <a:ext uri="{FF2B5EF4-FFF2-40B4-BE49-F238E27FC236}">
                 <a16:creationId xmlns:a16="http://schemas.microsoft.com/office/drawing/2014/main" id="{2DDB37EA-A3C9-8886-2554-B4F3286733E9}"/>
@@ -14821,7 +14821,7 @@
       </p:sp>
       <p:sp>
         <p:nvSpPr>
-          <p:cNvPr id="5" name="ZoneTexte 4">
+          <p:cNvPr id="5" name="slot.footer-logo">
             <a:extLst>
               <a:ext uri="{FF2B5EF4-FFF2-40B4-BE49-F238E27FC236}">
                 <a16:creationId xmlns:a16="http://schemas.microsoft.com/office/drawing/2014/main" id="{4171C2A4-A825-1321-2CCC-00A293AF826E}"/>
@@ -15150,7 +15150,7 @@
       </p:graphicFrame>
       <p:sp>
         <p:nvSpPr>
-          <p:cNvPr id="2" name="Titre 1">
+          <p:cNvPr id="2" name="slot.title">
             <a:extLst>
               <a:ext uri="{FF2B5EF4-FFF2-40B4-BE49-F238E27FC236}">
                 <a16:creationId xmlns:a16="http://schemas.microsoft.com/office/drawing/2014/main" id="{FCE45F8B-6B35-4416-DE1A-36DAC87E84D7}"/>
@@ -15184,7 +15184,7 @@
       </p:sp>
       <p:sp>
         <p:nvSpPr>
-          <p:cNvPr id="3" name="Espace réservé du contenu 2">
+          <p:cNvPr id="3" name="slot.body-left">
             <a:extLst>
               <a:ext uri="{FF2B5EF4-FFF2-40B4-BE49-F238E27FC236}">
                 <a16:creationId xmlns:a16="http://schemas.microsoft.com/office/drawing/2014/main" id="{DD259420-A1F5-B3E7-FA1E-AF141FA30A75}"/>
@@ -15247,7 +15247,7 @@
       </p:sp>
       <p:sp>
         <p:nvSpPr>
-          <p:cNvPr id="4" name="Sous-titre 2">
+          <p:cNvPr id="4" name="slot.subtitle">
             <a:extLst>
               <a:ext uri="{FF2B5EF4-FFF2-40B4-BE49-F238E27FC236}">
                 <a16:creationId xmlns:a16="http://schemas.microsoft.com/office/drawing/2014/main" id="{0BD151FF-774C-0F45-1C17-D35CEB240F37}"/>
@@ -15366,7 +15366,7 @@
       </p:cxnSp>
       <p:sp>
         <p:nvSpPr>
-          <p:cNvPr id="7" name="Espace réservé du numéro de diapositive 5">
+          <p:cNvPr id="7" name="slot.footer-page">
             <a:extLst>
               <a:ext uri="{FF2B5EF4-FFF2-40B4-BE49-F238E27FC236}">
                 <a16:creationId xmlns:a16="http://schemas.microsoft.com/office/drawing/2014/main" id="{E93BE603-3A6B-82E8-B096-333EF0F29FF1}"/>
@@ -15400,7 +15400,7 @@
       </p:sp>
       <p:sp>
         <p:nvSpPr>
-          <p:cNvPr id="16" name="Espace réservé du contenu 6">
+          <p:cNvPr id="16" name="slot.source">
             <a:extLst>
               <a:ext uri="{FF2B5EF4-FFF2-40B4-BE49-F238E27FC236}">
                 <a16:creationId xmlns:a16="http://schemas.microsoft.com/office/drawing/2014/main" id="{30FB613D-2E4E-C892-5E41-010F534973BA}"/>
@@ -15467,7 +15467,7 @@
       </p:sp>
       <p:sp>
         <p:nvSpPr>
-          <p:cNvPr id="5" name="ZoneTexte 30">
+          <p:cNvPr id="5" name="slot.footer-copyright">
             <a:extLst>
               <a:ext uri="{FF2B5EF4-FFF2-40B4-BE49-F238E27FC236}">
                 <a16:creationId xmlns:a16="http://schemas.microsoft.com/office/drawing/2014/main" id="{E99671A2-29BC-C486-4FDD-535AB808C56F}"/>
@@ -15521,7 +15521,7 @@
       </p:sp>
       <p:sp>
         <p:nvSpPr>
-          <p:cNvPr id="6" name="ZoneTexte 5">
+          <p:cNvPr id="6" name="slot.footer-logo">
             <a:extLst>
               <a:ext uri="{FF2B5EF4-FFF2-40B4-BE49-F238E27FC236}">
                 <a16:creationId xmlns:a16="http://schemas.microsoft.com/office/drawing/2014/main" id="{1F03ADAA-DE4B-1668-3DA4-78AC64CFC6AC}"/>
@@ -15703,7 +15703,7 @@
       </p:graphicFrame>
       <p:sp>
         <p:nvSpPr>
-          <p:cNvPr id="2" name="Titre 1">
+          <p:cNvPr id="2" name="slot.title">
             <a:extLst>
               <a:ext uri="{FF2B5EF4-FFF2-40B4-BE49-F238E27FC236}">
                 <a16:creationId xmlns:a16="http://schemas.microsoft.com/office/drawing/2014/main" id="{2177F37C-BE34-28C6-E3CA-11B0B3A1A2C2}"/>
@@ -15732,7 +15732,7 @@
       </p:sp>
       <p:sp>
         <p:nvSpPr>
-          <p:cNvPr id="3" name="Espace réservé du contenu 2">
+          <p:cNvPr id="3" name="slot.body-left">
             <a:extLst>
               <a:ext uri="{FF2B5EF4-FFF2-40B4-BE49-F238E27FC236}">
                 <a16:creationId xmlns:a16="http://schemas.microsoft.com/office/drawing/2014/main" id="{1F024AAB-E748-56F5-69CF-8D668412B46A}"/>
@@ -15831,7 +15831,7 @@
       </p:sp>
       <p:sp>
         <p:nvSpPr>
-          <p:cNvPr id="4" name="Espace réservé du contenu 3">
+          <p:cNvPr id="4" name="slot.body-left">
             <a:extLst>
               <a:ext uri="{FF2B5EF4-FFF2-40B4-BE49-F238E27FC236}">
                 <a16:creationId xmlns:a16="http://schemas.microsoft.com/office/drawing/2014/main" id="{8EB565A4-3D20-0C08-E4EA-AB81725F7D5D}"/>
@@ -15978,7 +15978,7 @@
       </p:cxnSp>
       <p:sp>
         <p:nvSpPr>
-          <p:cNvPr id="11" name="Espace réservé du numéro de diapositive 5">
+          <p:cNvPr id="11" name="slot.footer-page">
             <a:extLst>
               <a:ext uri="{FF2B5EF4-FFF2-40B4-BE49-F238E27FC236}">
                 <a16:creationId xmlns:a16="http://schemas.microsoft.com/office/drawing/2014/main" id="{1382F4B7-187B-8A42-30AA-40FBAC1ED43E}"/>
@@ -16012,7 +16012,7 @@
       </p:sp>
       <p:sp>
         <p:nvSpPr>
-          <p:cNvPr id="18" name="Espace réservé du contenu 6">
+          <p:cNvPr id="18" name="slot.body-left">
             <a:extLst>
               <a:ext uri="{FF2B5EF4-FFF2-40B4-BE49-F238E27FC236}">
                 <a16:creationId xmlns:a16="http://schemas.microsoft.com/office/drawing/2014/main" id="{134DD0FE-B05A-6304-7865-C88149104BD6}"/>
@@ -16079,7 +16079,7 @@
       </p:sp>
       <p:sp>
         <p:nvSpPr>
-          <p:cNvPr id="6" name="ZoneTexte 30">
+          <p:cNvPr id="6" name="slot.footer-copyright">
             <a:extLst>
               <a:ext uri="{FF2B5EF4-FFF2-40B4-BE49-F238E27FC236}">
                 <a16:creationId xmlns:a16="http://schemas.microsoft.com/office/drawing/2014/main" id="{4DF8E504-CA60-F860-96A9-F4BC5E46CA41}"/>
@@ -16133,7 +16133,7 @@
       </p:sp>
       <p:sp>
         <p:nvSpPr>
-          <p:cNvPr id="7" name="ZoneTexte 6">
+          <p:cNvPr id="7" name="slot.footer-logo">
             <a:extLst>
               <a:ext uri="{FF2B5EF4-FFF2-40B4-BE49-F238E27FC236}">
                 <a16:creationId xmlns:a16="http://schemas.microsoft.com/office/drawing/2014/main" id="{BB9E44C8-0E14-E627-B39C-3CC292226220}"/>
@@ -16315,7 +16315,7 @@
       </p:graphicFrame>
       <p:sp>
         <p:nvSpPr>
-          <p:cNvPr id="2" name="Titre 1">
+          <p:cNvPr id="2" name="slot.title">
             <a:extLst>
               <a:ext uri="{FF2B5EF4-FFF2-40B4-BE49-F238E27FC236}">
                 <a16:creationId xmlns:a16="http://schemas.microsoft.com/office/drawing/2014/main" id="{02A78A85-561E-020D-C7F8-40BBB3F191CA}"/>
@@ -16349,7 +16349,7 @@
       </p:sp>
       <p:sp>
         <p:nvSpPr>
-          <p:cNvPr id="3" name="Espace réservé du texte 2">
+          <p:cNvPr id="3" name="slot.subtitle-left">
             <a:extLst>
               <a:ext uri="{FF2B5EF4-FFF2-40B4-BE49-F238E27FC236}">
                 <a16:creationId xmlns:a16="http://schemas.microsoft.com/office/drawing/2014/main" id="{E43735A6-6302-B3D2-6BB7-6309454C5C3A}"/>
@@ -16427,7 +16427,7 @@
       </p:sp>
       <p:sp>
         <p:nvSpPr>
-          <p:cNvPr id="4" name="Espace réservé du contenu 3">
+          <p:cNvPr id="4" name="slot.body-left">
             <a:extLst>
               <a:ext uri="{FF2B5EF4-FFF2-40B4-BE49-F238E27FC236}">
                 <a16:creationId xmlns:a16="http://schemas.microsoft.com/office/drawing/2014/main" id="{2D3E2C40-4C7F-6E36-C2FB-962C73150210}"/>
@@ -16490,7 +16490,7 @@
       </p:sp>
       <p:sp>
         <p:nvSpPr>
-          <p:cNvPr id="5" name="Espace réservé du texte 4">
+          <p:cNvPr id="5" name="slot.subtitle-left">
             <a:extLst>
               <a:ext uri="{FF2B5EF4-FFF2-40B4-BE49-F238E27FC236}">
                 <a16:creationId xmlns:a16="http://schemas.microsoft.com/office/drawing/2014/main" id="{2D35804D-7044-B129-7E2C-ED3868BD4F80}"/>
@@ -16568,7 +16568,7 @@
       </p:sp>
       <p:sp>
         <p:nvSpPr>
-          <p:cNvPr id="6" name="Espace réservé du contenu 5">
+          <p:cNvPr id="6" name="slot.body-right">
             <a:extLst>
               <a:ext uri="{FF2B5EF4-FFF2-40B4-BE49-F238E27FC236}">
                 <a16:creationId xmlns:a16="http://schemas.microsoft.com/office/drawing/2014/main" id="{C56BF488-D9DF-64BA-30D9-77D4A3CB1561}"/>
@@ -16715,7 +16715,7 @@
       </p:cxnSp>
       <p:sp>
         <p:nvSpPr>
-          <p:cNvPr id="12" name="Espace réservé du numéro de diapositive 5">
+          <p:cNvPr id="12" name="slot.footer-page">
             <a:extLst>
               <a:ext uri="{FF2B5EF4-FFF2-40B4-BE49-F238E27FC236}">
                 <a16:creationId xmlns:a16="http://schemas.microsoft.com/office/drawing/2014/main" id="{B1FB7D05-838F-532B-0B3B-5466C302AAE2}"/>
@@ -16749,7 +16749,7 @@
       </p:sp>
       <p:sp>
         <p:nvSpPr>
-          <p:cNvPr id="18" name="Espace réservé du contenu 6">
+          <p:cNvPr id="18" name="slot.source">
             <a:extLst>
               <a:ext uri="{FF2B5EF4-FFF2-40B4-BE49-F238E27FC236}">
                 <a16:creationId xmlns:a16="http://schemas.microsoft.com/office/drawing/2014/main" id="{DD6D06F4-9510-38A2-079C-836FA0E25990}"/>
@@ -16816,7 +16816,7 @@
       </p:sp>
       <p:sp>
         <p:nvSpPr>
-          <p:cNvPr id="8" name="ZoneTexte 30">
+          <p:cNvPr id="8" name="slot.footer-copyright">
             <a:extLst>
               <a:ext uri="{FF2B5EF4-FFF2-40B4-BE49-F238E27FC236}">
                 <a16:creationId xmlns:a16="http://schemas.microsoft.com/office/drawing/2014/main" id="{3047539A-0BFC-5BB9-0072-5DE19483ABBF}"/>
@@ -16870,7 +16870,7 @@
       </p:sp>
       <p:sp>
         <p:nvSpPr>
-          <p:cNvPr id="9" name="ZoneTexte 8">
+          <p:cNvPr id="9" name="slot.footer-logo">
             <a:extLst>
               <a:ext uri="{FF2B5EF4-FFF2-40B4-BE49-F238E27FC236}">
                 <a16:creationId xmlns:a16="http://schemas.microsoft.com/office/drawing/2014/main" id="{247E3550-5CD6-33B5-5444-8A45D9F8FAC0}"/>
@@ -17052,7 +17052,7 @@
       </p:graphicFrame>
       <p:sp>
         <p:nvSpPr>
-          <p:cNvPr id="2" name="Titre 1">
+          <p:cNvPr id="2" name="slot.title">
             <a:extLst>
               <a:ext uri="{FF2B5EF4-FFF2-40B4-BE49-F238E27FC236}">
                 <a16:creationId xmlns:a16="http://schemas.microsoft.com/office/drawing/2014/main" id="{02A78A85-561E-020D-C7F8-40BBB3F191CA}"/>
@@ -17086,7 +17086,7 @@
       </p:sp>
       <p:sp>
         <p:nvSpPr>
-          <p:cNvPr id="3" name="Espace réservé du texte 2">
+          <p:cNvPr id="3" name="slot.subtitle-left">
             <a:extLst>
               <a:ext uri="{FF2B5EF4-FFF2-40B4-BE49-F238E27FC236}">
                 <a16:creationId xmlns:a16="http://schemas.microsoft.com/office/drawing/2014/main" id="{E43735A6-6302-B3D2-6BB7-6309454C5C3A}"/>
@@ -17164,7 +17164,7 @@
       </p:sp>
       <p:sp>
         <p:nvSpPr>
-          <p:cNvPr id="4" name="Espace réservé du contenu 3">
+          <p:cNvPr id="4" name="slot.body-left">
             <a:extLst>
               <a:ext uri="{FF2B5EF4-FFF2-40B4-BE49-F238E27FC236}">
                 <a16:creationId xmlns:a16="http://schemas.microsoft.com/office/drawing/2014/main" id="{2D3E2C40-4C7F-6E36-C2FB-962C73150210}"/>
@@ -17227,7 +17227,7 @@
       </p:sp>
       <p:sp>
         <p:nvSpPr>
-          <p:cNvPr id="5" name="Espace réservé du texte 4">
+          <p:cNvPr id="5" name="slot.subtitle-left">
             <a:extLst>
               <a:ext uri="{FF2B5EF4-FFF2-40B4-BE49-F238E27FC236}">
                 <a16:creationId xmlns:a16="http://schemas.microsoft.com/office/drawing/2014/main" id="{2D35804D-7044-B129-7E2C-ED3868BD4F80}"/>
@@ -17305,7 +17305,7 @@
       </p:sp>
       <p:sp>
         <p:nvSpPr>
-          <p:cNvPr id="6" name="Espace réservé du contenu 5">
+          <p:cNvPr id="6" name="slot.body-right">
             <a:extLst>
               <a:ext uri="{FF2B5EF4-FFF2-40B4-BE49-F238E27FC236}">
                 <a16:creationId xmlns:a16="http://schemas.microsoft.com/office/drawing/2014/main" id="{C56BF488-D9DF-64BA-30D9-77D4A3CB1561}"/>
@@ -17368,7 +17368,7 @@
       </p:sp>
       <p:sp>
         <p:nvSpPr>
-          <p:cNvPr id="7" name="Espace réservé du texte 2">
+          <p:cNvPr id="7" name="slot.subtitle-left">
             <a:extLst>
               <a:ext uri="{FF2B5EF4-FFF2-40B4-BE49-F238E27FC236}">
                 <a16:creationId xmlns:a16="http://schemas.microsoft.com/office/drawing/2014/main" id="{5E8252F0-DE57-E2EB-BE2E-BAD06505AF77}"/>
@@ -17446,7 +17446,7 @@
       </p:sp>
       <p:sp>
         <p:nvSpPr>
-          <p:cNvPr id="11" name="Espace réservé du contenu 3">
+          <p:cNvPr id="11" name="slot.body-left">
             <a:extLst>
               <a:ext uri="{FF2B5EF4-FFF2-40B4-BE49-F238E27FC236}">
                 <a16:creationId xmlns:a16="http://schemas.microsoft.com/office/drawing/2014/main" id="{AF4E5750-BDEC-4328-0B8F-9525E2496CFD}"/>
@@ -17653,7 +17653,7 @@
       </p:cxnSp>
       <p:sp>
         <p:nvSpPr>
-          <p:cNvPr id="16" name="Espace réservé du numéro de diapositive 5">
+          <p:cNvPr id="16" name="slot.footer-page">
             <a:extLst>
               <a:ext uri="{FF2B5EF4-FFF2-40B4-BE49-F238E27FC236}">
                 <a16:creationId xmlns:a16="http://schemas.microsoft.com/office/drawing/2014/main" id="{9591EC4D-D015-BB3F-B075-780ADAD4923D}"/>
@@ -17687,7 +17687,7 @@
       </p:sp>
       <p:sp>
         <p:nvSpPr>
-          <p:cNvPr id="23" name="Espace réservé du contenu 6">
+          <p:cNvPr id="23" name="slot.source">
             <a:extLst>
               <a:ext uri="{FF2B5EF4-FFF2-40B4-BE49-F238E27FC236}">
                 <a16:creationId xmlns:a16="http://schemas.microsoft.com/office/drawing/2014/main" id="{57B7AFE9-1481-AAAB-096A-34F44FCF4189}"/>
@@ -17754,7 +17754,7 @@
       </p:sp>
       <p:sp>
         <p:nvSpPr>
-          <p:cNvPr id="8" name="ZoneTexte 30">
+          <p:cNvPr id="8" name="slot.footer-copyright">
             <a:extLst>
               <a:ext uri="{FF2B5EF4-FFF2-40B4-BE49-F238E27FC236}">
                 <a16:creationId xmlns:a16="http://schemas.microsoft.com/office/drawing/2014/main" id="{AE48B899-D254-33FF-13F7-FB3591FAB6B1}"/>
@@ -17808,7 +17808,7 @@
       </p:sp>
       <p:sp>
         <p:nvSpPr>
-          <p:cNvPr id="9" name="ZoneTexte 8">
+          <p:cNvPr id="9" name="slot.footer-logo">
             <a:extLst>
               <a:ext uri="{FF2B5EF4-FFF2-40B4-BE49-F238E27FC236}">
                 <a16:creationId xmlns:a16="http://schemas.microsoft.com/office/drawing/2014/main" id="{5079D28D-C0D1-A414-D61D-CDD866EB1576}"/>
@@ -17990,7 +17990,7 @@
       </p:graphicFrame>
       <p:sp>
         <p:nvSpPr>
-          <p:cNvPr id="3" name="Espace réservé du numéro de diapositive 5">
+          <p:cNvPr id="3" name="slot.footer-page">
             <a:extLst>
               <a:ext uri="{FF2B5EF4-FFF2-40B4-BE49-F238E27FC236}">
                 <a16:creationId xmlns:a16="http://schemas.microsoft.com/office/drawing/2014/main" id="{AC98BCD7-B4BD-45F0-A1DC-E597AD321024}"/>
@@ -18024,7 +18024,7 @@
       </p:sp>
       <p:sp>
         <p:nvSpPr>
-          <p:cNvPr id="10" name="Espace réservé du contenu 6">
+          <p:cNvPr id="10" name="slot.source">
             <a:extLst>
               <a:ext uri="{FF2B5EF4-FFF2-40B4-BE49-F238E27FC236}">
                 <a16:creationId xmlns:a16="http://schemas.microsoft.com/office/drawing/2014/main" id="{DE645C6A-CC14-E4D3-22C9-E154707F3FF7}"/>
@@ -18384,7 +18384,7 @@
       </p:sp>
       <p:sp>
         <p:nvSpPr>
-          <p:cNvPr id="5" name="Titre 1">
+          <p:cNvPr id="5" name="slot.title">
             <a:extLst>
               <a:ext uri="{FF2B5EF4-FFF2-40B4-BE49-F238E27FC236}">
                 <a16:creationId xmlns:a16="http://schemas.microsoft.com/office/drawing/2014/main" id="{3A8C9D35-E503-FE8C-69EA-8B619E0CB8DB}"/>
@@ -18428,7 +18428,7 @@
       </p:sp>
       <p:sp>
         <p:nvSpPr>
-          <p:cNvPr id="7" name="Sous-titre 2">
+          <p:cNvPr id="7" name="slot.subtitle">
             <a:extLst>
               <a:ext uri="{FF2B5EF4-FFF2-40B4-BE49-F238E27FC236}">
                 <a16:creationId xmlns:a16="http://schemas.microsoft.com/office/drawing/2014/main" id="{C9E991B4-3678-BE6E-9D33-B6480825BFEA}"/>
@@ -18952,7 +18952,7 @@
       </p:pic>
       <p:sp>
         <p:nvSpPr>
-          <p:cNvPr id="2" name="Titre 1">
+          <p:cNvPr id="2" name="slot.section-title">
             <a:extLst>
               <a:ext uri="{FF2B5EF4-FFF2-40B4-BE49-F238E27FC236}">
                 <a16:creationId xmlns:a16="http://schemas.microsoft.com/office/drawing/2014/main" id="{1FAAFAE6-D60C-93B1-4819-060D20F8BFF4}"/>
@@ -18996,7 +18996,7 @@
       </p:sp>
       <p:sp>
         <p:nvSpPr>
-          <p:cNvPr id="3" name="Sous-titre 2">
+          <p:cNvPr id="3" name="slot.subtitle">
             <a:extLst>
               <a:ext uri="{FF2B5EF4-FFF2-40B4-BE49-F238E27FC236}">
                 <a16:creationId xmlns:a16="http://schemas.microsoft.com/office/drawing/2014/main" id="{B989298A-8D13-336B-A448-1CB247CE6E4F}"/>
@@ -19902,7 +19902,7 @@
       </p:grpSpPr>
       <p:sp>
         <p:nvSpPr>
-          <p:cNvPr id="2" name="Espace réservé pour une image  1">
+          <p:cNvPr id="2" name="slot.image">
             <a:extLst>
               <a:ext uri="{FF2B5EF4-FFF2-40B4-BE49-F238E27FC236}">
                 <a16:creationId xmlns:a16="http://schemas.microsoft.com/office/drawing/2014/main" id="{E0BCE59B-D444-7A18-DCCB-70AFE1EA42FF}"/>
@@ -19927,7 +19927,7 @@
       </p:sp>
       <p:sp>
         <p:nvSpPr>
-          <p:cNvPr id="3" name="Titre 2">
+          <p:cNvPr id="3" name="slot.title">
             <a:extLst>
               <a:ext uri="{FF2B5EF4-FFF2-40B4-BE49-F238E27FC236}">
                 <a16:creationId xmlns:a16="http://schemas.microsoft.com/office/drawing/2014/main" id="{7ACAD432-3BA2-C857-1F08-57EFA4F2680E}"/>
@@ -19952,7 +19952,7 @@
       </p:sp>
       <p:sp>
         <p:nvSpPr>
-          <p:cNvPr id="4" name="Sous-titre 3">
+          <p:cNvPr id="4" name="slot.subtitle">
             <a:extLst>
               <a:ext uri="{FF2B5EF4-FFF2-40B4-BE49-F238E27FC236}">
                 <a16:creationId xmlns:a16="http://schemas.microsoft.com/office/drawing/2014/main" id="{A7B49F1B-6722-9095-525C-4E4E2657BDB4}"/>
@@ -19977,7 +19977,7 @@
       </p:sp>
       <p:sp>
         <p:nvSpPr>
-          <p:cNvPr id="5" name="Espace réservé du texte 4">
+          <p:cNvPr id="5" name="slot.body">
             <a:extLst>
               <a:ext uri="{FF2B5EF4-FFF2-40B4-BE49-F238E27FC236}">
                 <a16:creationId xmlns:a16="http://schemas.microsoft.com/office/drawing/2014/main" id="{4CBFC38C-423B-3DD8-A88D-A1A1A9C3A913}"/>
@@ -20038,7 +20038,7 @@
       </p:grpSpPr>
       <p:sp>
         <p:nvSpPr>
-          <p:cNvPr id="11" name="Titre 10">
+          <p:cNvPr id="11" name="slot.title">
             <a:extLst>
               <a:ext uri="{FF2B5EF4-FFF2-40B4-BE49-F238E27FC236}">
                 <a16:creationId xmlns:a16="http://schemas.microsoft.com/office/drawing/2014/main" id="{5B9B5EFF-D6C0-5F6D-B181-93D9A1EEA543}"/>
@@ -20063,7 +20063,7 @@
       </p:sp>
       <p:graphicFrame>
         <p:nvGraphicFramePr>
-          <p:cNvPr id="2" name="Espace réservé du contenu 1">
+          <p:cNvPr id="2" name="slot.chart">
             <a:extLst>
               <a:ext uri="{FF2B5EF4-FFF2-40B4-BE49-F238E27FC236}">
                 <a16:creationId xmlns:a16="http://schemas.microsoft.com/office/drawing/2014/main" id="{6856BEA8-6434-0F26-881F-058CB793B77E}"/>
@@ -20094,7 +20094,7 @@
       </p:graphicFrame>
       <p:sp>
         <p:nvSpPr>
-          <p:cNvPr id="4" name="Espace réservé du numéro de diapositive 3">
+          <p:cNvPr id="4" name="slot.footer-page">
             <a:extLst>
               <a:ext uri="{FF2B5EF4-FFF2-40B4-BE49-F238E27FC236}">
                 <a16:creationId xmlns:a16="http://schemas.microsoft.com/office/drawing/2014/main" id="{A97A835A-87A2-B939-1DD1-F196BE144C01}"/>
@@ -20123,7 +20123,7 @@
       </p:sp>
       <p:sp>
         <p:nvSpPr>
-          <p:cNvPr id="12" name="Espace réservé du contenu 11">
+          <p:cNvPr id="12" name="slot.source">
             <a:extLst>
               <a:ext uri="{FF2B5EF4-FFF2-40B4-BE49-F238E27FC236}">
                 <a16:creationId xmlns:a16="http://schemas.microsoft.com/office/drawing/2014/main" id="{BBB8D210-4F84-AB0E-C916-9C28A9514921}"/>
@@ -20148,7 +20148,7 @@
       </p:sp>
       <p:sp>
         <p:nvSpPr>
-          <p:cNvPr id="10" name="Espace réservé du contenu 5">
+          <p:cNvPr id="10" name="slot.body-right">
             <a:extLst>
               <a:ext uri="{FF2B5EF4-FFF2-40B4-BE49-F238E27FC236}">
                 <a16:creationId xmlns:a16="http://schemas.microsoft.com/office/drawing/2014/main" id="{12965206-88B4-0F47-8E28-3FA959B2EF16}"/>
@@ -20387,7 +20387,7 @@
       </p:sp>
       <p:sp>
         <p:nvSpPr>
-          <p:cNvPr id="13" name="Espace réservé du contenu 5">
+          <p:cNvPr id="13" name="slot.chart-title">
             <a:extLst>
               <a:ext uri="{FF2B5EF4-FFF2-40B4-BE49-F238E27FC236}">
                 <a16:creationId xmlns:a16="http://schemas.microsoft.com/office/drawing/2014/main" id="{4B04BF95-50FB-9DF2-7E0A-AC1BBEDAB16D}"/>
@@ -20675,7 +20675,7 @@
       </p:grpSpPr>
       <p:sp>
         <p:nvSpPr>
-          <p:cNvPr id="6" name="Titre 5">
+          <p:cNvPr id="6" name="slot.title">
             <a:extLst>
               <a:ext uri="{FF2B5EF4-FFF2-40B4-BE49-F238E27FC236}">
                 <a16:creationId xmlns:a16="http://schemas.microsoft.com/office/drawing/2014/main" id="{BBC5BA43-0109-A451-0B17-1344EBBD7B3B}"/>
@@ -20700,7 +20700,7 @@
       </p:sp>
       <p:sp>
         <p:nvSpPr>
-          <p:cNvPr id="7" name="Espace réservé du contenu 6">
+          <p:cNvPr id="7" name="slot.body-left">
             <a:extLst>
               <a:ext uri="{FF2B5EF4-FFF2-40B4-BE49-F238E27FC236}">
                 <a16:creationId xmlns:a16="http://schemas.microsoft.com/office/drawing/2014/main" id="{F9A39B9F-8FE3-C5E4-66EB-23D6B854B01A}"/>
@@ -20725,7 +20725,7 @@
       </p:sp>
       <p:sp>
         <p:nvSpPr>
-          <p:cNvPr id="8" name="Espace réservé du contenu 7">
+          <p:cNvPr id="8" name="slot.body-left">
             <a:extLst>
               <a:ext uri="{FF2B5EF4-FFF2-40B4-BE49-F238E27FC236}">
                 <a16:creationId xmlns:a16="http://schemas.microsoft.com/office/drawing/2014/main" id="{37886110-4BF1-3B19-47FC-1B3A623E68F4}"/>
@@ -20750,7 +20750,7 @@
       </p:sp>
       <p:sp>
         <p:nvSpPr>
-          <p:cNvPr id="4" name="Espace réservé du numéro de diapositive 3">
+          <p:cNvPr id="4" name="slot.footer-page">
             <a:extLst>
               <a:ext uri="{FF2B5EF4-FFF2-40B4-BE49-F238E27FC236}">
                 <a16:creationId xmlns:a16="http://schemas.microsoft.com/office/drawing/2014/main" id="{955021DA-9147-47DF-2270-FA79520AA834}"/>
@@ -20779,7 +20779,7 @@
       </p:sp>
       <p:sp>
         <p:nvSpPr>
-          <p:cNvPr id="9" name="Espace réservé du contenu 8">
+          <p:cNvPr id="9" name="slot.source">
             <a:extLst>
               <a:ext uri="{FF2B5EF4-FFF2-40B4-BE49-F238E27FC236}">
                 <a16:creationId xmlns:a16="http://schemas.microsoft.com/office/drawing/2014/main" id="{08669132-B2E9-C7FD-0E5A-195E1E90B39F}"/>
@@ -20834,7 +20834,7 @@
       </p:grpSpPr>
       <p:sp>
         <p:nvSpPr>
-          <p:cNvPr id="2" name="Titre 1">
+          <p:cNvPr id="2" name="slot.title">
             <a:extLst>
               <a:ext uri="{FF2B5EF4-FFF2-40B4-BE49-F238E27FC236}">
                 <a16:creationId xmlns:a16="http://schemas.microsoft.com/office/drawing/2014/main" id="{A1B13B95-550F-B65B-3507-ADE3B9DA9E32}"/>
@@ -20859,7 +20859,7 @@
       </p:sp>
       <p:sp>
         <p:nvSpPr>
-          <p:cNvPr id="3" name="Espace réservé du texte 2">
+          <p:cNvPr id="3" name="slot.subtitle-left">
             <a:extLst>
               <a:ext uri="{FF2B5EF4-FFF2-40B4-BE49-F238E27FC236}">
                 <a16:creationId xmlns:a16="http://schemas.microsoft.com/office/drawing/2014/main" id="{472AF4BA-3A94-A6AA-75ED-51F19EF10D87}"/>
@@ -20884,7 +20884,7 @@
       </p:sp>
       <p:sp>
         <p:nvSpPr>
-          <p:cNvPr id="4" name="Espace réservé du contenu 3">
+          <p:cNvPr id="4" name="slot.body-left">
             <a:extLst>
               <a:ext uri="{FF2B5EF4-FFF2-40B4-BE49-F238E27FC236}">
                 <a16:creationId xmlns:a16="http://schemas.microsoft.com/office/drawing/2014/main" id="{B0ABFD61-CD4F-EC1A-5115-45CDDC420BF3}"/>
@@ -20909,7 +20909,7 @@
       </p:sp>
       <p:sp>
         <p:nvSpPr>
-          <p:cNvPr id="5" name="Espace réservé du texte 4">
+          <p:cNvPr id="5" name="slot.subtitle-right">
             <a:extLst>
               <a:ext uri="{FF2B5EF4-FFF2-40B4-BE49-F238E27FC236}">
                 <a16:creationId xmlns:a16="http://schemas.microsoft.com/office/drawing/2014/main" id="{DE696CA1-6E07-520A-1327-ED245650AA9E}"/>
@@ -20934,7 +20934,7 @@
       </p:sp>
       <p:sp>
         <p:nvSpPr>
-          <p:cNvPr id="6" name="Espace réservé du contenu 5">
+          <p:cNvPr id="6" name="slot.body-right">
             <a:extLst>
               <a:ext uri="{FF2B5EF4-FFF2-40B4-BE49-F238E27FC236}">
                 <a16:creationId xmlns:a16="http://schemas.microsoft.com/office/drawing/2014/main" id="{8C3FD960-175C-64AD-76A4-03C56B091E11}"/>
@@ -20959,7 +20959,7 @@
       </p:sp>
       <p:sp>
         <p:nvSpPr>
-          <p:cNvPr id="7" name="Espace réservé du numéro de diapositive 6">
+          <p:cNvPr id="7" name="slot.footer-page">
             <a:extLst>
               <a:ext uri="{FF2B5EF4-FFF2-40B4-BE49-F238E27FC236}">
                 <a16:creationId xmlns:a16="http://schemas.microsoft.com/office/drawing/2014/main" id="{AD7EC4A8-8CF5-8C79-BAB5-0AA6E55EAE76}"/>
@@ -20988,7 +20988,7 @@
       </p:sp>
       <p:sp>
         <p:nvSpPr>
-          <p:cNvPr id="8" name="Espace réservé du contenu 7">
+          <p:cNvPr id="8" name="slot.source">
             <a:extLst>
               <a:ext uri="{FF2B5EF4-FFF2-40B4-BE49-F238E27FC236}">
                 <a16:creationId xmlns:a16="http://schemas.microsoft.com/office/drawing/2014/main" id="{78FA1B2A-92F7-40FB-F965-CA4A4804D578}"/>
@@ -21043,7 +21043,7 @@
       </p:grpSpPr>
       <p:sp>
         <p:nvSpPr>
-          <p:cNvPr id="2" name="Titre 1">
+          <p:cNvPr id="2" name="slot.title">
             <a:extLst>
               <a:ext uri="{FF2B5EF4-FFF2-40B4-BE49-F238E27FC236}">
                 <a16:creationId xmlns:a16="http://schemas.microsoft.com/office/drawing/2014/main" id="{96382BF3-A58D-9FCC-73D2-D23B8E3097D6}"/>
@@ -21068,7 +21068,7 @@
       </p:sp>
       <p:sp>
         <p:nvSpPr>
-          <p:cNvPr id="3" name="Espace réservé du texte 2">
+          <p:cNvPr id="3" name="slot.subtitle-left">
             <a:extLst>
               <a:ext uri="{FF2B5EF4-FFF2-40B4-BE49-F238E27FC236}">
                 <a16:creationId xmlns:a16="http://schemas.microsoft.com/office/drawing/2014/main" id="{507C86A9-5AA4-5FEE-279D-DB62E9AF5A84}"/>
@@ -21093,7 +21093,7 @@
       </p:sp>
       <p:sp>
         <p:nvSpPr>
-          <p:cNvPr id="4" name="Espace réservé du contenu 3">
+          <p:cNvPr id="4" name="slot.body-left">
             <a:extLst>
               <a:ext uri="{FF2B5EF4-FFF2-40B4-BE49-F238E27FC236}">
                 <a16:creationId xmlns:a16="http://schemas.microsoft.com/office/drawing/2014/main" id="{1615B9A0-C888-2906-494C-2BE85967A792}"/>
@@ -21118,7 +21118,7 @@
       </p:sp>
       <p:sp>
         <p:nvSpPr>
-          <p:cNvPr id="5" name="Espace réservé du texte 4">
+          <p:cNvPr id="5" name="slot.subtitle-center">
             <a:extLst>
               <a:ext uri="{FF2B5EF4-FFF2-40B4-BE49-F238E27FC236}">
                 <a16:creationId xmlns:a16="http://schemas.microsoft.com/office/drawing/2014/main" id="{899EBAB0-D7CA-FCF6-5AE7-F3182BDD73D7}"/>
@@ -21143,7 +21143,7 @@
       </p:sp>
       <p:sp>
         <p:nvSpPr>
-          <p:cNvPr id="6" name="Espace réservé du contenu 5">
+          <p:cNvPr id="6" name="slot.body-right">
             <a:extLst>
               <a:ext uri="{FF2B5EF4-FFF2-40B4-BE49-F238E27FC236}">
                 <a16:creationId xmlns:a16="http://schemas.microsoft.com/office/drawing/2014/main" id="{15A49452-0460-60CD-1237-4332D2B7D644}"/>
@@ -21168,7 +21168,7 @@
       </p:sp>
       <p:sp>
         <p:nvSpPr>
-          <p:cNvPr id="7" name="Espace réservé du numéro de diapositive 6">
+          <p:cNvPr id="7" name="slot.footer-page">
             <a:extLst>
               <a:ext uri="{FF2B5EF4-FFF2-40B4-BE49-F238E27FC236}">
                 <a16:creationId xmlns:a16="http://schemas.microsoft.com/office/drawing/2014/main" id="{244EFA7C-21AE-6C7D-FAC2-7D19DE421203}"/>
@@ -21197,7 +21197,7 @@
       </p:sp>
       <p:sp>
         <p:nvSpPr>
-          <p:cNvPr id="8" name="Espace réservé du contenu 7">
+          <p:cNvPr id="8" name="slot.source">
             <a:extLst>
               <a:ext uri="{FF2B5EF4-FFF2-40B4-BE49-F238E27FC236}">
                 <a16:creationId xmlns:a16="http://schemas.microsoft.com/office/drawing/2014/main" id="{B421CB7E-7CF9-8773-A8E0-CBC5497D8F78}"/>
@@ -21252,7 +21252,7 @@
       </p:grpSpPr>
       <p:sp>
         <p:nvSpPr>
-          <p:cNvPr id="2" name="Titre 1">
+          <p:cNvPr id="2" name="slot.title">
             <a:extLst>
               <a:ext uri="{FF2B5EF4-FFF2-40B4-BE49-F238E27FC236}">
                 <a16:creationId xmlns:a16="http://schemas.microsoft.com/office/drawing/2014/main" id="{642C1C7A-2951-8460-E931-5812BA57EE8A}"/>
@@ -21277,7 +21277,7 @@
       </p:sp>
       <p:sp>
         <p:nvSpPr>
-          <p:cNvPr id="3" name="Espace réservé du texte 2">
+          <p:cNvPr id="3" name="slot.subtitle-1">
             <a:extLst>
               <a:ext uri="{FF2B5EF4-FFF2-40B4-BE49-F238E27FC236}">
                 <a16:creationId xmlns:a16="http://schemas.microsoft.com/office/drawing/2014/main" id="{4BE58D27-D33D-9A6A-261A-FC37592CCB76}"/>
@@ -21302,7 +21302,7 @@
       </p:sp>
       <p:sp>
         <p:nvSpPr>
-          <p:cNvPr id="4" name="Espace réservé du texte 3">
+          <p:cNvPr id="4" name="slot.subtitle-2">
             <a:extLst>
               <a:ext uri="{FF2B5EF4-FFF2-40B4-BE49-F238E27FC236}">
                 <a16:creationId xmlns:a16="http://schemas.microsoft.com/office/drawing/2014/main" id="{4358881E-4F55-3D28-CF02-3F4E9115E333}"/>
@@ -21327,7 +21327,7 @@
       </p:sp>
       <p:sp>
         <p:nvSpPr>
-          <p:cNvPr id="5" name="Espace réservé du contenu 4">
+          <p:cNvPr id="5" name="slot.body">
             <a:extLst>
               <a:ext uri="{FF2B5EF4-FFF2-40B4-BE49-F238E27FC236}">
                 <a16:creationId xmlns:a16="http://schemas.microsoft.com/office/drawing/2014/main" id="{8705FAFD-60FB-F8C7-491E-8FB862F9C8A6}"/>
@@ -21352,7 +21352,7 @@
       </p:sp>
       <p:sp>
         <p:nvSpPr>
-          <p:cNvPr id="6" name="Espace réservé du numéro de diapositive 5">
+          <p:cNvPr id="6" name="slot.footer-page">
             <a:extLst>
               <a:ext uri="{FF2B5EF4-FFF2-40B4-BE49-F238E27FC236}">
                 <a16:creationId xmlns:a16="http://schemas.microsoft.com/office/drawing/2014/main" id="{5A64BB6A-ABB8-43B5-C4FE-21B96FB0BB2E}"/>
@@ -21381,7 +21381,7 @@
       </p:sp>
       <p:sp>
         <p:nvSpPr>
-          <p:cNvPr id="7" name="Espace réservé du contenu 6">
+          <p:cNvPr id="7" name="slot.source">
             <a:extLst>
               <a:ext uri="{FF2B5EF4-FFF2-40B4-BE49-F238E27FC236}">
                 <a16:creationId xmlns:a16="http://schemas.microsoft.com/office/drawing/2014/main" id="{86E2B333-DEEF-7099-9A0E-5BCFE4306828}"/>
@@ -21436,7 +21436,7 @@
       </p:grpSpPr>
       <p:sp>
         <p:nvSpPr>
-          <p:cNvPr id="2" name="Titre 1">
+          <p:cNvPr id="2" name="slot.title">
             <a:extLst>
               <a:ext uri="{FF2B5EF4-FFF2-40B4-BE49-F238E27FC236}">
                 <a16:creationId xmlns:a16="http://schemas.microsoft.com/office/drawing/2014/main" id="{F04B6622-6B31-137C-3057-BEC114E1EA0A}"/>
@@ -21461,7 +21461,7 @@
       </p:sp>
       <p:sp>
         <p:nvSpPr>
-          <p:cNvPr id="3" name="Espace réservé du texte 2">
+          <p:cNvPr id="3" name="slot.subtitle-left">
             <a:extLst>
               <a:ext uri="{FF2B5EF4-FFF2-40B4-BE49-F238E27FC236}">
                 <a16:creationId xmlns:a16="http://schemas.microsoft.com/office/drawing/2014/main" id="{9BECFB8F-18AF-4F46-A86C-FEBFF34FBD84}"/>
@@ -21486,7 +21486,7 @@
       </p:sp>
       <p:sp>
         <p:nvSpPr>
-          <p:cNvPr id="4" name="Espace réservé du contenu 3">
+          <p:cNvPr id="4" name="slot.body-left">
             <a:extLst>
               <a:ext uri="{FF2B5EF4-FFF2-40B4-BE49-F238E27FC236}">
                 <a16:creationId xmlns:a16="http://schemas.microsoft.com/office/drawing/2014/main" id="{92B2C9B2-1C38-1A3B-A3B6-94D76323AA00}"/>
@@ -21511,7 +21511,7 @@
       </p:sp>
       <p:sp>
         <p:nvSpPr>
-          <p:cNvPr id="5" name="Espace réservé du texte 4">
+          <p:cNvPr id="5" name="slot.subtitle-right">
             <a:extLst>
               <a:ext uri="{FF2B5EF4-FFF2-40B4-BE49-F238E27FC236}">
                 <a16:creationId xmlns:a16="http://schemas.microsoft.com/office/drawing/2014/main" id="{F2F573AA-32F1-9474-AA0B-5F748B545775}"/>
@@ -21536,7 +21536,7 @@
       </p:sp>
       <p:sp>
         <p:nvSpPr>
-          <p:cNvPr id="6" name="Espace réservé du contenu 5">
+          <p:cNvPr id="6" name="slot.body-right">
             <a:extLst>
               <a:ext uri="{FF2B5EF4-FFF2-40B4-BE49-F238E27FC236}">
                 <a16:creationId xmlns:a16="http://schemas.microsoft.com/office/drawing/2014/main" id="{209746BB-053D-5EAC-CCE0-A0561FCC3E14}"/>
@@ -21561,7 +21561,7 @@
       </p:sp>
       <p:sp>
         <p:nvSpPr>
-          <p:cNvPr id="7" name="Espace réservé du texte 6">
+          <p:cNvPr id="7" name="slot.subtitle-middle">
             <a:extLst>
               <a:ext uri="{FF2B5EF4-FFF2-40B4-BE49-F238E27FC236}">
                 <a16:creationId xmlns:a16="http://schemas.microsoft.com/office/drawing/2014/main" id="{82EE0964-0DD7-A113-68C6-51DE83E049B7}"/>
@@ -21586,7 +21586,7 @@
       </p:sp>
       <p:sp>
         <p:nvSpPr>
-          <p:cNvPr id="8" name="Espace réservé du contenu 7">
+          <p:cNvPr id="8" name="slot.body-center">
             <a:extLst>
               <a:ext uri="{FF2B5EF4-FFF2-40B4-BE49-F238E27FC236}">
                 <a16:creationId xmlns:a16="http://schemas.microsoft.com/office/drawing/2014/main" id="{4E8625F8-C8B3-70DA-59F3-2E8F89562010}"/>
@@ -21611,7 +21611,7 @@
       </p:sp>
       <p:sp>
         <p:nvSpPr>
-          <p:cNvPr id="9" name="Espace réservé du numéro de diapositive 8">
+          <p:cNvPr id="9" name="slot.footer-page">
             <a:extLst>
               <a:ext uri="{FF2B5EF4-FFF2-40B4-BE49-F238E27FC236}">
                 <a16:creationId xmlns:a16="http://schemas.microsoft.com/office/drawing/2014/main" id="{56BA1548-2B85-A72F-BEF1-2AF72880F211}"/>
@@ -21640,7 +21640,7 @@
       </p:sp>
       <p:sp>
         <p:nvSpPr>
-          <p:cNvPr id="10" name="Espace réservé du contenu 9">
+          <p:cNvPr id="10" name="slot.source">
             <a:extLst>
               <a:ext uri="{FF2B5EF4-FFF2-40B4-BE49-F238E27FC236}">
                 <a16:creationId xmlns:a16="http://schemas.microsoft.com/office/drawing/2014/main" id="{94A0CC14-B06D-8574-9642-42CAE0EDB56C}"/>
@@ -21695,7 +21695,7 @@
       </p:grpSpPr>
       <p:sp>
         <p:nvSpPr>
-          <p:cNvPr id="2" name="Titre 1">
+          <p:cNvPr id="2" name="slot.title">
             <a:extLst>
               <a:ext uri="{FF2B5EF4-FFF2-40B4-BE49-F238E27FC236}">
                 <a16:creationId xmlns:a16="http://schemas.microsoft.com/office/drawing/2014/main" id="{3F90EC06-30A6-F2AF-B561-806978C6E639}"/>
@@ -21720,7 +21720,7 @@
       </p:sp>
       <p:sp>
         <p:nvSpPr>
-          <p:cNvPr id="3" name="Espace réservé du contenu 2">
+          <p:cNvPr id="3" name="slot.body-left">
             <a:extLst>
               <a:ext uri="{FF2B5EF4-FFF2-40B4-BE49-F238E27FC236}">
                 <a16:creationId xmlns:a16="http://schemas.microsoft.com/office/drawing/2014/main" id="{BF51E751-4D1F-8AFF-4DDB-151A4B82F877}"/>
@@ -21745,7 +21745,7 @@
       </p:sp>
       <p:sp>
         <p:nvSpPr>
-          <p:cNvPr id="4" name="Espace réservé du numéro de diapositive 3">
+          <p:cNvPr id="4" name="slot.footer-page">
             <a:extLst>
               <a:ext uri="{FF2B5EF4-FFF2-40B4-BE49-F238E27FC236}">
                 <a16:creationId xmlns:a16="http://schemas.microsoft.com/office/drawing/2014/main" id="{0E735BF3-7AFE-76C1-631C-652548B2CDC7}"/>
@@ -21805,7 +21805,7 @@
       </p:grpSpPr>
       <p:sp>
         <p:nvSpPr>
-          <p:cNvPr id="2" name="Titre 1">
+          <p:cNvPr id="2" name="slot.title">
             <a:extLst>
               <a:ext uri="{FF2B5EF4-FFF2-40B4-BE49-F238E27FC236}">
                 <a16:creationId xmlns:a16="http://schemas.microsoft.com/office/drawing/2014/main" id="{09AD6002-5264-FF81-5C58-8257C5BE35E0}"/>
@@ -21830,7 +21830,7 @@
       </p:sp>
       <p:sp>
         <p:nvSpPr>
-          <p:cNvPr id="3" name="Espace réservé du texte 2">
+          <p:cNvPr id="3" name="slot.subtitle-left">
             <a:extLst>
               <a:ext uri="{FF2B5EF4-FFF2-40B4-BE49-F238E27FC236}">
                 <a16:creationId xmlns:a16="http://schemas.microsoft.com/office/drawing/2014/main" id="{3DA0BAAF-9233-FECD-C9A4-9D6BB9CB133F}"/>
@@ -21855,7 +21855,7 @@
       </p:sp>
       <p:sp>
         <p:nvSpPr>
-          <p:cNvPr id="4" name="Espace réservé du contenu 3">
+          <p:cNvPr id="4" name="slot.body-left">
             <a:extLst>
               <a:ext uri="{FF2B5EF4-FFF2-40B4-BE49-F238E27FC236}">
                 <a16:creationId xmlns:a16="http://schemas.microsoft.com/office/drawing/2014/main" id="{9F86A069-0F52-B4CB-EABB-F7F2BE1DDC39}"/>
@@ -21880,7 +21880,7 @@
       </p:sp>
       <p:sp>
         <p:nvSpPr>
-          <p:cNvPr id="5" name="Espace réservé du texte 4">
+          <p:cNvPr id="5" name="slot.subtitle-center">
             <a:extLst>
               <a:ext uri="{FF2B5EF4-FFF2-40B4-BE49-F238E27FC236}">
                 <a16:creationId xmlns:a16="http://schemas.microsoft.com/office/drawing/2014/main" id="{3F8F4092-5C55-47A8-80BF-15DB6F705E87}"/>
@@ -21905,7 +21905,7 @@
       </p:sp>
       <p:sp>
         <p:nvSpPr>
-          <p:cNvPr id="6" name="Espace réservé du contenu 5">
+          <p:cNvPr id="6" name="slot.body-right">
             <a:extLst>
               <a:ext uri="{FF2B5EF4-FFF2-40B4-BE49-F238E27FC236}">
                 <a16:creationId xmlns:a16="http://schemas.microsoft.com/office/drawing/2014/main" id="{4FD0BBC1-AF6B-7FB2-8131-9CFFE5B4F720}"/>
@@ -21930,7 +21930,7 @@
       </p:sp>
       <p:sp>
         <p:nvSpPr>
-          <p:cNvPr id="7" name="Espace réservé du numéro de diapositive 6">
+          <p:cNvPr id="7" name="slot.footer-page">
             <a:extLst>
               <a:ext uri="{FF2B5EF4-FFF2-40B4-BE49-F238E27FC236}">
                 <a16:creationId xmlns:a16="http://schemas.microsoft.com/office/drawing/2014/main" id="{85C13A4A-3651-3F41-649E-1290DB09A996}"/>
@@ -21959,7 +21959,7 @@
       </p:sp>
       <p:sp>
         <p:nvSpPr>
-          <p:cNvPr id="8" name="Espace réservé du contenu 7">
+          <p:cNvPr id="8" name="slot.source">
             <a:extLst>
               <a:ext uri="{FF2B5EF4-FFF2-40B4-BE49-F238E27FC236}">
                 <a16:creationId xmlns:a16="http://schemas.microsoft.com/office/drawing/2014/main" id="{DBFFDC8F-D14C-28D8-B388-6724C21B4BA1}"/>
@@ -22014,7 +22014,7 @@
       </p:grpSpPr>
       <p:sp>
         <p:nvSpPr>
-          <p:cNvPr id="2" name="Espace réservé du numéro de diapositive 1">
+          <p:cNvPr id="2" name="slot.footer-page">
             <a:extLst>
               <a:ext uri="{FF2B5EF4-FFF2-40B4-BE49-F238E27FC236}">
                 <a16:creationId xmlns:a16="http://schemas.microsoft.com/office/drawing/2014/main" id="{F8C126C1-B24A-39D2-94A0-FFACD11454AA}"/>
@@ -22043,7 +22043,7 @@
       </p:sp>
       <p:sp>
         <p:nvSpPr>
-          <p:cNvPr id="3" name="Espace réservé du contenu 2">
+          <p:cNvPr id="3" name="slot.source">
             <a:extLst>
               <a:ext uri="{FF2B5EF4-FFF2-40B4-BE49-F238E27FC236}">
                 <a16:creationId xmlns:a16="http://schemas.microsoft.com/office/drawing/2014/main" id="{EDAB797B-BD47-F8EB-9C7B-5DD0CFEBADB8}"/>
@@ -22098,7 +22098,7 @@
       </p:grpSpPr>
       <p:sp>
         <p:nvSpPr>
-          <p:cNvPr id="2" name="Titre 1">
+          <p:cNvPr id="2" name="slot.title">
             <a:extLst>
               <a:ext uri="{FF2B5EF4-FFF2-40B4-BE49-F238E27FC236}">
                 <a16:creationId xmlns:a16="http://schemas.microsoft.com/office/drawing/2014/main" id="{374C00EF-B038-0C65-A241-7BA2006BD93D}"/>
@@ -22123,7 +22123,7 @@
       </p:sp>
       <p:sp>
         <p:nvSpPr>
-          <p:cNvPr id="3" name="Sous-titre 2">
+          <p:cNvPr id="3" name="slot.subtitle">
             <a:extLst>
               <a:ext uri="{FF2B5EF4-FFF2-40B4-BE49-F238E27FC236}">
                 <a16:creationId xmlns:a16="http://schemas.microsoft.com/office/drawing/2014/main" id="{B200C2F0-0A4E-E4B1-6889-CCD71BAA093E}"/>
@@ -22148,7 +22148,7 @@
       </p:sp>
       <p:sp>
         <p:nvSpPr>
-          <p:cNvPr id="4" name="Espace réservé du texte 3">
+          <p:cNvPr id="4" name="slot.body">
             <a:extLst>
               <a:ext uri="{FF2B5EF4-FFF2-40B4-BE49-F238E27FC236}">
                 <a16:creationId xmlns:a16="http://schemas.microsoft.com/office/drawing/2014/main" id="{64EDA83A-70CF-2093-E08B-6577F07B93B0}"/>
@@ -22173,7 +22173,7 @@
       </p:sp>
       <p:sp>
         <p:nvSpPr>
-          <p:cNvPr id="5" name="Espace réservé pour une image  4">
+          <p:cNvPr id="5" name="slot.image">
             <a:extLst>
               <a:ext uri="{FF2B5EF4-FFF2-40B4-BE49-F238E27FC236}">
                 <a16:creationId xmlns:a16="http://schemas.microsoft.com/office/drawing/2014/main" id="{03704343-FDF9-0B04-E26C-C52FDAC38AE3}"/>
@@ -22228,7 +22228,7 @@
       </p:grpSpPr>
       <p:sp>
         <p:nvSpPr>
-          <p:cNvPr id="2" name="Titre 1">
+          <p:cNvPr id="2" name="slot.section-title">
             <a:extLst>
               <a:ext uri="{FF2B5EF4-FFF2-40B4-BE49-F238E27FC236}">
                 <a16:creationId xmlns:a16="http://schemas.microsoft.com/office/drawing/2014/main" id="{F1BC0C3D-26C5-B176-7BFF-6520034413BA}"/>
@@ -22253,7 +22253,7 @@
       </p:sp>
       <p:sp>
         <p:nvSpPr>
-          <p:cNvPr id="3" name="Sous-titre 2">
+          <p:cNvPr id="3" name="slot.subtitle">
             <a:extLst>
               <a:ext uri="{FF2B5EF4-FFF2-40B4-BE49-F238E27FC236}">
                 <a16:creationId xmlns:a16="http://schemas.microsoft.com/office/drawing/2014/main" id="{72D99522-BBC2-339A-157B-E266188B49E5}"/>
@@ -22308,7 +22308,7 @@
       </p:grpSpPr>
       <p:sp>
         <p:nvSpPr>
-          <p:cNvPr id="2" name="Titre 1">
+          <p:cNvPr id="2" name="slot.section-title">
             <a:extLst>
               <a:ext uri="{FF2B5EF4-FFF2-40B4-BE49-F238E27FC236}">
                 <a16:creationId xmlns:a16="http://schemas.microsoft.com/office/drawing/2014/main" id="{7ABCA97C-1EB3-759D-152E-F5D49FB8B12D}"/>
@@ -22333,7 +22333,7 @@
       </p:sp>
       <p:sp>
         <p:nvSpPr>
-          <p:cNvPr id="3" name="Sous-titre 2">
+          <p:cNvPr id="3" name="slot.subtitle">
             <a:extLst>
               <a:ext uri="{FF2B5EF4-FFF2-40B4-BE49-F238E27FC236}">
                 <a16:creationId xmlns:a16="http://schemas.microsoft.com/office/drawing/2014/main" id="{10574AA7-F19E-53D0-15C6-BAED9DD9AE99}"/>
@@ -22388,7 +22388,7 @@
       </p:grpSpPr>
       <p:sp>
         <p:nvSpPr>
-          <p:cNvPr id="2" name="Titre 1">
+          <p:cNvPr id="2" name="slot.title">
             <a:extLst>
               <a:ext uri="{FF2B5EF4-FFF2-40B4-BE49-F238E27FC236}">
                 <a16:creationId xmlns:a16="http://schemas.microsoft.com/office/drawing/2014/main" id="{3557F5E2-DE24-B1BE-806A-41DFD0EA573B}"/>
@@ -22413,7 +22413,7 @@
       </p:sp>
       <p:sp>
         <p:nvSpPr>
-          <p:cNvPr id="3" name="Espace réservé du numéro de diapositive 2">
+          <p:cNvPr id="3" name="slot.footer-page">
             <a:extLst>
               <a:ext uri="{FF2B5EF4-FFF2-40B4-BE49-F238E27FC236}">
                 <a16:creationId xmlns:a16="http://schemas.microsoft.com/office/drawing/2014/main" id="{E389FC4E-69D2-CB98-99E0-8235C5DF4832}"/>
@@ -22442,7 +22442,7 @@
       </p:sp>
       <p:sp>
         <p:nvSpPr>
-          <p:cNvPr id="4" name="Espace réservé du contenu 3">
+          <p:cNvPr id="4" name="slot.body-left">
             <a:extLst>
               <a:ext uri="{FF2B5EF4-FFF2-40B4-BE49-F238E27FC236}">
                 <a16:creationId xmlns:a16="http://schemas.microsoft.com/office/drawing/2014/main" id="{57014636-1242-DAAA-256A-ED368B606BEC}"/>
@@ -22497,7 +22497,7 @@
       </p:grpSpPr>
       <p:sp>
         <p:nvSpPr>
-          <p:cNvPr id="2" name="Titre 1">
+          <p:cNvPr id="2" name="slot.title">
             <a:extLst>
               <a:ext uri="{FF2B5EF4-FFF2-40B4-BE49-F238E27FC236}">
                 <a16:creationId xmlns:a16="http://schemas.microsoft.com/office/drawing/2014/main" id="{AD338188-5DE4-C5CB-FE17-B4AE4BD42079}"/>
@@ -22522,7 +22522,7 @@
       </p:sp>
       <p:sp>
         <p:nvSpPr>
-          <p:cNvPr id="3" name="Espace réservé du texte 2">
+          <p:cNvPr id="3" name="slot.subtitle-1">
             <a:extLst>
               <a:ext uri="{FF2B5EF4-FFF2-40B4-BE49-F238E27FC236}">
                 <a16:creationId xmlns:a16="http://schemas.microsoft.com/office/drawing/2014/main" id="{57F5E41D-FE93-0A76-9D73-D1E1F79C27F3}"/>
@@ -22547,7 +22547,7 @@
       </p:sp>
       <p:sp>
         <p:nvSpPr>
-          <p:cNvPr id="4" name="Espace réservé du texte 3">
+          <p:cNvPr id="4" name="slot.subtitle-2">
             <a:extLst>
               <a:ext uri="{FF2B5EF4-FFF2-40B4-BE49-F238E27FC236}">
                 <a16:creationId xmlns:a16="http://schemas.microsoft.com/office/drawing/2014/main" id="{FE9D7C8C-FA55-7BC1-9885-70240B5F619E}"/>
@@ -22572,7 +22572,7 @@
       </p:sp>
       <p:sp>
         <p:nvSpPr>
-          <p:cNvPr id="5" name="Espace réservé du contenu 4">
+          <p:cNvPr id="5" name="slot.body">
             <a:extLst>
               <a:ext uri="{FF2B5EF4-FFF2-40B4-BE49-F238E27FC236}">
                 <a16:creationId xmlns:a16="http://schemas.microsoft.com/office/drawing/2014/main" id="{F04F6FA0-64EA-A96F-77DB-DC9007910239}"/>
@@ -22597,7 +22597,7 @@
       </p:sp>
       <p:sp>
         <p:nvSpPr>
-          <p:cNvPr id="6" name="Espace réservé du numéro de diapositive 5">
+          <p:cNvPr id="6" name="slot.footer-page">
             <a:extLst>
               <a:ext uri="{FF2B5EF4-FFF2-40B4-BE49-F238E27FC236}">
                 <a16:creationId xmlns:a16="http://schemas.microsoft.com/office/drawing/2014/main" id="{93029647-4684-D393-CF0A-BF12BF20539B}"/>
@@ -22626,7 +22626,7 @@
       </p:sp>
       <p:sp>
         <p:nvSpPr>
-          <p:cNvPr id="7" name="Espace réservé du contenu 6">
+          <p:cNvPr id="7" name="slot.source">
             <a:extLst>
               <a:ext uri="{FF2B5EF4-FFF2-40B4-BE49-F238E27FC236}">
                 <a16:creationId xmlns:a16="http://schemas.microsoft.com/office/drawing/2014/main" id="{7D007424-99FE-9625-45E0-4F3C4A8FB982}"/>
@@ -22681,7 +22681,7 @@
       </p:grpSpPr>
       <p:sp>
         <p:nvSpPr>
-          <p:cNvPr id="2" name="Titre 1">
+          <p:cNvPr id="2" name="slot.title">
             <a:extLst>
               <a:ext uri="{FF2B5EF4-FFF2-40B4-BE49-F238E27FC236}">
                 <a16:creationId xmlns:a16="http://schemas.microsoft.com/office/drawing/2014/main" id="{60196F93-28B3-0AC4-E12E-B919C02EDE9E}"/>
@@ -22706,7 +22706,7 @@
       </p:sp>
       <p:sp>
         <p:nvSpPr>
-          <p:cNvPr id="3" name="Espace réservé du texte 2">
+          <p:cNvPr id="3" name="slot.subtitle-left">
             <a:extLst>
               <a:ext uri="{FF2B5EF4-FFF2-40B4-BE49-F238E27FC236}">
                 <a16:creationId xmlns:a16="http://schemas.microsoft.com/office/drawing/2014/main" id="{F5334444-FCDF-1684-3FB8-353DDE1A56F3}"/>
@@ -22731,7 +22731,7 @@
       </p:sp>
       <p:sp>
         <p:nvSpPr>
-          <p:cNvPr id="4" name="Espace réservé du contenu 3">
+          <p:cNvPr id="4" name="slot.body-left">
             <a:extLst>
               <a:ext uri="{FF2B5EF4-FFF2-40B4-BE49-F238E27FC236}">
                 <a16:creationId xmlns:a16="http://schemas.microsoft.com/office/drawing/2014/main" id="{FD352B93-713D-7B29-0C96-707BE1CD5EB1}"/>
@@ -22756,7 +22756,7 @@
       </p:sp>
       <p:sp>
         <p:nvSpPr>
-          <p:cNvPr id="5" name="Espace réservé du texte 4">
+          <p:cNvPr id="5" name="slot.subtitle-right">
             <a:extLst>
               <a:ext uri="{FF2B5EF4-FFF2-40B4-BE49-F238E27FC236}">
                 <a16:creationId xmlns:a16="http://schemas.microsoft.com/office/drawing/2014/main" id="{2155886C-20D1-8079-4E2C-A73C6BE8B440}"/>
@@ -22781,7 +22781,7 @@
       </p:sp>
       <p:sp>
         <p:nvSpPr>
-          <p:cNvPr id="6" name="Espace réservé du contenu 5">
+          <p:cNvPr id="6" name="slot.body-right">
             <a:extLst>
               <a:ext uri="{FF2B5EF4-FFF2-40B4-BE49-F238E27FC236}">
                 <a16:creationId xmlns:a16="http://schemas.microsoft.com/office/drawing/2014/main" id="{F79C5220-BA0D-98C6-8A4B-CC116CD16EFD}"/>
@@ -22806,7 +22806,7 @@
       </p:sp>
       <p:sp>
         <p:nvSpPr>
-          <p:cNvPr id="7" name="Espace réservé du numéro de diapositive 6">
+          <p:cNvPr id="7" name="slot.footer-page">
             <a:extLst>
               <a:ext uri="{FF2B5EF4-FFF2-40B4-BE49-F238E27FC236}">
                 <a16:creationId xmlns:a16="http://schemas.microsoft.com/office/drawing/2014/main" id="{3F8D98DD-0E84-F6F8-641C-DE30A625FDBA}"/>
@@ -22836,7 +22836,7 @@
       </p:sp>
       <p:sp>
         <p:nvSpPr>
-          <p:cNvPr id="8" name="Espace réservé du contenu 7">
+          <p:cNvPr id="8" name="slot.source">
             <a:extLst>
               <a:ext uri="{FF2B5EF4-FFF2-40B4-BE49-F238E27FC236}">
                 <a16:creationId xmlns:a16="http://schemas.microsoft.com/office/drawing/2014/main" id="{B74E6D85-D63B-5397-6C95-9A1C410A807A}"/>
@@ -22891,7 +22891,7 @@
       </p:grpSpPr>
       <p:sp>
         <p:nvSpPr>
-          <p:cNvPr id="2" name="Titre 1">
+          <p:cNvPr id="2" name="slot.title">
             <a:extLst>
               <a:ext uri="{FF2B5EF4-FFF2-40B4-BE49-F238E27FC236}">
                 <a16:creationId xmlns:a16="http://schemas.microsoft.com/office/drawing/2014/main" id="{A1CFCE2F-EEED-699F-16B7-14583F29EE31}"/>
@@ -22916,7 +22916,7 @@
       </p:sp>
       <p:sp>
         <p:nvSpPr>
-          <p:cNvPr id="3" name="Espace réservé du texte 2">
+          <p:cNvPr id="3" name="slot.subtitle-left">
             <a:extLst>
               <a:ext uri="{FF2B5EF4-FFF2-40B4-BE49-F238E27FC236}">
                 <a16:creationId xmlns:a16="http://schemas.microsoft.com/office/drawing/2014/main" id="{52EE0DEE-BE02-0E60-46F1-9B17BE9DCC2C}"/>
@@ -22941,7 +22941,7 @@
       </p:sp>
       <p:sp>
         <p:nvSpPr>
-          <p:cNvPr id="4" name="Espace réservé du contenu 3">
+          <p:cNvPr id="4" name="slot.body-left">
             <a:extLst>
               <a:ext uri="{FF2B5EF4-FFF2-40B4-BE49-F238E27FC236}">
                 <a16:creationId xmlns:a16="http://schemas.microsoft.com/office/drawing/2014/main" id="{6DEB6691-49FC-D5CD-00E2-956161A686E3}"/>
@@ -22966,7 +22966,7 @@
       </p:sp>
       <p:sp>
         <p:nvSpPr>
-          <p:cNvPr id="5" name="Espace réservé du texte 4">
+          <p:cNvPr id="5" name="slot.subtitle-center">
             <a:extLst>
               <a:ext uri="{FF2B5EF4-FFF2-40B4-BE49-F238E27FC236}">
                 <a16:creationId xmlns:a16="http://schemas.microsoft.com/office/drawing/2014/main" id="{A6481CB5-EAF6-34D0-38D2-004DF250D138}"/>
@@ -22991,7 +22991,7 @@
       </p:sp>
       <p:sp>
         <p:nvSpPr>
-          <p:cNvPr id="6" name="Espace réservé du contenu 5">
+          <p:cNvPr id="6" name="slot.body-right">
             <a:extLst>
               <a:ext uri="{FF2B5EF4-FFF2-40B4-BE49-F238E27FC236}">
                 <a16:creationId xmlns:a16="http://schemas.microsoft.com/office/drawing/2014/main" id="{CCBAEE9E-9656-7330-1450-08204C79A982}"/>
@@ -23016,7 +23016,7 @@
       </p:sp>
       <p:sp>
         <p:nvSpPr>
-          <p:cNvPr id="7" name="Espace réservé du numéro de diapositive 6">
+          <p:cNvPr id="7" name="slot.footer-page">
             <a:extLst>
               <a:ext uri="{FF2B5EF4-FFF2-40B4-BE49-F238E27FC236}">
                 <a16:creationId xmlns:a16="http://schemas.microsoft.com/office/drawing/2014/main" id="{C737C2DD-0597-C781-B47B-9ED87A6858D2}"/>
@@ -23046,7 +23046,7 @@
       </p:sp>
       <p:sp>
         <p:nvSpPr>
-          <p:cNvPr id="8" name="Espace réservé du contenu 7">
+          <p:cNvPr id="8" name="slot.source">
             <a:extLst>
               <a:ext uri="{FF2B5EF4-FFF2-40B4-BE49-F238E27FC236}">
                 <a16:creationId xmlns:a16="http://schemas.microsoft.com/office/drawing/2014/main" id="{E45008B4-06ED-42AB-99A0-FF2AA10C8FC1}"/>
@@ -23101,7 +23101,7 @@
       </p:grpSpPr>
       <p:sp>
         <p:nvSpPr>
-          <p:cNvPr id="2" name="Titre 1">
+          <p:cNvPr id="2" name="slot.title">
             <a:extLst>
               <a:ext uri="{FF2B5EF4-FFF2-40B4-BE49-F238E27FC236}">
                 <a16:creationId xmlns:a16="http://schemas.microsoft.com/office/drawing/2014/main" id="{4E843E8F-F946-1ADE-FB37-0EBF4D9CBEF8}"/>
@@ -23126,7 +23126,7 @@
       </p:sp>
       <p:sp>
         <p:nvSpPr>
-          <p:cNvPr id="3" name="Espace réservé du texte 2">
+          <p:cNvPr id="3" name="slot.subtitle-1">
             <a:extLst>
               <a:ext uri="{FF2B5EF4-FFF2-40B4-BE49-F238E27FC236}">
                 <a16:creationId xmlns:a16="http://schemas.microsoft.com/office/drawing/2014/main" id="{1675CAD6-9E20-BF63-6D76-BAE57FC8D65D}"/>
@@ -23151,7 +23151,7 @@
       </p:sp>
       <p:sp>
         <p:nvSpPr>
-          <p:cNvPr id="4" name="Espace réservé du texte 3">
+          <p:cNvPr id="4" name="slot.subtitle-2">
             <a:extLst>
               <a:ext uri="{FF2B5EF4-FFF2-40B4-BE49-F238E27FC236}">
                 <a16:creationId xmlns:a16="http://schemas.microsoft.com/office/drawing/2014/main" id="{103ADEE2-BB69-96C8-ECF0-FBB50E9BFEA1}"/>
@@ -23176,7 +23176,7 @@
       </p:sp>
       <p:sp>
         <p:nvSpPr>
-          <p:cNvPr id="5" name="Espace réservé du contenu 4">
+          <p:cNvPr id="5" name="slot.body">
             <a:extLst>
               <a:ext uri="{FF2B5EF4-FFF2-40B4-BE49-F238E27FC236}">
                 <a16:creationId xmlns:a16="http://schemas.microsoft.com/office/drawing/2014/main" id="{491EAC36-2BCB-A68E-5176-6D64BE2064F7}"/>
@@ -23201,7 +23201,7 @@
       </p:sp>
       <p:sp>
         <p:nvSpPr>
-          <p:cNvPr id="6" name="Espace réservé du numéro de diapositive 5">
+          <p:cNvPr id="6" name="slot.footer-page">
             <a:extLst>
               <a:ext uri="{FF2B5EF4-FFF2-40B4-BE49-F238E27FC236}">
                 <a16:creationId xmlns:a16="http://schemas.microsoft.com/office/drawing/2014/main" id="{0CF94BA1-CADC-3BB5-F63F-E912932EAE7F}"/>
@@ -23231,7 +23231,7 @@
       </p:sp>
       <p:sp>
         <p:nvSpPr>
-          <p:cNvPr id="7" name="Espace réservé du contenu 6">
+          <p:cNvPr id="7" name="slot.source">
             <a:extLst>
               <a:ext uri="{FF2B5EF4-FFF2-40B4-BE49-F238E27FC236}">
                 <a16:creationId xmlns:a16="http://schemas.microsoft.com/office/drawing/2014/main" id="{DA655AE8-4AB0-E991-4F30-5F6219C4F5C4}"/>
@@ -23286,7 +23286,7 @@
       </p:grpSpPr>
       <p:sp>
         <p:nvSpPr>
-          <p:cNvPr id="2" name="Titre 1">
+          <p:cNvPr id="2" name="slot.title">
             <a:extLst>
               <a:ext uri="{FF2B5EF4-FFF2-40B4-BE49-F238E27FC236}">
                 <a16:creationId xmlns:a16="http://schemas.microsoft.com/office/drawing/2014/main" id="{A6D17A19-CAE4-FA2F-080D-DA17849C5916}"/>
@@ -23311,7 +23311,7 @@
       </p:sp>
       <p:sp>
         <p:nvSpPr>
-          <p:cNvPr id="3" name="Espace réservé du texte 2">
+          <p:cNvPr id="3" name="slot.subtitle-1">
             <a:extLst>
               <a:ext uri="{FF2B5EF4-FFF2-40B4-BE49-F238E27FC236}">
                 <a16:creationId xmlns:a16="http://schemas.microsoft.com/office/drawing/2014/main" id="{F6D07D73-8ACA-BC20-1ADF-744E20D84DFA}"/>
@@ -23336,7 +23336,7 @@
       </p:sp>
       <p:sp>
         <p:nvSpPr>
-          <p:cNvPr id="4" name="Espace réservé du texte 3">
+          <p:cNvPr id="4" name="slot.subtitle-2">
             <a:extLst>
               <a:ext uri="{FF2B5EF4-FFF2-40B4-BE49-F238E27FC236}">
                 <a16:creationId xmlns:a16="http://schemas.microsoft.com/office/drawing/2014/main" id="{F6D383B4-B0C9-D409-F9B1-C9DF0C4ED39B}"/>
@@ -23361,7 +23361,7 @@
       </p:sp>
       <p:sp>
         <p:nvSpPr>
-          <p:cNvPr id="5" name="Espace réservé du contenu 4">
+          <p:cNvPr id="5" name="slot.body">
             <a:extLst>
               <a:ext uri="{FF2B5EF4-FFF2-40B4-BE49-F238E27FC236}">
                 <a16:creationId xmlns:a16="http://schemas.microsoft.com/office/drawing/2014/main" id="{8682BE46-4ADD-712E-693C-56A5CC4DE5D0}"/>
@@ -23386,7 +23386,7 @@
       </p:sp>
       <p:sp>
         <p:nvSpPr>
-          <p:cNvPr id="6" name="Espace réservé du numéro de diapositive 5">
+          <p:cNvPr id="6" name="slot.footer-page">
             <a:extLst>
               <a:ext uri="{FF2B5EF4-FFF2-40B4-BE49-F238E27FC236}">
                 <a16:creationId xmlns:a16="http://schemas.microsoft.com/office/drawing/2014/main" id="{BF5E0291-96D4-4AAD-9728-6D7882490A4F}"/>
@@ -23416,7 +23416,7 @@
       </p:sp>
       <p:sp>
         <p:nvSpPr>
-          <p:cNvPr id="7" name="Espace réservé du contenu 6">
+          <p:cNvPr id="7" name="slot.source">
             <a:extLst>
               <a:ext uri="{FF2B5EF4-FFF2-40B4-BE49-F238E27FC236}">
                 <a16:creationId xmlns:a16="http://schemas.microsoft.com/office/drawing/2014/main" id="{9414BBDE-DFC1-B1B1-CCB9-338AAFF2DAEB}"/>
@@ -23471,7 +23471,7 @@
       </p:grpSpPr>
       <p:sp>
         <p:nvSpPr>
-          <p:cNvPr id="2" name="Titre 1">
+          <p:cNvPr id="2" name="slot.title">
             <a:extLst>
               <a:ext uri="{FF2B5EF4-FFF2-40B4-BE49-F238E27FC236}">
                 <a16:creationId xmlns:a16="http://schemas.microsoft.com/office/drawing/2014/main" id="{C9860B66-4F97-16A2-5884-362D844D5186}"/>
@@ -23496,7 +23496,7 @@
       </p:sp>
       <p:sp>
         <p:nvSpPr>
-          <p:cNvPr id="3" name="Espace réservé du contenu 2">
+          <p:cNvPr id="3" name="slot.body-left">
             <a:extLst>
               <a:ext uri="{FF2B5EF4-FFF2-40B4-BE49-F238E27FC236}">
                 <a16:creationId xmlns:a16="http://schemas.microsoft.com/office/drawing/2014/main" id="{67D0980E-EC25-1F76-A0E7-024667E7F4A2}"/>
@@ -23521,7 +23521,7 @@
       </p:sp>
       <p:sp>
         <p:nvSpPr>
-          <p:cNvPr id="4" name="Espace réservé du numéro de diapositive 3">
+          <p:cNvPr id="4" name="slot.footer-page">
             <a:extLst>
               <a:ext uri="{FF2B5EF4-FFF2-40B4-BE49-F238E27FC236}">
                 <a16:creationId xmlns:a16="http://schemas.microsoft.com/office/drawing/2014/main" id="{EE0DA2D1-8508-AF08-321B-9DD6AB3193E9}"/>
@@ -23581,7 +23581,7 @@
       </p:grpSpPr>
       <p:sp>
         <p:nvSpPr>
-          <p:cNvPr id="2" name="Titre 1">
+          <p:cNvPr id="2" name="slot.title">
             <a:extLst>
               <a:ext uri="{FF2B5EF4-FFF2-40B4-BE49-F238E27FC236}">
                 <a16:creationId xmlns:a16="http://schemas.microsoft.com/office/drawing/2014/main" id="{8380E5D0-5026-EB71-0F67-47CE171B2266}"/>
@@ -23606,7 +23606,7 @@
       </p:sp>
       <p:sp>
         <p:nvSpPr>
-          <p:cNvPr id="3" name="Espace réservé du contenu 2">
+          <p:cNvPr id="3" name="slot.body-left">
             <a:extLst>
               <a:ext uri="{FF2B5EF4-FFF2-40B4-BE49-F238E27FC236}">
                 <a16:creationId xmlns:a16="http://schemas.microsoft.com/office/drawing/2014/main" id="{61F73BCE-7414-9647-031B-5E1E96589689}"/>
@@ -23631,7 +23631,7 @@
       </p:sp>
       <p:sp>
         <p:nvSpPr>
-          <p:cNvPr id="4" name="Espace réservé du numéro de diapositive 3">
+          <p:cNvPr id="4" name="slot.footer-page">
             <a:extLst>
               <a:ext uri="{FF2B5EF4-FFF2-40B4-BE49-F238E27FC236}">
                 <a16:creationId xmlns:a16="http://schemas.microsoft.com/office/drawing/2014/main" id="{CCB1391B-9E18-29A1-5039-16BED643ACED}"/>
@@ -23660,7 +23660,7 @@
       </p:sp>
       <p:sp>
         <p:nvSpPr>
-          <p:cNvPr id="5" name="Espace réservé du contenu 4">
+          <p:cNvPr id="5" name="slot.source">
             <a:extLst>
               <a:ext uri="{FF2B5EF4-FFF2-40B4-BE49-F238E27FC236}">
                 <a16:creationId xmlns:a16="http://schemas.microsoft.com/office/drawing/2014/main" id="{1FA08A71-20BC-F105-521A-0896E8DDCFEC}"/>
@@ -23715,7 +23715,7 @@
       </p:grpSpPr>
       <p:sp>
         <p:nvSpPr>
-          <p:cNvPr id="5" name="Titre 4">
+          <p:cNvPr id="5" name="slot.title">
             <a:extLst>
               <a:ext uri="{FF2B5EF4-FFF2-40B4-BE49-F238E27FC236}">
                 <a16:creationId xmlns:a16="http://schemas.microsoft.com/office/drawing/2014/main" id="{56AFBC28-EC91-4C6B-21FC-51452A2E0D5E}"/>
@@ -23740,7 +23740,7 @@
       </p:sp>
       <p:sp>
         <p:nvSpPr>
-          <p:cNvPr id="6" name="Espace réservé du contenu 5">
+          <p:cNvPr id="6" name="slot.source">
             <a:extLst>
               <a:ext uri="{FF2B5EF4-FFF2-40B4-BE49-F238E27FC236}">
                 <a16:creationId xmlns:a16="http://schemas.microsoft.com/office/drawing/2014/main" id="{7E4542B0-4EEC-FBEE-97E0-DC5D5E41CC6B}"/>
@@ -23765,7 +23765,7 @@
       </p:sp>
       <p:sp>
         <p:nvSpPr>
-          <p:cNvPr id="4" name="Espace réservé du numéro de diapositive 3">
+          <p:cNvPr id="4" name="slot.footer-page">
             <a:extLst>
               <a:ext uri="{FF2B5EF4-FFF2-40B4-BE49-F238E27FC236}">
                 <a16:creationId xmlns:a16="http://schemas.microsoft.com/office/drawing/2014/main" id="{6F138008-195A-9DF9-CDBA-4C150FA42D20}"/>
@@ -23824,7 +23824,7 @@
       </p:grpSpPr>
       <p:sp>
         <p:nvSpPr>
-          <p:cNvPr id="5" name="Titre 4">
+          <p:cNvPr id="5" name="slot.title">
             <a:extLst>
               <a:ext uri="{FF2B5EF4-FFF2-40B4-BE49-F238E27FC236}">
                 <a16:creationId xmlns:a16="http://schemas.microsoft.com/office/drawing/2014/main" id="{A78B4462-098A-BEFB-12A5-0B2130617E9E}"/>
@@ -23849,7 +23849,7 @@
       </p:sp>
       <p:sp>
         <p:nvSpPr>
-          <p:cNvPr id="6" name="Espace réservé du contenu 5">
+          <p:cNvPr id="6" name="slot.body-left">
             <a:extLst>
               <a:ext uri="{FF2B5EF4-FFF2-40B4-BE49-F238E27FC236}">
                 <a16:creationId xmlns:a16="http://schemas.microsoft.com/office/drawing/2014/main" id="{B2DBBAC5-9A7A-F9B1-7594-7A706C39E559}"/>
@@ -23874,7 +23874,7 @@
       </p:sp>
       <p:sp>
         <p:nvSpPr>
-          <p:cNvPr id="8" name="Sous-titre 7">
+          <p:cNvPr id="8" name="slot.subtitle">
             <a:extLst>
               <a:ext uri="{FF2B5EF4-FFF2-40B4-BE49-F238E27FC236}">
                 <a16:creationId xmlns:a16="http://schemas.microsoft.com/office/drawing/2014/main" id="{3C84BBC7-166F-A5FB-3EB4-D0E396C32405}"/>
@@ -23899,7 +23899,7 @@
       </p:sp>
       <p:sp>
         <p:nvSpPr>
-          <p:cNvPr id="4" name="Espace réservé du numéro de diapositive 3">
+          <p:cNvPr id="4" name="slot.footer-page">
             <a:extLst>
               <a:ext uri="{FF2B5EF4-FFF2-40B4-BE49-F238E27FC236}">
                 <a16:creationId xmlns:a16="http://schemas.microsoft.com/office/drawing/2014/main" id="{5C8601E0-E097-6F4C-1CB6-93C63DFC9604}"/>
@@ -23928,7 +23928,7 @@
       </p:sp>
       <p:sp>
         <p:nvSpPr>
-          <p:cNvPr id="7" name="Espace réservé du contenu 6">
+          <p:cNvPr id="7" name="slot.source">
             <a:extLst>
               <a:ext uri="{FF2B5EF4-FFF2-40B4-BE49-F238E27FC236}">
                 <a16:creationId xmlns:a16="http://schemas.microsoft.com/office/drawing/2014/main" id="{140ECFB3-DB91-97BB-BC3F-A41D4BC064F2}"/>
@@ -23951,12 +23951,158 @@
           </a:p>
         </p:txBody>
       </p:sp>
-      <p:sp>
-        <p:nvSpPr>
-          <p:cNvPr id="2" name="Espace réservé du contenu 5">
-            <a:extLst>
-              <a:ext uri="{FF2B5EF4-FFF2-40B4-BE49-F238E27FC236}">
-                <a16:creationId xmlns:a16="http://schemas.microsoft.com/office/drawing/2014/main" id="{1CDF13B5-C492-7E19-E47D-AF5DEC25A9CD}"/>
+    </p:spTree>
+    <p:extLst>
+      <p:ext uri="{BB962C8B-B14F-4D97-AF65-F5344CB8AC3E}">
+        <p14:creationId xmlns:p14="http://schemas.microsoft.com/office/powerpoint/2010/main" val="1849693561"/>
+      </p:ext>
+    </p:extLst>
+  </p:cSld>
+  <p:clrMapOvr>
+    <a:masterClrMapping/>
+  </p:clrMapOvr>
+</p:sld>
+</file>
+
+<file path=ppt/slides/slide7.xml><?xml version="1.0" encoding="utf-8"?>
+<p:sld xmlns:a="http://schemas.openxmlformats.org/drawingml/2006/main" xmlns:r="http://schemas.openxmlformats.org/officeDocument/2006/relationships" xmlns:p="http://schemas.openxmlformats.org/presentationml/2006/main">
+  <p:cSld>
+    <p:spTree>
+      <p:nvGrpSpPr>
+        <p:cNvPr id="1" name="">
+          <a:extLst>
+            <a:ext uri="{FF2B5EF4-FFF2-40B4-BE49-F238E27FC236}">
+              <a16:creationId xmlns:a16="http://schemas.microsoft.com/office/drawing/2014/main" id="{D61B41E7-9281-699C-9E57-E2B30557148A}"/>
+            </a:ext>
+          </a:extLst>
+        </p:cNvPr>
+        <p:cNvGrpSpPr/>
+        <p:nvPr/>
+      </p:nvGrpSpPr>
+      <p:grpSpPr>
+        <a:xfrm>
+          <a:off x="0" y="0"/>
+          <a:ext cx="0" cy="0"/>
+          <a:chOff x="0" y="0"/>
+          <a:chExt cx="0" cy="0"/>
+        </a:xfrm>
+      </p:grpSpPr>
+      <p:sp>
+        <p:nvSpPr>
+          <p:cNvPr id="11" name="slot.title">
+            <a:extLst>
+              <a:ext uri="{FF2B5EF4-FFF2-40B4-BE49-F238E27FC236}">
+                <a16:creationId xmlns:a16="http://schemas.microsoft.com/office/drawing/2014/main" id="{D1C5C7F7-F1BB-F645-9BFD-AC43D790CDB8}"/>
+              </a:ext>
+            </a:extLst>
+          </p:cNvPr>
+          <p:cNvSpPr>
+            <a:spLocks noGrp="1"/>
+          </p:cNvSpPr>
+          <p:nvPr>
+            <p:ph type="title"/>
+          </p:nvPr>
+        </p:nvSpPr>
+        <p:spPr/>
+        <p:txBody>
+          <a:bodyPr/>
+          <a:lstStyle/>
+          <a:p>
+            <a:endParaRPr lang="fr-FR"/>
+          </a:p>
+        </p:txBody>
+      </p:sp>
+      <p:graphicFrame>
+        <p:nvGraphicFramePr>
+          <p:cNvPr id="2" name="slot.chart">
+            <a:extLst>
+              <a:ext uri="{FF2B5EF4-FFF2-40B4-BE49-F238E27FC236}">
+                <a16:creationId xmlns:a16="http://schemas.microsoft.com/office/drawing/2014/main" id="{8B9A51C8-0821-CC8D-FE41-EC04560121EE}"/>
+              </a:ext>
+            </a:extLst>
+          </p:cNvPr>
+          <p:cNvGraphicFramePr>
+            <a:graphicFrameLocks noGrp="1"/>
+          </p:cNvGraphicFramePr>
+          <p:nvPr>
+            <p:ph idx="1"/>
+            <p:extLst>
+              <p:ext uri="{D42A27DB-BD31-4B8C-83A1-F6EECF244321}">
+                <p14:modId xmlns:p14="http://schemas.microsoft.com/office/powerpoint/2010/main" val="845708311"/>
+              </p:ext>
+            </p:extLst>
+          </p:nvPr>
+        </p:nvGraphicFramePr>
+        <p:xfrm>
+          <a:off x="550863" y="1622758"/>
+          <a:ext cx="5918303" cy="4614530"/>
+        </p:xfrm>
+        <a:graphic>
+          <a:graphicData uri="http://schemas.openxmlformats.org/drawingml/2006/chart">
+            <c:chart xmlns:c="http://schemas.openxmlformats.org/drawingml/2006/chart" xmlns:r="http://schemas.openxmlformats.org/officeDocument/2006/relationships" r:id="rId2"/>
+          </a:graphicData>
+        </a:graphic>
+      </p:graphicFrame>
+      <p:sp>
+        <p:nvSpPr>
+          <p:cNvPr id="4" name="slot.footer-page">
+            <a:extLst>
+              <a:ext uri="{FF2B5EF4-FFF2-40B4-BE49-F238E27FC236}">
+                <a16:creationId xmlns:a16="http://schemas.microsoft.com/office/drawing/2014/main" id="{ACA357C0-33AA-F8BB-B7C0-8DFBCE7B96BC}"/>
+              </a:ext>
+            </a:extLst>
+          </p:cNvPr>
+          <p:cNvSpPr>
+            <a:spLocks noGrp="1"/>
+          </p:cNvSpPr>
+          <p:nvPr>
+            <p:ph type="sldNum" sz="quarter" idx="12"/>
+          </p:nvPr>
+        </p:nvSpPr>
+        <p:spPr/>
+        <p:txBody>
+          <a:bodyPr/>
+          <a:lstStyle/>
+          <a:p>
+            <a:fld id="{27D40A0C-669C-7745-8A4B-A0A60E70B612}" type="slidenum">
+              <a:rPr lang="fr-FR" smtClean="0"/>
+              <a:t>7</a:t>
+            </a:fld>
+            <a:endParaRPr lang="fr-FR"/>
+          </a:p>
+        </p:txBody>
+      </p:sp>
+      <p:sp>
+        <p:nvSpPr>
+          <p:cNvPr id="12" name="slot.source">
+            <a:extLst>
+              <a:ext uri="{FF2B5EF4-FFF2-40B4-BE49-F238E27FC236}">
+                <a16:creationId xmlns:a16="http://schemas.microsoft.com/office/drawing/2014/main" id="{3C2A6227-568F-E980-735B-9E2C7525D872}"/>
+              </a:ext>
+            </a:extLst>
+          </p:cNvPr>
+          <p:cNvSpPr>
+            <a:spLocks noGrp="1"/>
+          </p:cNvSpPr>
+          <p:nvPr>
+            <p:ph sz="quarter" idx="18"/>
+          </p:nvPr>
+        </p:nvSpPr>
+        <p:spPr/>
+        <p:txBody>
+          <a:bodyPr/>
+          <a:lstStyle/>
+          <a:p>
+            <a:endParaRPr lang="fr-FR"/>
+          </a:p>
+        </p:txBody>
+      </p:sp>
+      <p:sp>
+        <p:nvSpPr>
+          <p:cNvPr id="3" name="slot.body-right">
+            <a:extLst>
+              <a:ext uri="{FF2B5EF4-FFF2-40B4-BE49-F238E27FC236}">
+                <a16:creationId xmlns:a16="http://schemas.microsoft.com/office/drawing/2014/main" id="{8D0B1F2F-2950-2FED-2CF1-55AA8817ED3F}"/>
               </a:ext>
             </a:extLst>
           </p:cNvPr>
@@ -23967,8 +24113,8 @@
         </p:nvSpPr>
         <p:spPr>
           <a:xfrm>
-            <a:off x="1947271" y="2356821"/>
-            <a:ext cx="11090275" cy="4723984"/>
+            <a:off x="6882254" y="1622758"/>
+            <a:ext cx="4804303" cy="4448433"/>
           </a:xfrm>
           <a:prstGeom prst="rect">
             <a:avLst/>
@@ -24184,165 +24330,18 @@
           </a:lstStyle>
           <a:p>
             <a:r>
-              <a:rPr lang="fr-FR" dirty="0" err="1"/>
-              <a:t>qsdf</a:t>
-            </a:r>
-            <a:endParaRPr lang="fr-FR" dirty="0"/>
-          </a:p>
-        </p:txBody>
-      </p:sp>
-    </p:spTree>
-    <p:extLst>
-      <p:ext uri="{BB962C8B-B14F-4D97-AF65-F5344CB8AC3E}">
-        <p14:creationId xmlns:p14="http://schemas.microsoft.com/office/powerpoint/2010/main" val="1849693561"/>
-      </p:ext>
-    </p:extLst>
-  </p:cSld>
-  <p:clrMapOvr>
-    <a:masterClrMapping/>
-  </p:clrMapOvr>
-</p:sld>
-</file>
-
-<file path=ppt/slides/slide7.xml><?xml version="1.0" encoding="utf-8"?>
-<p:sld xmlns:a="http://schemas.openxmlformats.org/drawingml/2006/main" xmlns:r="http://schemas.openxmlformats.org/officeDocument/2006/relationships" xmlns:p="http://schemas.openxmlformats.org/presentationml/2006/main">
-  <p:cSld>
-    <p:spTree>
-      <p:nvGrpSpPr>
-        <p:cNvPr id="1" name="">
-          <a:extLst>
-            <a:ext uri="{FF2B5EF4-FFF2-40B4-BE49-F238E27FC236}">
-              <a16:creationId xmlns:a16="http://schemas.microsoft.com/office/drawing/2014/main" id="{D61B41E7-9281-699C-9E57-E2B30557148A}"/>
-            </a:ext>
-          </a:extLst>
-        </p:cNvPr>
-        <p:cNvGrpSpPr/>
-        <p:nvPr/>
-      </p:nvGrpSpPr>
-      <p:grpSpPr>
-        <a:xfrm>
-          <a:off x="0" y="0"/>
-          <a:ext cx="0" cy="0"/>
-          <a:chOff x="0" y="0"/>
-          <a:chExt cx="0" cy="0"/>
-        </a:xfrm>
-      </p:grpSpPr>
-      <p:sp>
-        <p:nvSpPr>
-          <p:cNvPr id="11" name="Titre 10">
-            <a:extLst>
-              <a:ext uri="{FF2B5EF4-FFF2-40B4-BE49-F238E27FC236}">
-                <a16:creationId xmlns:a16="http://schemas.microsoft.com/office/drawing/2014/main" id="{D1C5C7F7-F1BB-F645-9BFD-AC43D790CDB8}"/>
-              </a:ext>
-            </a:extLst>
-          </p:cNvPr>
-          <p:cNvSpPr>
-            <a:spLocks noGrp="1"/>
-          </p:cNvSpPr>
-          <p:nvPr>
-            <p:ph type="title"/>
-          </p:nvPr>
-        </p:nvSpPr>
-        <p:spPr/>
-        <p:txBody>
-          <a:bodyPr/>
-          <a:lstStyle/>
-          <a:p>
-            <a:endParaRPr lang="fr-FR"/>
-          </a:p>
-        </p:txBody>
-      </p:sp>
-      <p:graphicFrame>
-        <p:nvGraphicFramePr>
-          <p:cNvPr id="2" name="Espace réservé du contenu 1">
-            <a:extLst>
-              <a:ext uri="{FF2B5EF4-FFF2-40B4-BE49-F238E27FC236}">
-                <a16:creationId xmlns:a16="http://schemas.microsoft.com/office/drawing/2014/main" id="{8B9A51C8-0821-CC8D-FE41-EC04560121EE}"/>
-              </a:ext>
-            </a:extLst>
-          </p:cNvPr>
-          <p:cNvGraphicFramePr>
-            <a:graphicFrameLocks noGrp="1"/>
-          </p:cNvGraphicFramePr>
-          <p:nvPr>
-            <p:ph idx="1"/>
-            <p:extLst>
-              <p:ext uri="{D42A27DB-BD31-4B8C-83A1-F6EECF244321}">
-                <p14:modId xmlns:p14="http://schemas.microsoft.com/office/powerpoint/2010/main" val="845708311"/>
-              </p:ext>
-            </p:extLst>
-          </p:nvPr>
-        </p:nvGraphicFramePr>
-        <p:xfrm>
-          <a:off x="550863" y="1622758"/>
-          <a:ext cx="5918303" cy="4614530"/>
-        </p:xfrm>
-        <a:graphic>
-          <a:graphicData uri="http://schemas.openxmlformats.org/drawingml/2006/chart">
-            <c:chart xmlns:c="http://schemas.openxmlformats.org/drawingml/2006/chart" xmlns:r="http://schemas.openxmlformats.org/officeDocument/2006/relationships" r:id="rId2"/>
-          </a:graphicData>
-        </a:graphic>
-      </p:graphicFrame>
-      <p:sp>
-        <p:nvSpPr>
-          <p:cNvPr id="4" name="Espace réservé du numéro de diapositive 3">
-            <a:extLst>
-              <a:ext uri="{FF2B5EF4-FFF2-40B4-BE49-F238E27FC236}">
-                <a16:creationId xmlns:a16="http://schemas.microsoft.com/office/drawing/2014/main" id="{ACA357C0-33AA-F8BB-B7C0-8DFBCE7B96BC}"/>
-              </a:ext>
-            </a:extLst>
-          </p:cNvPr>
-          <p:cNvSpPr>
-            <a:spLocks noGrp="1"/>
-          </p:cNvSpPr>
-          <p:nvPr>
-            <p:ph type="sldNum" sz="quarter" idx="12"/>
-          </p:nvPr>
-        </p:nvSpPr>
-        <p:spPr/>
-        <p:txBody>
-          <a:bodyPr/>
-          <a:lstStyle/>
-          <a:p>
-            <a:fld id="{27D40A0C-669C-7745-8A4B-A0A60E70B612}" type="slidenum">
-              <a:rPr lang="fr-FR" smtClean="0"/>
-              <a:t>7</a:t>
-            </a:fld>
-            <a:endParaRPr lang="fr-FR"/>
-          </a:p>
-        </p:txBody>
-      </p:sp>
-      <p:sp>
-        <p:nvSpPr>
-          <p:cNvPr id="12" name="Espace réservé du contenu 11">
-            <a:extLst>
-              <a:ext uri="{FF2B5EF4-FFF2-40B4-BE49-F238E27FC236}">
-                <a16:creationId xmlns:a16="http://schemas.microsoft.com/office/drawing/2014/main" id="{3C2A6227-568F-E980-735B-9E2C7525D872}"/>
-              </a:ext>
-            </a:extLst>
-          </p:cNvPr>
-          <p:cNvSpPr>
-            <a:spLocks noGrp="1"/>
-          </p:cNvSpPr>
-          <p:nvPr>
-            <p:ph sz="quarter" idx="18"/>
-          </p:nvPr>
-        </p:nvSpPr>
-        <p:spPr/>
-        <p:txBody>
-          <a:bodyPr/>
-          <a:lstStyle/>
-          <a:p>
-            <a:endParaRPr lang="fr-FR"/>
-          </a:p>
-        </p:txBody>
-      </p:sp>
-      <p:sp>
-        <p:nvSpPr>
-          <p:cNvPr id="3" name="Espace réservé du contenu 5">
-            <a:extLst>
-              <a:ext uri="{FF2B5EF4-FFF2-40B4-BE49-F238E27FC236}">
-                <a16:creationId xmlns:a16="http://schemas.microsoft.com/office/drawing/2014/main" id="{8D0B1F2F-2950-2FED-2CF1-55AA8817ED3F}"/>
+              <a:rPr lang="fr-FR" dirty="0"/>
+              <a:t>Comment</a:t>
+            </a:r>
+          </a:p>
+        </p:txBody>
+      </p:sp>
+      <p:sp>
+        <p:nvSpPr>
+          <p:cNvPr id="13" name="slot.chart-title">
+            <a:extLst>
+              <a:ext uri="{FF2B5EF4-FFF2-40B4-BE49-F238E27FC236}">
+                <a16:creationId xmlns:a16="http://schemas.microsoft.com/office/drawing/2014/main" id="{945984DF-2BDC-B335-76E3-4D1A5C06727A}"/>
               </a:ext>
             </a:extLst>
           </p:cNvPr>
@@ -24353,8 +24352,8 @@
         </p:nvSpPr>
         <p:spPr>
           <a:xfrm>
-            <a:off x="6882254" y="1622758"/>
-            <a:ext cx="4804303" cy="4448433"/>
+            <a:off x="550863" y="1204783"/>
+            <a:ext cx="5636292" cy="275101"/>
           </a:xfrm>
           <a:prstGeom prst="rect">
             <a:avLst/>
@@ -24569,19 +24568,184 @@
             </a:lvl9pPr>
           </a:lstStyle>
           <a:p>
+            <a:pPr marL="3175" indent="0">
+              <a:buNone/>
+            </a:pPr>
+            <a:r>
+              <a:rPr lang="fr-FR" b="1" dirty="0"/>
+              <a:t>Chart </a:t>
+            </a:r>
+            <a:r>
+              <a:rPr lang="fr-FR" b="1" dirty="0" err="1"/>
+              <a:t>name</a:t>
+            </a:r>
             <a:r>
               <a:rPr lang="fr-FR" dirty="0"/>
-              <a:t>Comment</a:t>
-            </a:r>
-          </a:p>
-        </p:txBody>
-      </p:sp>
-      <p:sp>
-        <p:nvSpPr>
-          <p:cNvPr id="13" name="Espace réservé du contenu 5">
-            <a:extLst>
-              <a:ext uri="{FF2B5EF4-FFF2-40B4-BE49-F238E27FC236}">
-                <a16:creationId xmlns:a16="http://schemas.microsoft.com/office/drawing/2014/main" id="{945984DF-2BDC-B335-76E3-4D1A5C06727A}"/>
+              <a:t>, </a:t>
+            </a:r>
+            <a:r>
+              <a:rPr lang="fr-FR" i="1" dirty="0">
+                <a:solidFill>
+                  <a:schemeClr val="accent6"/>
+                </a:solidFill>
+              </a:rPr>
+              <a:t>unit</a:t>
+            </a:r>
+          </a:p>
+        </p:txBody>
+      </p:sp>
+    </p:spTree>
+    <p:extLst>
+      <p:ext uri="{BB962C8B-B14F-4D97-AF65-F5344CB8AC3E}">
+        <p14:creationId xmlns:p14="http://schemas.microsoft.com/office/powerpoint/2010/main" val="3710206233"/>
+      </p:ext>
+    </p:extLst>
+  </p:cSld>
+  <p:clrMapOvr>
+    <a:masterClrMapping/>
+  </p:clrMapOvr>
+</p:sld>
+</file>
+
+<file path=ppt/slides/slide8.xml><?xml version="1.0" encoding="utf-8"?>
+<p:sld xmlns:a="http://schemas.openxmlformats.org/drawingml/2006/main" xmlns:r="http://schemas.openxmlformats.org/officeDocument/2006/relationships" xmlns:p="http://schemas.openxmlformats.org/presentationml/2006/main">
+  <p:cSld>
+    <p:spTree>
+      <p:nvGrpSpPr>
+        <p:cNvPr id="1" name="">
+          <a:extLst>
+            <a:ext uri="{FF2B5EF4-FFF2-40B4-BE49-F238E27FC236}">
+              <a16:creationId xmlns:a16="http://schemas.microsoft.com/office/drawing/2014/main" id="{B0AB688E-47CF-1959-E687-9402B2CA2A73}"/>
+            </a:ext>
+          </a:extLst>
+        </p:cNvPr>
+        <p:cNvGrpSpPr/>
+        <p:nvPr/>
+      </p:nvGrpSpPr>
+      <p:grpSpPr>
+        <a:xfrm>
+          <a:off x="0" y="0"/>
+          <a:ext cx="0" cy="0"/>
+          <a:chOff x="0" y="0"/>
+          <a:chExt cx="0" cy="0"/>
+        </a:xfrm>
+      </p:grpSpPr>
+      <p:sp>
+        <p:nvSpPr>
+          <p:cNvPr id="11" name="slot.title">
+            <a:extLst>
+              <a:ext uri="{FF2B5EF4-FFF2-40B4-BE49-F238E27FC236}">
+                <a16:creationId xmlns:a16="http://schemas.microsoft.com/office/drawing/2014/main" id="{9BD6B52A-FF19-78CF-A935-E133AB89A4BB}"/>
+              </a:ext>
+            </a:extLst>
+          </p:cNvPr>
+          <p:cNvSpPr>
+            <a:spLocks noGrp="1"/>
+          </p:cNvSpPr>
+          <p:nvPr>
+            <p:ph type="title"/>
+          </p:nvPr>
+        </p:nvSpPr>
+        <p:spPr/>
+        <p:txBody>
+          <a:bodyPr/>
+          <a:lstStyle/>
+          <a:p>
+            <a:endParaRPr lang="fr-FR"/>
+          </a:p>
+        </p:txBody>
+      </p:sp>
+      <p:graphicFrame>
+        <p:nvGraphicFramePr>
+          <p:cNvPr id="2" name="slot.chart">
+            <a:extLst>
+              <a:ext uri="{FF2B5EF4-FFF2-40B4-BE49-F238E27FC236}">
+                <a16:creationId xmlns:a16="http://schemas.microsoft.com/office/drawing/2014/main" id="{43A9A298-18DF-1A43-C8A6-AF4C2F808ABB}"/>
+              </a:ext>
+            </a:extLst>
+          </p:cNvPr>
+          <p:cNvGraphicFramePr>
+            <a:graphicFrameLocks noGrp="1"/>
+          </p:cNvGraphicFramePr>
+          <p:nvPr>
+            <p:ph idx="1"/>
+            <p:extLst>
+              <p:ext uri="{D42A27DB-BD31-4B8C-83A1-F6EECF244321}">
+                <p14:modId xmlns:p14="http://schemas.microsoft.com/office/powerpoint/2010/main" val="356047063"/>
+              </p:ext>
+            </p:extLst>
+          </p:nvPr>
+        </p:nvGraphicFramePr>
+        <p:xfrm>
+          <a:off x="550863" y="1622758"/>
+          <a:ext cx="5935395" cy="4614530"/>
+        </p:xfrm>
+        <a:graphic>
+          <a:graphicData uri="http://schemas.openxmlformats.org/drawingml/2006/chart">
+            <c:chart xmlns:c="http://schemas.openxmlformats.org/drawingml/2006/chart" xmlns:r="http://schemas.openxmlformats.org/officeDocument/2006/relationships" r:id="rId2"/>
+          </a:graphicData>
+        </a:graphic>
+      </p:graphicFrame>
+      <p:sp>
+        <p:nvSpPr>
+          <p:cNvPr id="4" name="slot.footer-page">
+            <a:extLst>
+              <a:ext uri="{FF2B5EF4-FFF2-40B4-BE49-F238E27FC236}">
+                <a16:creationId xmlns:a16="http://schemas.microsoft.com/office/drawing/2014/main" id="{F4B4F2E0-11FD-0E6A-3E72-DE65E7BF7B3C}"/>
+              </a:ext>
+            </a:extLst>
+          </p:cNvPr>
+          <p:cNvSpPr>
+            <a:spLocks noGrp="1"/>
+          </p:cNvSpPr>
+          <p:nvPr>
+            <p:ph type="sldNum" sz="quarter" idx="12"/>
+          </p:nvPr>
+        </p:nvSpPr>
+        <p:spPr/>
+        <p:txBody>
+          <a:bodyPr/>
+          <a:lstStyle/>
+          <a:p>
+            <a:fld id="{27D40A0C-669C-7745-8A4B-A0A60E70B612}" type="slidenum">
+              <a:rPr lang="fr-FR" smtClean="0"/>
+              <a:t>8</a:t>
+            </a:fld>
+            <a:endParaRPr lang="fr-FR"/>
+          </a:p>
+        </p:txBody>
+      </p:sp>
+      <p:sp>
+        <p:nvSpPr>
+          <p:cNvPr id="12" name="slot.source">
+            <a:extLst>
+              <a:ext uri="{FF2B5EF4-FFF2-40B4-BE49-F238E27FC236}">
+                <a16:creationId xmlns:a16="http://schemas.microsoft.com/office/drawing/2014/main" id="{4FFBAF71-AAF1-3782-E97A-9AE70D79E6AF}"/>
+              </a:ext>
+            </a:extLst>
+          </p:cNvPr>
+          <p:cNvSpPr>
+            <a:spLocks noGrp="1"/>
+          </p:cNvSpPr>
+          <p:nvPr>
+            <p:ph sz="quarter" idx="18"/>
+          </p:nvPr>
+        </p:nvSpPr>
+        <p:spPr/>
+        <p:txBody>
+          <a:bodyPr/>
+          <a:lstStyle/>
+          <a:p>
+            <a:endParaRPr lang="fr-FR"/>
+          </a:p>
+        </p:txBody>
+      </p:sp>
+      <p:sp>
+        <p:nvSpPr>
+          <p:cNvPr id="10" name="slot.body-right">
+            <a:extLst>
+              <a:ext uri="{FF2B5EF4-FFF2-40B4-BE49-F238E27FC236}">
+                <a16:creationId xmlns:a16="http://schemas.microsoft.com/office/drawing/2014/main" id="{E47B0D7A-5F90-F7D3-A811-E1A7AEE96FB1}"/>
               </a:ext>
             </a:extLst>
           </p:cNvPr>
@@ -24592,8 +24756,8 @@
         </p:nvSpPr>
         <p:spPr>
           <a:xfrm>
-            <a:off x="550863" y="1204783"/>
-            <a:ext cx="5636292" cy="275101"/>
+            <a:off x="6882254" y="1622758"/>
+            <a:ext cx="4804303" cy="4448433"/>
           </a:xfrm>
           <a:prstGeom prst="rect">
             <a:avLst/>
@@ -24808,184 +24972,19 @@
             </a:lvl9pPr>
           </a:lstStyle>
           <a:p>
-            <a:pPr marL="3175" indent="0">
-              <a:buNone/>
-            </a:pPr>
-            <a:r>
-              <a:rPr lang="fr-FR" b="1" dirty="0"/>
-              <a:t>Chart </a:t>
-            </a:r>
-            <a:r>
-              <a:rPr lang="fr-FR" b="1" dirty="0" err="1"/>
-              <a:t>name</a:t>
-            </a:r>
             <a:r>
               <a:rPr lang="fr-FR" dirty="0"/>
-              <a:t>, </a:t>
-            </a:r>
-            <a:r>
-              <a:rPr lang="fr-FR" i="1" dirty="0">
-                <a:solidFill>
-                  <a:schemeClr val="accent6"/>
-                </a:solidFill>
-              </a:rPr>
-              <a:t>unit</a:t>
-            </a:r>
-          </a:p>
-        </p:txBody>
-      </p:sp>
-    </p:spTree>
-    <p:extLst>
-      <p:ext uri="{BB962C8B-B14F-4D97-AF65-F5344CB8AC3E}">
-        <p14:creationId xmlns:p14="http://schemas.microsoft.com/office/powerpoint/2010/main" val="3710206233"/>
-      </p:ext>
-    </p:extLst>
-  </p:cSld>
-  <p:clrMapOvr>
-    <a:masterClrMapping/>
-  </p:clrMapOvr>
-</p:sld>
-</file>
-
-<file path=ppt/slides/slide8.xml><?xml version="1.0" encoding="utf-8"?>
-<p:sld xmlns:a="http://schemas.openxmlformats.org/drawingml/2006/main" xmlns:r="http://schemas.openxmlformats.org/officeDocument/2006/relationships" xmlns:p="http://schemas.openxmlformats.org/presentationml/2006/main">
-  <p:cSld>
-    <p:spTree>
-      <p:nvGrpSpPr>
-        <p:cNvPr id="1" name="">
-          <a:extLst>
-            <a:ext uri="{FF2B5EF4-FFF2-40B4-BE49-F238E27FC236}">
-              <a16:creationId xmlns:a16="http://schemas.microsoft.com/office/drawing/2014/main" id="{B0AB688E-47CF-1959-E687-9402B2CA2A73}"/>
-            </a:ext>
-          </a:extLst>
-        </p:cNvPr>
-        <p:cNvGrpSpPr/>
-        <p:nvPr/>
-      </p:nvGrpSpPr>
-      <p:grpSpPr>
-        <a:xfrm>
-          <a:off x="0" y="0"/>
-          <a:ext cx="0" cy="0"/>
-          <a:chOff x="0" y="0"/>
-          <a:chExt cx="0" cy="0"/>
-        </a:xfrm>
-      </p:grpSpPr>
-      <p:sp>
-        <p:nvSpPr>
-          <p:cNvPr id="11" name="Titre 10">
-            <a:extLst>
-              <a:ext uri="{FF2B5EF4-FFF2-40B4-BE49-F238E27FC236}">
-                <a16:creationId xmlns:a16="http://schemas.microsoft.com/office/drawing/2014/main" id="{9BD6B52A-FF19-78CF-A935-E133AB89A4BB}"/>
-              </a:ext>
-            </a:extLst>
-          </p:cNvPr>
-          <p:cNvSpPr>
-            <a:spLocks noGrp="1"/>
-          </p:cNvSpPr>
-          <p:nvPr>
-            <p:ph type="title"/>
-          </p:nvPr>
-        </p:nvSpPr>
-        <p:spPr/>
-        <p:txBody>
-          <a:bodyPr/>
-          <a:lstStyle/>
-          <a:p>
-            <a:endParaRPr lang="fr-FR"/>
-          </a:p>
-        </p:txBody>
-      </p:sp>
-      <p:graphicFrame>
-        <p:nvGraphicFramePr>
-          <p:cNvPr id="2" name="Espace réservé du contenu 1">
-            <a:extLst>
-              <a:ext uri="{FF2B5EF4-FFF2-40B4-BE49-F238E27FC236}">
-                <a16:creationId xmlns:a16="http://schemas.microsoft.com/office/drawing/2014/main" id="{43A9A298-18DF-1A43-C8A6-AF4C2F808ABB}"/>
-              </a:ext>
-            </a:extLst>
-          </p:cNvPr>
-          <p:cNvGraphicFramePr>
-            <a:graphicFrameLocks noGrp="1"/>
-          </p:cNvGraphicFramePr>
-          <p:nvPr>
-            <p:ph idx="1"/>
-            <p:extLst>
-              <p:ext uri="{D42A27DB-BD31-4B8C-83A1-F6EECF244321}">
-                <p14:modId xmlns:p14="http://schemas.microsoft.com/office/powerpoint/2010/main" val="356047063"/>
-              </p:ext>
-            </p:extLst>
-          </p:nvPr>
-        </p:nvGraphicFramePr>
-        <p:xfrm>
-          <a:off x="550863" y="1622758"/>
-          <a:ext cx="5935395" cy="4614530"/>
-        </p:xfrm>
-        <a:graphic>
-          <a:graphicData uri="http://schemas.openxmlformats.org/drawingml/2006/chart">
-            <c:chart xmlns:c="http://schemas.openxmlformats.org/drawingml/2006/chart" xmlns:r="http://schemas.openxmlformats.org/officeDocument/2006/relationships" r:id="rId2"/>
-          </a:graphicData>
-        </a:graphic>
-      </p:graphicFrame>
-      <p:sp>
-        <p:nvSpPr>
-          <p:cNvPr id="4" name="Espace réservé du numéro de diapositive 3">
-            <a:extLst>
-              <a:ext uri="{FF2B5EF4-FFF2-40B4-BE49-F238E27FC236}">
-                <a16:creationId xmlns:a16="http://schemas.microsoft.com/office/drawing/2014/main" id="{F4B4F2E0-11FD-0E6A-3E72-DE65E7BF7B3C}"/>
-              </a:ext>
-            </a:extLst>
-          </p:cNvPr>
-          <p:cNvSpPr>
-            <a:spLocks noGrp="1"/>
-          </p:cNvSpPr>
-          <p:nvPr>
-            <p:ph type="sldNum" sz="quarter" idx="12"/>
-          </p:nvPr>
-        </p:nvSpPr>
-        <p:spPr/>
-        <p:txBody>
-          <a:bodyPr/>
-          <a:lstStyle/>
-          <a:p>
-            <a:fld id="{27D40A0C-669C-7745-8A4B-A0A60E70B612}" type="slidenum">
-              <a:rPr lang="fr-FR" smtClean="0"/>
-              <a:t>8</a:t>
-            </a:fld>
-            <a:endParaRPr lang="fr-FR"/>
-          </a:p>
-        </p:txBody>
-      </p:sp>
-      <p:sp>
-        <p:nvSpPr>
-          <p:cNvPr id="12" name="Espace réservé du contenu 11">
-            <a:extLst>
-              <a:ext uri="{FF2B5EF4-FFF2-40B4-BE49-F238E27FC236}">
-                <a16:creationId xmlns:a16="http://schemas.microsoft.com/office/drawing/2014/main" id="{4FFBAF71-AAF1-3782-E97A-9AE70D79E6AF}"/>
-              </a:ext>
-            </a:extLst>
-          </p:cNvPr>
-          <p:cNvSpPr>
-            <a:spLocks noGrp="1"/>
-          </p:cNvSpPr>
-          <p:nvPr>
-            <p:ph sz="quarter" idx="18"/>
-          </p:nvPr>
-        </p:nvSpPr>
-        <p:spPr/>
-        <p:txBody>
-          <a:bodyPr/>
-          <a:lstStyle/>
-          <a:p>
-            <a:endParaRPr lang="fr-FR"/>
-          </a:p>
-        </p:txBody>
-      </p:sp>
-      <p:sp>
-        <p:nvSpPr>
-          <p:cNvPr id="10" name="Espace réservé du contenu 5">
-            <a:extLst>
-              <a:ext uri="{FF2B5EF4-FFF2-40B4-BE49-F238E27FC236}">
-                <a16:creationId xmlns:a16="http://schemas.microsoft.com/office/drawing/2014/main" id="{E47B0D7A-5F90-F7D3-A811-E1A7AEE96FB1}"/>
+              <a:t>Comment</a:t>
+            </a:r>
+          </a:p>
+        </p:txBody>
+      </p:sp>
+      <p:sp>
+        <p:nvSpPr>
+          <p:cNvPr id="13" name="slot.chart-title">
+            <a:extLst>
+              <a:ext uri="{FF2B5EF4-FFF2-40B4-BE49-F238E27FC236}">
+                <a16:creationId xmlns:a16="http://schemas.microsoft.com/office/drawing/2014/main" id="{997B11C3-8955-D64A-329E-B0AA8D59C74C}"/>
               </a:ext>
             </a:extLst>
           </p:cNvPr>
@@ -24996,8 +24995,8 @@
         </p:nvSpPr>
         <p:spPr>
           <a:xfrm>
-            <a:off x="6882254" y="1622758"/>
-            <a:ext cx="4804303" cy="4448433"/>
+            <a:off x="550863" y="1204783"/>
+            <a:ext cx="5636292" cy="275101"/>
           </a:xfrm>
           <a:prstGeom prst="rect">
             <a:avLst/>
@@ -25212,19 +25211,184 @@
             </a:lvl9pPr>
           </a:lstStyle>
           <a:p>
+            <a:pPr marL="3175" indent="0">
+              <a:buNone/>
+            </a:pPr>
+            <a:r>
+              <a:rPr lang="fr-FR" b="1" dirty="0"/>
+              <a:t>Chart </a:t>
+            </a:r>
+            <a:r>
+              <a:rPr lang="fr-FR" b="1" dirty="0" err="1"/>
+              <a:t>name</a:t>
+            </a:r>
             <a:r>
               <a:rPr lang="fr-FR" dirty="0"/>
-              <a:t>Comment</a:t>
-            </a:r>
-          </a:p>
-        </p:txBody>
-      </p:sp>
-      <p:sp>
-        <p:nvSpPr>
-          <p:cNvPr id="13" name="Espace réservé du contenu 5">
-            <a:extLst>
-              <a:ext uri="{FF2B5EF4-FFF2-40B4-BE49-F238E27FC236}">
-                <a16:creationId xmlns:a16="http://schemas.microsoft.com/office/drawing/2014/main" id="{997B11C3-8955-D64A-329E-B0AA8D59C74C}"/>
+              <a:t>, </a:t>
+            </a:r>
+            <a:r>
+              <a:rPr lang="fr-FR" i="1" dirty="0">
+                <a:solidFill>
+                  <a:schemeClr val="accent6"/>
+                </a:solidFill>
+              </a:rPr>
+              <a:t>unit</a:t>
+            </a:r>
+          </a:p>
+        </p:txBody>
+      </p:sp>
+    </p:spTree>
+    <p:extLst>
+      <p:ext uri="{BB962C8B-B14F-4D97-AF65-F5344CB8AC3E}">
+        <p14:creationId xmlns:p14="http://schemas.microsoft.com/office/powerpoint/2010/main" val="3525562660"/>
+      </p:ext>
+    </p:extLst>
+  </p:cSld>
+  <p:clrMapOvr>
+    <a:masterClrMapping/>
+  </p:clrMapOvr>
+</p:sld>
+</file>
+
+<file path=ppt/slides/slide9.xml><?xml version="1.0" encoding="utf-8"?>
+<p:sld xmlns:a="http://schemas.openxmlformats.org/drawingml/2006/main" xmlns:r="http://schemas.openxmlformats.org/officeDocument/2006/relationships" xmlns:p="http://schemas.openxmlformats.org/presentationml/2006/main">
+  <p:cSld>
+    <p:spTree>
+      <p:nvGrpSpPr>
+        <p:cNvPr id="1" name="">
+          <a:extLst>
+            <a:ext uri="{FF2B5EF4-FFF2-40B4-BE49-F238E27FC236}">
+              <a16:creationId xmlns:a16="http://schemas.microsoft.com/office/drawing/2014/main" id="{977B962F-0DD9-4D69-1322-91DEA5F6127C}"/>
+            </a:ext>
+          </a:extLst>
+        </p:cNvPr>
+        <p:cNvGrpSpPr/>
+        <p:nvPr/>
+      </p:nvGrpSpPr>
+      <p:grpSpPr>
+        <a:xfrm>
+          <a:off x="0" y="0"/>
+          <a:ext cx="0" cy="0"/>
+          <a:chOff x="0" y="0"/>
+          <a:chExt cx="0" cy="0"/>
+        </a:xfrm>
+      </p:grpSpPr>
+      <p:sp>
+        <p:nvSpPr>
+          <p:cNvPr id="11" name="slot.title">
+            <a:extLst>
+              <a:ext uri="{FF2B5EF4-FFF2-40B4-BE49-F238E27FC236}">
+                <a16:creationId xmlns:a16="http://schemas.microsoft.com/office/drawing/2014/main" id="{E6BA610B-9EE9-45A1-B28B-47B1ECDE0349}"/>
+              </a:ext>
+            </a:extLst>
+          </p:cNvPr>
+          <p:cNvSpPr>
+            <a:spLocks noGrp="1"/>
+          </p:cNvSpPr>
+          <p:nvPr>
+            <p:ph type="title"/>
+          </p:nvPr>
+        </p:nvSpPr>
+        <p:spPr/>
+        <p:txBody>
+          <a:bodyPr/>
+          <a:lstStyle/>
+          <a:p>
+            <a:endParaRPr lang="fr-FR"/>
+          </a:p>
+        </p:txBody>
+      </p:sp>
+      <p:graphicFrame>
+        <p:nvGraphicFramePr>
+          <p:cNvPr id="2" name="slot.chart">
+            <a:extLst>
+              <a:ext uri="{FF2B5EF4-FFF2-40B4-BE49-F238E27FC236}">
+                <a16:creationId xmlns:a16="http://schemas.microsoft.com/office/drawing/2014/main" id="{9C81EFE1-097D-C671-2766-C25389738490}"/>
+              </a:ext>
+            </a:extLst>
+          </p:cNvPr>
+          <p:cNvGraphicFramePr>
+            <a:graphicFrameLocks noGrp="1"/>
+          </p:cNvGraphicFramePr>
+          <p:nvPr>
+            <p:ph idx="1"/>
+            <p:extLst>
+              <p:ext uri="{D42A27DB-BD31-4B8C-83A1-F6EECF244321}">
+                <p14:modId xmlns:p14="http://schemas.microsoft.com/office/powerpoint/2010/main" val="1077567379"/>
+              </p:ext>
+            </p:extLst>
+          </p:nvPr>
+        </p:nvGraphicFramePr>
+        <p:xfrm>
+          <a:off x="550864" y="1622758"/>
+          <a:ext cx="5713204" cy="4614530"/>
+        </p:xfrm>
+        <a:graphic>
+          <a:graphicData uri="http://schemas.openxmlformats.org/drawingml/2006/chart">
+            <c:chart xmlns:c="http://schemas.openxmlformats.org/drawingml/2006/chart" xmlns:r="http://schemas.openxmlformats.org/officeDocument/2006/relationships" r:id="rId2"/>
+          </a:graphicData>
+        </a:graphic>
+      </p:graphicFrame>
+      <p:sp>
+        <p:nvSpPr>
+          <p:cNvPr id="4" name="slot.footer-page">
+            <a:extLst>
+              <a:ext uri="{FF2B5EF4-FFF2-40B4-BE49-F238E27FC236}">
+                <a16:creationId xmlns:a16="http://schemas.microsoft.com/office/drawing/2014/main" id="{EC42C37B-CB35-17E7-8EE5-6ED39227D43E}"/>
+              </a:ext>
+            </a:extLst>
+          </p:cNvPr>
+          <p:cNvSpPr>
+            <a:spLocks noGrp="1"/>
+          </p:cNvSpPr>
+          <p:nvPr>
+            <p:ph type="sldNum" sz="quarter" idx="12"/>
+          </p:nvPr>
+        </p:nvSpPr>
+        <p:spPr/>
+        <p:txBody>
+          <a:bodyPr/>
+          <a:lstStyle/>
+          <a:p>
+            <a:fld id="{27D40A0C-669C-7745-8A4B-A0A60E70B612}" type="slidenum">
+              <a:rPr lang="fr-FR" smtClean="0"/>
+              <a:t>9</a:t>
+            </a:fld>
+            <a:endParaRPr lang="fr-FR"/>
+          </a:p>
+        </p:txBody>
+      </p:sp>
+      <p:sp>
+        <p:nvSpPr>
+          <p:cNvPr id="12" name="slot.source">
+            <a:extLst>
+              <a:ext uri="{FF2B5EF4-FFF2-40B4-BE49-F238E27FC236}">
+                <a16:creationId xmlns:a16="http://schemas.microsoft.com/office/drawing/2014/main" id="{190093B9-4BCE-CCC2-2DCD-4F71A64766E9}"/>
+              </a:ext>
+            </a:extLst>
+          </p:cNvPr>
+          <p:cNvSpPr>
+            <a:spLocks noGrp="1"/>
+          </p:cNvSpPr>
+          <p:nvPr>
+            <p:ph sz="quarter" idx="18"/>
+          </p:nvPr>
+        </p:nvSpPr>
+        <p:spPr/>
+        <p:txBody>
+          <a:bodyPr/>
+          <a:lstStyle/>
+          <a:p>
+            <a:endParaRPr lang="fr-FR"/>
+          </a:p>
+        </p:txBody>
+      </p:sp>
+      <p:sp>
+        <p:nvSpPr>
+          <p:cNvPr id="10" name="slot.body-right">
+            <a:extLst>
+              <a:ext uri="{FF2B5EF4-FFF2-40B4-BE49-F238E27FC236}">
+                <a16:creationId xmlns:a16="http://schemas.microsoft.com/office/drawing/2014/main" id="{9B4B49E6-ACBD-1A9F-8953-1EB368346C96}"/>
               </a:ext>
             </a:extLst>
           </p:cNvPr>
@@ -25235,8 +25399,8 @@
         </p:nvSpPr>
         <p:spPr>
           <a:xfrm>
-            <a:off x="550863" y="1204783"/>
-            <a:ext cx="5636292" cy="275101"/>
+            <a:off x="6882254" y="1622758"/>
+            <a:ext cx="4804303" cy="4448433"/>
           </a:xfrm>
           <a:prstGeom prst="rect">
             <a:avLst/>
@@ -25451,410 +25615,6 @@
             </a:lvl9pPr>
           </a:lstStyle>
           <a:p>
-            <a:pPr marL="3175" indent="0">
-              <a:buNone/>
-            </a:pPr>
-            <a:r>
-              <a:rPr lang="fr-FR" b="1" dirty="0"/>
-              <a:t>Chart </a:t>
-            </a:r>
-            <a:r>
-              <a:rPr lang="fr-FR" b="1" dirty="0" err="1"/>
-              <a:t>name</a:t>
-            </a:r>
-            <a:r>
-              <a:rPr lang="fr-FR" dirty="0"/>
-              <a:t>, </a:t>
-            </a:r>
-            <a:r>
-              <a:rPr lang="fr-FR" i="1" dirty="0">
-                <a:solidFill>
-                  <a:schemeClr val="accent6"/>
-                </a:solidFill>
-              </a:rPr>
-              <a:t>unit</a:t>
-            </a:r>
-          </a:p>
-        </p:txBody>
-      </p:sp>
-    </p:spTree>
-    <p:extLst>
-      <p:ext uri="{BB962C8B-B14F-4D97-AF65-F5344CB8AC3E}">
-        <p14:creationId xmlns:p14="http://schemas.microsoft.com/office/powerpoint/2010/main" val="3525562660"/>
-      </p:ext>
-    </p:extLst>
-  </p:cSld>
-  <p:clrMapOvr>
-    <a:masterClrMapping/>
-  </p:clrMapOvr>
-</p:sld>
-</file>
-
-<file path=ppt/slides/slide9.xml><?xml version="1.0" encoding="utf-8"?>
-<p:sld xmlns:a="http://schemas.openxmlformats.org/drawingml/2006/main" xmlns:r="http://schemas.openxmlformats.org/officeDocument/2006/relationships" xmlns:p="http://schemas.openxmlformats.org/presentationml/2006/main">
-  <p:cSld>
-    <p:spTree>
-      <p:nvGrpSpPr>
-        <p:cNvPr id="1" name="">
-          <a:extLst>
-            <a:ext uri="{FF2B5EF4-FFF2-40B4-BE49-F238E27FC236}">
-              <a16:creationId xmlns:a16="http://schemas.microsoft.com/office/drawing/2014/main" id="{977B962F-0DD9-4D69-1322-91DEA5F6127C}"/>
-            </a:ext>
-          </a:extLst>
-        </p:cNvPr>
-        <p:cNvGrpSpPr/>
-        <p:nvPr/>
-      </p:nvGrpSpPr>
-      <p:grpSpPr>
-        <a:xfrm>
-          <a:off x="0" y="0"/>
-          <a:ext cx="0" cy="0"/>
-          <a:chOff x="0" y="0"/>
-          <a:chExt cx="0" cy="0"/>
-        </a:xfrm>
-      </p:grpSpPr>
-      <p:sp>
-        <p:nvSpPr>
-          <p:cNvPr id="11" name="Titre 10">
-            <a:extLst>
-              <a:ext uri="{FF2B5EF4-FFF2-40B4-BE49-F238E27FC236}">
-                <a16:creationId xmlns:a16="http://schemas.microsoft.com/office/drawing/2014/main" id="{E6BA610B-9EE9-45A1-B28B-47B1ECDE0349}"/>
-              </a:ext>
-            </a:extLst>
-          </p:cNvPr>
-          <p:cNvSpPr>
-            <a:spLocks noGrp="1"/>
-          </p:cNvSpPr>
-          <p:nvPr>
-            <p:ph type="title"/>
-          </p:nvPr>
-        </p:nvSpPr>
-        <p:spPr/>
-        <p:txBody>
-          <a:bodyPr/>
-          <a:lstStyle/>
-          <a:p>
-            <a:endParaRPr lang="fr-FR"/>
-          </a:p>
-        </p:txBody>
-      </p:sp>
-      <p:graphicFrame>
-        <p:nvGraphicFramePr>
-          <p:cNvPr id="2" name="Espace réservé du contenu 1">
-            <a:extLst>
-              <a:ext uri="{FF2B5EF4-FFF2-40B4-BE49-F238E27FC236}">
-                <a16:creationId xmlns:a16="http://schemas.microsoft.com/office/drawing/2014/main" id="{9C81EFE1-097D-C671-2766-C25389738490}"/>
-              </a:ext>
-            </a:extLst>
-          </p:cNvPr>
-          <p:cNvGraphicFramePr>
-            <a:graphicFrameLocks noGrp="1"/>
-          </p:cNvGraphicFramePr>
-          <p:nvPr>
-            <p:ph idx="1"/>
-            <p:extLst>
-              <p:ext uri="{D42A27DB-BD31-4B8C-83A1-F6EECF244321}">
-                <p14:modId xmlns:p14="http://schemas.microsoft.com/office/powerpoint/2010/main" val="1077567379"/>
-              </p:ext>
-            </p:extLst>
-          </p:nvPr>
-        </p:nvGraphicFramePr>
-        <p:xfrm>
-          <a:off x="550864" y="1622758"/>
-          <a:ext cx="5713204" cy="4614530"/>
-        </p:xfrm>
-        <a:graphic>
-          <a:graphicData uri="http://schemas.openxmlformats.org/drawingml/2006/chart">
-            <c:chart xmlns:c="http://schemas.openxmlformats.org/drawingml/2006/chart" xmlns:r="http://schemas.openxmlformats.org/officeDocument/2006/relationships" r:id="rId2"/>
-          </a:graphicData>
-        </a:graphic>
-      </p:graphicFrame>
-      <p:sp>
-        <p:nvSpPr>
-          <p:cNvPr id="4" name="Espace réservé du numéro de diapositive 3">
-            <a:extLst>
-              <a:ext uri="{FF2B5EF4-FFF2-40B4-BE49-F238E27FC236}">
-                <a16:creationId xmlns:a16="http://schemas.microsoft.com/office/drawing/2014/main" id="{EC42C37B-CB35-17E7-8EE5-6ED39227D43E}"/>
-              </a:ext>
-            </a:extLst>
-          </p:cNvPr>
-          <p:cNvSpPr>
-            <a:spLocks noGrp="1"/>
-          </p:cNvSpPr>
-          <p:nvPr>
-            <p:ph type="sldNum" sz="quarter" idx="12"/>
-          </p:nvPr>
-        </p:nvSpPr>
-        <p:spPr/>
-        <p:txBody>
-          <a:bodyPr/>
-          <a:lstStyle/>
-          <a:p>
-            <a:fld id="{27D40A0C-669C-7745-8A4B-A0A60E70B612}" type="slidenum">
-              <a:rPr lang="fr-FR" smtClean="0"/>
-              <a:t>9</a:t>
-            </a:fld>
-            <a:endParaRPr lang="fr-FR"/>
-          </a:p>
-        </p:txBody>
-      </p:sp>
-      <p:sp>
-        <p:nvSpPr>
-          <p:cNvPr id="12" name="Espace réservé du contenu 11">
-            <a:extLst>
-              <a:ext uri="{FF2B5EF4-FFF2-40B4-BE49-F238E27FC236}">
-                <a16:creationId xmlns:a16="http://schemas.microsoft.com/office/drawing/2014/main" id="{190093B9-4BCE-CCC2-2DCD-4F71A64766E9}"/>
-              </a:ext>
-            </a:extLst>
-          </p:cNvPr>
-          <p:cNvSpPr>
-            <a:spLocks noGrp="1"/>
-          </p:cNvSpPr>
-          <p:nvPr>
-            <p:ph sz="quarter" idx="18"/>
-          </p:nvPr>
-        </p:nvSpPr>
-        <p:spPr/>
-        <p:txBody>
-          <a:bodyPr/>
-          <a:lstStyle/>
-          <a:p>
-            <a:endParaRPr lang="fr-FR"/>
-          </a:p>
-        </p:txBody>
-      </p:sp>
-      <p:sp>
-        <p:nvSpPr>
-          <p:cNvPr id="10" name="Espace réservé du contenu 5">
-            <a:extLst>
-              <a:ext uri="{FF2B5EF4-FFF2-40B4-BE49-F238E27FC236}">
-                <a16:creationId xmlns:a16="http://schemas.microsoft.com/office/drawing/2014/main" id="{9B4B49E6-ACBD-1A9F-8953-1EB368346C96}"/>
-              </a:ext>
-            </a:extLst>
-          </p:cNvPr>
-          <p:cNvSpPr txBox="1">
-            <a:spLocks/>
-          </p:cNvSpPr>
-          <p:nvPr/>
-        </p:nvSpPr>
-        <p:spPr>
-          <a:xfrm>
-            <a:off x="6882254" y="1622758"/>
-            <a:ext cx="4804303" cy="4448433"/>
-          </a:xfrm>
-          <a:prstGeom prst="rect">
-            <a:avLst/>
-          </a:prstGeom>
-        </p:spPr>
-        <p:txBody>
-          <a:bodyPr vert="horz" lIns="0" tIns="0" rIns="0" bIns="0" rtlCol="0">
-            <a:noAutofit/>
-          </a:bodyPr>
-          <a:lstStyle>
-            <a:lvl1pPr marL="136525" indent="-133350" algn="l" defTabSz="914400" rtl="0" eaLnBrk="1" latinLnBrk="0" hangingPunct="1">
-              <a:lnSpc>
-                <a:spcPct val="100000"/>
-              </a:lnSpc>
-              <a:spcBef>
-                <a:spcPts val="0"/>
-              </a:spcBef>
-              <a:spcAft>
-                <a:spcPts val="200"/>
-              </a:spcAft>
-              <a:buClr>
-                <a:schemeClr val="tx2"/>
-              </a:buClr>
-              <a:buSzPct val="100000"/>
-              <a:buFont typeface="System Font Regular"/>
-              <a:buChar char="•"/>
-              <a:tabLst/>
-              <a:defRPr sz="1200" kern="1200">
-                <a:solidFill>
-                  <a:schemeClr val="tx1"/>
-                </a:solidFill>
-                <a:latin typeface="Arial" panose="020B0604020202020204" pitchFamily="34" charset="0"/>
-                <a:ea typeface="+mn-ea"/>
-                <a:cs typeface="Arial" panose="020B0604020202020204" pitchFamily="34" charset="0"/>
-              </a:defRPr>
-            </a:lvl1pPr>
-            <a:lvl2pPr marL="273050" indent="-136525" algn="l" defTabSz="914400" rtl="0" eaLnBrk="1" latinLnBrk="0" hangingPunct="1">
-              <a:lnSpc>
-                <a:spcPct val="100000"/>
-              </a:lnSpc>
-              <a:spcBef>
-                <a:spcPts val="0"/>
-              </a:spcBef>
-              <a:spcAft>
-                <a:spcPts val="200"/>
-              </a:spcAft>
-              <a:buClr>
-                <a:schemeClr val="tx2"/>
-              </a:buClr>
-              <a:buSzPct val="100000"/>
-              <a:buFont typeface="System Font Regular"/>
-              <a:buChar char="−"/>
-              <a:tabLst/>
-              <a:defRPr sz="1200" kern="1200">
-                <a:solidFill>
-                  <a:schemeClr val="tx1"/>
-                </a:solidFill>
-                <a:latin typeface="Arial" panose="020B0604020202020204" pitchFamily="34" charset="0"/>
-                <a:ea typeface="+mn-ea"/>
-                <a:cs typeface="Arial" panose="020B0604020202020204" pitchFamily="34" charset="0"/>
-              </a:defRPr>
-            </a:lvl2pPr>
-            <a:lvl3pPr marL="401638" indent="-128588" algn="l" defTabSz="914400" rtl="0" eaLnBrk="1" latinLnBrk="0" hangingPunct="1">
-              <a:lnSpc>
-                <a:spcPct val="100000"/>
-              </a:lnSpc>
-              <a:spcBef>
-                <a:spcPts val="0"/>
-              </a:spcBef>
-              <a:spcAft>
-                <a:spcPts val="200"/>
-              </a:spcAft>
-              <a:buClr>
-                <a:schemeClr val="tx2"/>
-              </a:buClr>
-              <a:buSzPct val="100000"/>
-              <a:buFont typeface="System Font Regular"/>
-              <a:buChar char="◦"/>
-              <a:tabLst/>
-              <a:defRPr sz="1200" kern="1200">
-                <a:solidFill>
-                  <a:schemeClr val="tx1"/>
-                </a:solidFill>
-                <a:latin typeface="Arial" panose="020B0604020202020204" pitchFamily="34" charset="0"/>
-                <a:ea typeface="+mn-ea"/>
-                <a:cs typeface="Arial" panose="020B0604020202020204" pitchFamily="34" charset="0"/>
-              </a:defRPr>
-            </a:lvl3pPr>
-            <a:lvl4pPr marL="534988" indent="-133350" algn="l" defTabSz="914400" rtl="0" eaLnBrk="1" latinLnBrk="0" hangingPunct="1">
-              <a:lnSpc>
-                <a:spcPct val="100000"/>
-              </a:lnSpc>
-              <a:spcBef>
-                <a:spcPts val="0"/>
-              </a:spcBef>
-              <a:spcAft>
-                <a:spcPts val="200"/>
-              </a:spcAft>
-              <a:buClr>
-                <a:schemeClr val="tx2"/>
-              </a:buClr>
-              <a:buSzPct val="100000"/>
-              <a:buFont typeface="Wingdings" pitchFamily="2" charset="2"/>
-              <a:buChar char="§"/>
-              <a:tabLst/>
-              <a:defRPr sz="1200" kern="1200">
-                <a:solidFill>
-                  <a:schemeClr val="tx1"/>
-                </a:solidFill>
-                <a:latin typeface="Arial" panose="020B0604020202020204" pitchFamily="34" charset="0"/>
-                <a:ea typeface="+mn-ea"/>
-                <a:cs typeface="Arial" panose="020B0604020202020204" pitchFamily="34" charset="0"/>
-              </a:defRPr>
-            </a:lvl4pPr>
-            <a:lvl5pPr marL="668338" indent="-133350" algn="l" defTabSz="914400" rtl="0" eaLnBrk="1" latinLnBrk="0" hangingPunct="1">
-              <a:lnSpc>
-                <a:spcPct val="100000"/>
-              </a:lnSpc>
-              <a:spcBef>
-                <a:spcPts val="0"/>
-              </a:spcBef>
-              <a:spcAft>
-                <a:spcPts val="200"/>
-              </a:spcAft>
-              <a:buClr>
-                <a:schemeClr val="tx2"/>
-              </a:buClr>
-              <a:buSzPct val="100000"/>
-              <a:buFont typeface="System Font Regular"/>
-              <a:buChar char="▫"/>
-              <a:tabLst/>
-              <a:defRPr sz="1200" kern="1200">
-                <a:solidFill>
-                  <a:schemeClr val="tx1"/>
-                </a:solidFill>
-                <a:latin typeface="Arial" panose="020B0604020202020204" pitchFamily="34" charset="0"/>
-                <a:ea typeface="+mn-ea"/>
-                <a:cs typeface="Arial" panose="020B0604020202020204" pitchFamily="34" charset="0"/>
-              </a:defRPr>
-            </a:lvl5pPr>
-            <a:lvl6pPr marL="2514600" indent="-228600" algn="l" defTabSz="914400" rtl="0" eaLnBrk="1" latinLnBrk="0" hangingPunct="1">
-              <a:lnSpc>
-                <a:spcPct val="90000"/>
-              </a:lnSpc>
-              <a:spcBef>
-                <a:spcPts val="500"/>
-              </a:spcBef>
-              <a:buFont typeface="Arial" panose="020B0604020202020204" pitchFamily="34" charset="0"/>
-              <a:buChar char="•"/>
-              <a:defRPr sz="1800" kern="1200">
-                <a:solidFill>
-                  <a:schemeClr val="tx1"/>
-                </a:solidFill>
-                <a:latin typeface="+mn-lt"/>
-                <a:ea typeface="+mn-ea"/>
-                <a:cs typeface="+mn-cs"/>
-              </a:defRPr>
-            </a:lvl6pPr>
-            <a:lvl7pPr marL="2971800" indent="-228600" algn="l" defTabSz="914400" rtl="0" eaLnBrk="1" latinLnBrk="0" hangingPunct="1">
-              <a:lnSpc>
-                <a:spcPct val="90000"/>
-              </a:lnSpc>
-              <a:spcBef>
-                <a:spcPts val="500"/>
-              </a:spcBef>
-              <a:buFont typeface="Arial" panose="020B0604020202020204" pitchFamily="34" charset="0"/>
-              <a:buChar char="•"/>
-              <a:defRPr sz="1800" kern="1200">
-                <a:solidFill>
-                  <a:schemeClr val="tx1"/>
-                </a:solidFill>
-                <a:latin typeface="+mn-lt"/>
-                <a:ea typeface="+mn-ea"/>
-                <a:cs typeface="+mn-cs"/>
-              </a:defRPr>
-            </a:lvl7pPr>
-            <a:lvl8pPr marL="3429000" indent="-228600" algn="l" defTabSz="914400" rtl="0" eaLnBrk="1" latinLnBrk="0" hangingPunct="1">
-              <a:lnSpc>
-                <a:spcPct val="90000"/>
-              </a:lnSpc>
-              <a:spcBef>
-                <a:spcPts val="500"/>
-              </a:spcBef>
-              <a:buFont typeface="Arial" panose="020B0604020202020204" pitchFamily="34" charset="0"/>
-              <a:buChar char="•"/>
-              <a:defRPr sz="1800" kern="1200">
-                <a:solidFill>
-                  <a:schemeClr val="tx1"/>
-                </a:solidFill>
-                <a:latin typeface="+mn-lt"/>
-                <a:ea typeface="+mn-ea"/>
-                <a:cs typeface="+mn-cs"/>
-              </a:defRPr>
-            </a:lvl8pPr>
-            <a:lvl9pPr marL="3886200" indent="-228600" algn="l" defTabSz="914400" rtl="0" eaLnBrk="1" latinLnBrk="0" hangingPunct="1">
-              <a:lnSpc>
-                <a:spcPct val="90000"/>
-              </a:lnSpc>
-              <a:spcBef>
-                <a:spcPts val="500"/>
-              </a:spcBef>
-              <a:buFont typeface="Arial" panose="020B0604020202020204" pitchFamily="34" charset="0"/>
-              <a:buChar char="•"/>
-              <a:defRPr sz="1800" kern="1200">
-                <a:solidFill>
-                  <a:schemeClr val="tx1"/>
-                </a:solidFill>
-                <a:latin typeface="+mn-lt"/>
-                <a:ea typeface="+mn-ea"/>
-                <a:cs typeface="+mn-cs"/>
-              </a:defRPr>
-            </a:lvl9pPr>
-          </a:lstStyle>
-          <a:p>
             <a:r>
               <a:rPr lang="fr-FR" dirty="0"/>
               <a:t>Comment</a:t>
@@ -25864,7 +25624,7 @@
       </p:sp>
       <p:sp>
         <p:nvSpPr>
-          <p:cNvPr id="13" name="Espace réservé du contenu 5">
+          <p:cNvPr id="13" name="slot.chart-title">
             <a:extLst>
               <a:ext uri="{FF2B5EF4-FFF2-40B4-BE49-F238E27FC236}">
                 <a16:creationId xmlns:a16="http://schemas.microsoft.com/office/drawing/2014/main" id="{33F8A7A2-5825-1682-27AF-955BF8FEC5B1}"/>

</xml_diff>

<commit_message>
fix: remediate dual-review findings #13–#15 — logic + slot contract (Phase 3.6)
Enforce D21 schema soundness (XOR dataset source, no charts in generic
content slots, line/bubble validation splits, stacked-column rename),
harden conjunctive slot matching and per-shape chart validation, correct
two-columns/subtitle-right slot names in spec+master, and add drift,
replay, and parameterized fixture coverage for all 26 layouts.

Co-authored-by: Cursor <cursoragent@cursor.com>
</commit_message>
<xml_diff>
--- a/templates/report.master.pptx
+++ b/templates/report.master.pptx
@@ -7772,7 +7772,7 @@
       </p:sp>
       <p:sp>
         <p:nvSpPr>
-          <p:cNvPr id="5" name="slot.subtitle-left">
+          <p:cNvPr id="5" name="slot.subtitle-right">
             <a:extLst>
               <a:ext uri="{FF2B5EF4-FFF2-40B4-BE49-F238E27FC236}">
                 <a16:creationId xmlns:a16="http://schemas.microsoft.com/office/drawing/2014/main" id="{2D35804D-7044-B129-7E2C-ED3868BD4F80}"/>
@@ -8670,7 +8670,7 @@
       </p:sp>
       <p:sp>
         <p:nvSpPr>
-          <p:cNvPr id="5" name="slot.subtitle-left">
+          <p:cNvPr id="5" name="slot.subtitle-right">
             <a:extLst>
               <a:ext uri="{FF2B5EF4-FFF2-40B4-BE49-F238E27FC236}">
                 <a16:creationId xmlns:a16="http://schemas.microsoft.com/office/drawing/2014/main" id="{2D35804D-7044-B129-7E2C-ED3868BD4F80}"/>
@@ -11270,7 +11270,7 @@
       </p:sp>
       <p:sp>
         <p:nvSpPr>
-          <p:cNvPr id="5" name="slot.subtitle-left">
+          <p:cNvPr id="5" name="slot.subtitle-right">
             <a:extLst>
               <a:ext uri="{FF2B5EF4-FFF2-40B4-BE49-F238E27FC236}">
                 <a16:creationId xmlns:a16="http://schemas.microsoft.com/office/drawing/2014/main" id="{2D35804D-7044-B129-7E2C-ED3868BD4F80}"/>
@@ -12244,7 +12244,7 @@
       </p:sp>
       <p:sp>
         <p:nvSpPr>
-          <p:cNvPr id="5" name="slot.subtitle-left">
+          <p:cNvPr id="5" name="slot.subtitle-right">
             <a:extLst>
               <a:ext uri="{FF2B5EF4-FFF2-40B4-BE49-F238E27FC236}">
                 <a16:creationId xmlns:a16="http://schemas.microsoft.com/office/drawing/2014/main" id="{2D35804D-7044-B129-7E2C-ED3868BD4F80}"/>
@@ -15831,7 +15831,7 @@
       </p:sp>
       <p:sp>
         <p:nvSpPr>
-          <p:cNvPr id="4" name="slot.body-left">
+          <p:cNvPr id="4" name="slot.body-right">
             <a:extLst>
               <a:ext uri="{FF2B5EF4-FFF2-40B4-BE49-F238E27FC236}">
                 <a16:creationId xmlns:a16="http://schemas.microsoft.com/office/drawing/2014/main" id="{8EB565A4-3D20-0C08-E4EA-AB81725F7D5D}"/>
@@ -16012,7 +16012,7 @@
       </p:sp>
       <p:sp>
         <p:nvSpPr>
-          <p:cNvPr id="18" name="slot.body-left">
+          <p:cNvPr id="18" name="slot.source">
             <a:extLst>
               <a:ext uri="{FF2B5EF4-FFF2-40B4-BE49-F238E27FC236}">
                 <a16:creationId xmlns:a16="http://schemas.microsoft.com/office/drawing/2014/main" id="{134DD0FE-B05A-6304-7865-C88149104BD6}"/>
@@ -16490,7 +16490,7 @@
       </p:sp>
       <p:sp>
         <p:nvSpPr>
-          <p:cNvPr id="5" name="slot.subtitle-left">
+          <p:cNvPr id="5" name="slot.subtitle-right">
             <a:extLst>
               <a:ext uri="{FF2B5EF4-FFF2-40B4-BE49-F238E27FC236}">
                 <a16:creationId xmlns:a16="http://schemas.microsoft.com/office/drawing/2014/main" id="{2D35804D-7044-B129-7E2C-ED3868BD4F80}"/>
@@ -17227,7 +17227,7 @@
       </p:sp>
       <p:sp>
         <p:nvSpPr>
-          <p:cNvPr id="5" name="slot.subtitle-left">
+          <p:cNvPr id="5" name="slot.subtitle-right">
             <a:extLst>
               <a:ext uri="{FF2B5EF4-FFF2-40B4-BE49-F238E27FC236}">
                 <a16:creationId xmlns:a16="http://schemas.microsoft.com/office/drawing/2014/main" id="{2D35804D-7044-B129-7E2C-ED3868BD4F80}"/>
@@ -17368,7 +17368,7 @@
       </p:sp>
       <p:sp>
         <p:nvSpPr>
-          <p:cNvPr id="7" name="slot.subtitle-left">
+          <p:cNvPr id="7" name="slot.subtitle-middle">
             <a:extLst>
               <a:ext uri="{FF2B5EF4-FFF2-40B4-BE49-F238E27FC236}">
                 <a16:creationId xmlns:a16="http://schemas.microsoft.com/office/drawing/2014/main" id="{5E8252F0-DE57-E2EB-BE2E-BAD06505AF77}"/>
@@ -17446,7 +17446,7 @@
       </p:sp>
       <p:sp>
         <p:nvSpPr>
-          <p:cNvPr id="11" name="slot.body-left">
+          <p:cNvPr id="11" name="slot.body-center">
             <a:extLst>
               <a:ext uri="{FF2B5EF4-FFF2-40B4-BE49-F238E27FC236}">
                 <a16:creationId xmlns:a16="http://schemas.microsoft.com/office/drawing/2014/main" id="{AF4E5750-BDEC-4328-0B8F-9525E2496CFD}"/>
@@ -20725,7 +20725,7 @@
       </p:sp>
       <p:sp>
         <p:nvSpPr>
-          <p:cNvPr id="8" name="slot.body-left">
+          <p:cNvPr id="8" name="slot.body-right">
             <a:extLst>
               <a:ext uri="{FF2B5EF4-FFF2-40B4-BE49-F238E27FC236}">
                 <a16:creationId xmlns:a16="http://schemas.microsoft.com/office/drawing/2014/main" id="{37886110-4BF1-3B19-47FC-1B3A623E68F4}"/>
@@ -21118,7 +21118,7 @@
       </p:sp>
       <p:sp>
         <p:nvSpPr>
-          <p:cNvPr id="5" name="slot.subtitle-center">
+          <p:cNvPr id="5" name="slot.subtitle-right">
             <a:extLst>
               <a:ext uri="{FF2B5EF4-FFF2-40B4-BE49-F238E27FC236}">
                 <a16:creationId xmlns:a16="http://schemas.microsoft.com/office/drawing/2014/main" id="{899EBAB0-D7CA-FCF6-5AE7-F3182BDD73D7}"/>
@@ -21880,7 +21880,7 @@
       </p:sp>
       <p:sp>
         <p:nvSpPr>
-          <p:cNvPr id="5" name="slot.subtitle-center">
+          <p:cNvPr id="5" name="slot.subtitle-right">
             <a:extLst>
               <a:ext uri="{FF2B5EF4-FFF2-40B4-BE49-F238E27FC236}">
                 <a16:creationId xmlns:a16="http://schemas.microsoft.com/office/drawing/2014/main" id="{3F8F4092-5C55-47A8-80BF-15DB6F705E87}"/>
@@ -22966,7 +22966,7 @@
       </p:sp>
       <p:sp>
         <p:nvSpPr>
-          <p:cNvPr id="5" name="slot.subtitle-center">
+          <p:cNvPr id="5" name="slot.subtitle-right">
             <a:extLst>
               <a:ext uri="{FF2B5EF4-FFF2-40B4-BE49-F238E27FC236}">
                 <a16:creationId xmlns:a16="http://schemas.microsoft.com/office/drawing/2014/main" id="{A6481CB5-EAF6-34D0-38D2-004DF250D138}"/>

</xml_diff>